<commit_message>
Perspective shadows and shadows of turned shapes
outerShdw sx, sy, kx and ky skew, then scale the shape about the alignment point
before the offset and the blur; rotWithShape 0 keeps a shadow's direction and
transform on the slide (about the box around the turned shape).

Co-Authored-By: Claude Opus 5.5 <noreply@anthropic.com>
</commit_message>
<xml_diff>
--- a/tests/corpus/pptx/generated/effects.pptx
+++ b/tests/corpus/pptx/generated/effects.pptx
@@ -7,6 +7,8 @@
   <p:sldIdLst>
     <p:sldId id="256" r:id="rId2"/>
     <p:sldId id="257" r:id="rId3"/>
+    <p:sldId id="258" r:id="rId4"/>
+    <p:sldId id="259" r:id="rId5"/>
   </p:sldIdLst>
   <p:sldSz cx="12192000" cy="6858000"/>
   <p:notesSz cx="6858000" cy="9144000"/>
@@ -130,7 +132,7 @@
           <p:cNvPr id="2" name="Titel 1">
             <a:extLst>
               <a:ext uri="{FF2B5EF4-FFF2-40B4-BE49-F238E27FC236}">
-                <a16:creationId xmlns:a16="http://schemas.microsoft.com/office/drawing/2014/main" id="{CE080CB4-AAD6-0317-86F7-46FBADB73F14}"/>
+                <a16:creationId xmlns:a16="http://schemas.microsoft.com/office/drawing/2014/main" id="{0A7199FF-1A45-EB29-A0BC-0EA369265080}"/>
               </a:ext>
             </a:extLst>
           </p:cNvPr>
@@ -167,7 +169,7 @@
           <p:cNvPr id="3" name="Untertitel 2">
             <a:extLst>
               <a:ext uri="{FF2B5EF4-FFF2-40B4-BE49-F238E27FC236}">
-                <a16:creationId xmlns:a16="http://schemas.microsoft.com/office/drawing/2014/main" id="{C7443D61-3317-D154-E090-C3464FF5FC3D}"/>
+                <a16:creationId xmlns:a16="http://schemas.microsoft.com/office/drawing/2014/main" id="{635552F4-D857-C88F-B9B6-839C18DAECCC}"/>
               </a:ext>
             </a:extLst>
           </p:cNvPr>
@@ -237,7 +239,7 @@
           <p:cNvPr id="4" name="Datumsplatzhalter 3">
             <a:extLst>
               <a:ext uri="{FF2B5EF4-FFF2-40B4-BE49-F238E27FC236}">
-                <a16:creationId xmlns:a16="http://schemas.microsoft.com/office/drawing/2014/main" id="{A9649D8F-401E-2638-7340-A4DDF1F0DE3F}"/>
+                <a16:creationId xmlns:a16="http://schemas.microsoft.com/office/drawing/2014/main" id="{95999C38-F840-427D-78D0-4D9FA453A46E}"/>
               </a:ext>
             </a:extLst>
           </p:cNvPr>
@@ -253,7 +255,7 @@
           <a:bodyPr/>
           <a:lstStyle/>
           <a:p>
-            <a:fld id="{6D4811C1-AEF3-4DDB-8A6F-AFFB6AB542CA}" type="datetimeFigureOut">
+            <a:fld id="{5A1AF197-8666-45A1-A9DD-65DA68AEA0EB}" type="datetimeFigureOut">
               <a:rPr lang="de-DE" smtClean="0"/>
               <a:t>08.10.2026</a:t>
             </a:fld>
@@ -266,7 +268,7 @@
           <p:cNvPr id="5" name="Fußzeilenplatzhalter 4">
             <a:extLst>
               <a:ext uri="{FF2B5EF4-FFF2-40B4-BE49-F238E27FC236}">
-                <a16:creationId xmlns:a16="http://schemas.microsoft.com/office/drawing/2014/main" id="{296DCE64-2846-0D08-052C-5B90A4751DA5}"/>
+                <a16:creationId xmlns:a16="http://schemas.microsoft.com/office/drawing/2014/main" id="{09DA14AC-79FD-C1B9-6E65-4EF3646A7740}"/>
               </a:ext>
             </a:extLst>
           </p:cNvPr>
@@ -291,7 +293,7 @@
           <p:cNvPr id="6" name="Foliennummernplatzhalter 5">
             <a:extLst>
               <a:ext uri="{FF2B5EF4-FFF2-40B4-BE49-F238E27FC236}">
-                <a16:creationId xmlns:a16="http://schemas.microsoft.com/office/drawing/2014/main" id="{13F64646-27F7-2B86-1524-B75CCAC88092}"/>
+                <a16:creationId xmlns:a16="http://schemas.microsoft.com/office/drawing/2014/main" id="{4D73CA68-EBAD-AC26-0814-CC06634918CC}"/>
               </a:ext>
             </a:extLst>
           </p:cNvPr>
@@ -307,7 +309,7 @@
           <a:bodyPr/>
           <a:lstStyle/>
           <a:p>
-            <a:fld id="{F45884CD-9BF8-425B-9EAD-9E0FE3DAEAB7}" type="slidenum">
+            <a:fld id="{FD7A2B11-542E-4CA3-8CAD-ADBF93301D0C}" type="slidenum">
               <a:rPr lang="de-DE" smtClean="0"/>
               <a:t>‹Nr.›</a:t>
             </a:fld>
@@ -318,7 +320,7 @@
     </p:spTree>
     <p:extLst>
       <p:ext uri="{BB962C8B-B14F-4D97-AF65-F5344CB8AC3E}">
-        <p14:creationId xmlns:p14="http://schemas.microsoft.com/office/powerpoint/2010/main" val="2645735984"/>
+        <p14:creationId xmlns:p14="http://schemas.microsoft.com/office/powerpoint/2010/main" val="1518090723"/>
       </p:ext>
     </p:extLst>
   </p:cSld>
@@ -350,7 +352,7 @@
           <p:cNvPr id="2" name="Titel 1">
             <a:extLst>
               <a:ext uri="{FF2B5EF4-FFF2-40B4-BE49-F238E27FC236}">
-                <a16:creationId xmlns:a16="http://schemas.microsoft.com/office/drawing/2014/main" id="{E76D8CF9-A832-9D05-0C70-AB7099DE483A}"/>
+                <a16:creationId xmlns:a16="http://schemas.microsoft.com/office/drawing/2014/main" id="{C2D471B9-DACF-73F3-4910-A236AC245575}"/>
               </a:ext>
             </a:extLst>
           </p:cNvPr>
@@ -378,7 +380,7 @@
           <p:cNvPr id="3" name="Vertikaler Textplatzhalter 2">
             <a:extLst>
               <a:ext uri="{FF2B5EF4-FFF2-40B4-BE49-F238E27FC236}">
-                <a16:creationId xmlns:a16="http://schemas.microsoft.com/office/drawing/2014/main" id="{D07B7777-8947-2054-698D-5A1BECF45261}"/>
+                <a16:creationId xmlns:a16="http://schemas.microsoft.com/office/drawing/2014/main" id="{951D566B-99B9-9C48-292E-2E1A7FD6694F}"/>
               </a:ext>
             </a:extLst>
           </p:cNvPr>
@@ -435,7 +437,7 @@
           <p:cNvPr id="4" name="Datumsplatzhalter 3">
             <a:extLst>
               <a:ext uri="{FF2B5EF4-FFF2-40B4-BE49-F238E27FC236}">
-                <a16:creationId xmlns:a16="http://schemas.microsoft.com/office/drawing/2014/main" id="{B7A7123E-0C86-AEC4-F7D5-856B028C1C9B}"/>
+                <a16:creationId xmlns:a16="http://schemas.microsoft.com/office/drawing/2014/main" id="{5E2A96C1-E8E7-57C9-9F4B-7B979C3FFDD4}"/>
               </a:ext>
             </a:extLst>
           </p:cNvPr>
@@ -451,7 +453,7 @@
           <a:bodyPr/>
           <a:lstStyle/>
           <a:p>
-            <a:fld id="{6D4811C1-AEF3-4DDB-8A6F-AFFB6AB542CA}" type="datetimeFigureOut">
+            <a:fld id="{5A1AF197-8666-45A1-A9DD-65DA68AEA0EB}" type="datetimeFigureOut">
               <a:rPr lang="de-DE" smtClean="0"/>
               <a:t>08.10.2026</a:t>
             </a:fld>
@@ -464,7 +466,7 @@
           <p:cNvPr id="5" name="Fußzeilenplatzhalter 4">
             <a:extLst>
               <a:ext uri="{FF2B5EF4-FFF2-40B4-BE49-F238E27FC236}">
-                <a16:creationId xmlns:a16="http://schemas.microsoft.com/office/drawing/2014/main" id="{8E81005A-F2D4-7DAE-F799-9FBE8E983760}"/>
+                <a16:creationId xmlns:a16="http://schemas.microsoft.com/office/drawing/2014/main" id="{26E1B800-A5C4-1EF5-CF70-A1C1DF6ADAFD}"/>
               </a:ext>
             </a:extLst>
           </p:cNvPr>
@@ -489,7 +491,7 @@
           <p:cNvPr id="6" name="Foliennummernplatzhalter 5">
             <a:extLst>
               <a:ext uri="{FF2B5EF4-FFF2-40B4-BE49-F238E27FC236}">
-                <a16:creationId xmlns:a16="http://schemas.microsoft.com/office/drawing/2014/main" id="{34F1124B-C9E9-AFA3-1BC0-351E5E576600}"/>
+                <a16:creationId xmlns:a16="http://schemas.microsoft.com/office/drawing/2014/main" id="{4C33FB90-B6C9-FCFE-BB89-6D2C34CCCC09}"/>
               </a:ext>
             </a:extLst>
           </p:cNvPr>
@@ -505,7 +507,7 @@
           <a:bodyPr/>
           <a:lstStyle/>
           <a:p>
-            <a:fld id="{F45884CD-9BF8-425B-9EAD-9E0FE3DAEAB7}" type="slidenum">
+            <a:fld id="{FD7A2B11-542E-4CA3-8CAD-ADBF93301D0C}" type="slidenum">
               <a:rPr lang="de-DE" smtClean="0"/>
               <a:t>‹Nr.›</a:t>
             </a:fld>
@@ -516,7 +518,7 @@
     </p:spTree>
     <p:extLst>
       <p:ext uri="{BB962C8B-B14F-4D97-AF65-F5344CB8AC3E}">
-        <p14:creationId xmlns:p14="http://schemas.microsoft.com/office/powerpoint/2010/main" val="381265737"/>
+        <p14:creationId xmlns:p14="http://schemas.microsoft.com/office/powerpoint/2010/main" val="3911492640"/>
       </p:ext>
     </p:extLst>
   </p:cSld>
@@ -548,7 +550,7 @@
           <p:cNvPr id="2" name="Vertikaler Titel 1">
             <a:extLst>
               <a:ext uri="{FF2B5EF4-FFF2-40B4-BE49-F238E27FC236}">
-                <a16:creationId xmlns:a16="http://schemas.microsoft.com/office/drawing/2014/main" id="{3277CA28-5B36-8E9F-7607-0DFC92BECF6F}"/>
+                <a16:creationId xmlns:a16="http://schemas.microsoft.com/office/drawing/2014/main" id="{FA0F1A3C-1479-6884-1416-B0A0961B3680}"/>
               </a:ext>
             </a:extLst>
           </p:cNvPr>
@@ -581,7 +583,7 @@
           <p:cNvPr id="3" name="Vertikaler Textplatzhalter 2">
             <a:extLst>
               <a:ext uri="{FF2B5EF4-FFF2-40B4-BE49-F238E27FC236}">
-                <a16:creationId xmlns:a16="http://schemas.microsoft.com/office/drawing/2014/main" id="{A1717527-E1F9-BF8D-98F6-5D9B5CE463C9}"/>
+                <a16:creationId xmlns:a16="http://schemas.microsoft.com/office/drawing/2014/main" id="{B77E2EDB-B08E-4A97-ABCA-81778AB8F83B}"/>
               </a:ext>
             </a:extLst>
           </p:cNvPr>
@@ -643,7 +645,7 @@
           <p:cNvPr id="4" name="Datumsplatzhalter 3">
             <a:extLst>
               <a:ext uri="{FF2B5EF4-FFF2-40B4-BE49-F238E27FC236}">
-                <a16:creationId xmlns:a16="http://schemas.microsoft.com/office/drawing/2014/main" id="{27A82997-3840-FBD2-3D67-B8834CEBEA52}"/>
+                <a16:creationId xmlns:a16="http://schemas.microsoft.com/office/drawing/2014/main" id="{F7278748-A8E4-B974-554A-4B8390B89CD0}"/>
               </a:ext>
             </a:extLst>
           </p:cNvPr>
@@ -659,7 +661,7 @@
           <a:bodyPr/>
           <a:lstStyle/>
           <a:p>
-            <a:fld id="{6D4811C1-AEF3-4DDB-8A6F-AFFB6AB542CA}" type="datetimeFigureOut">
+            <a:fld id="{5A1AF197-8666-45A1-A9DD-65DA68AEA0EB}" type="datetimeFigureOut">
               <a:rPr lang="de-DE" smtClean="0"/>
               <a:t>08.10.2026</a:t>
             </a:fld>
@@ -672,7 +674,7 @@
           <p:cNvPr id="5" name="Fußzeilenplatzhalter 4">
             <a:extLst>
               <a:ext uri="{FF2B5EF4-FFF2-40B4-BE49-F238E27FC236}">
-                <a16:creationId xmlns:a16="http://schemas.microsoft.com/office/drawing/2014/main" id="{08D55F48-3EB1-2CC0-0A4C-0B19079BC3C9}"/>
+                <a16:creationId xmlns:a16="http://schemas.microsoft.com/office/drawing/2014/main" id="{C496F664-2D0B-E9FF-0148-7EB4FFCD3E23}"/>
               </a:ext>
             </a:extLst>
           </p:cNvPr>
@@ -697,7 +699,7 @@
           <p:cNvPr id="6" name="Foliennummernplatzhalter 5">
             <a:extLst>
               <a:ext uri="{FF2B5EF4-FFF2-40B4-BE49-F238E27FC236}">
-                <a16:creationId xmlns:a16="http://schemas.microsoft.com/office/drawing/2014/main" id="{7121ADDB-1201-9708-CCF3-3F288CA05C2E}"/>
+                <a16:creationId xmlns:a16="http://schemas.microsoft.com/office/drawing/2014/main" id="{7B71E32C-4056-C975-9368-BD507506F8B9}"/>
               </a:ext>
             </a:extLst>
           </p:cNvPr>
@@ -713,7 +715,7 @@
           <a:bodyPr/>
           <a:lstStyle/>
           <a:p>
-            <a:fld id="{F45884CD-9BF8-425B-9EAD-9E0FE3DAEAB7}" type="slidenum">
+            <a:fld id="{FD7A2B11-542E-4CA3-8CAD-ADBF93301D0C}" type="slidenum">
               <a:rPr lang="de-DE" smtClean="0"/>
               <a:t>‹Nr.›</a:t>
             </a:fld>
@@ -724,7 +726,7 @@
     </p:spTree>
     <p:extLst>
       <p:ext uri="{BB962C8B-B14F-4D97-AF65-F5344CB8AC3E}">
-        <p14:creationId xmlns:p14="http://schemas.microsoft.com/office/powerpoint/2010/main" val="2576090773"/>
+        <p14:creationId xmlns:p14="http://schemas.microsoft.com/office/powerpoint/2010/main" val="1763581593"/>
       </p:ext>
     </p:extLst>
   </p:cSld>
@@ -756,7 +758,7 @@
           <p:cNvPr id="2" name="Titel 1">
             <a:extLst>
               <a:ext uri="{FF2B5EF4-FFF2-40B4-BE49-F238E27FC236}">
-                <a16:creationId xmlns:a16="http://schemas.microsoft.com/office/drawing/2014/main" id="{DBBC8467-CA26-9EFC-0E24-C05C456665D9}"/>
+                <a16:creationId xmlns:a16="http://schemas.microsoft.com/office/drawing/2014/main" id="{06755BAF-71E2-3262-D3F5-0467D0BE2F7A}"/>
               </a:ext>
             </a:extLst>
           </p:cNvPr>
@@ -784,7 +786,7 @@
           <p:cNvPr id="3" name="Inhaltsplatzhalter 2">
             <a:extLst>
               <a:ext uri="{FF2B5EF4-FFF2-40B4-BE49-F238E27FC236}">
-                <a16:creationId xmlns:a16="http://schemas.microsoft.com/office/drawing/2014/main" id="{76F11E0E-F658-2E5B-A8D6-6CA9DF3C6234}"/>
+                <a16:creationId xmlns:a16="http://schemas.microsoft.com/office/drawing/2014/main" id="{81E498FD-4E31-362D-976A-A05120E89C00}"/>
               </a:ext>
             </a:extLst>
           </p:cNvPr>
@@ -841,7 +843,7 @@
           <p:cNvPr id="4" name="Datumsplatzhalter 3">
             <a:extLst>
               <a:ext uri="{FF2B5EF4-FFF2-40B4-BE49-F238E27FC236}">
-                <a16:creationId xmlns:a16="http://schemas.microsoft.com/office/drawing/2014/main" id="{332E4051-45DD-5916-F9A0-32084320E887}"/>
+                <a16:creationId xmlns:a16="http://schemas.microsoft.com/office/drawing/2014/main" id="{540030CB-C414-0BE1-AB5E-6CD1644FB07C}"/>
               </a:ext>
             </a:extLst>
           </p:cNvPr>
@@ -857,7 +859,7 @@
           <a:bodyPr/>
           <a:lstStyle/>
           <a:p>
-            <a:fld id="{6D4811C1-AEF3-4DDB-8A6F-AFFB6AB542CA}" type="datetimeFigureOut">
+            <a:fld id="{5A1AF197-8666-45A1-A9DD-65DA68AEA0EB}" type="datetimeFigureOut">
               <a:rPr lang="de-DE" smtClean="0"/>
               <a:t>08.10.2026</a:t>
             </a:fld>
@@ -870,7 +872,7 @@
           <p:cNvPr id="5" name="Fußzeilenplatzhalter 4">
             <a:extLst>
               <a:ext uri="{FF2B5EF4-FFF2-40B4-BE49-F238E27FC236}">
-                <a16:creationId xmlns:a16="http://schemas.microsoft.com/office/drawing/2014/main" id="{F3A5EF10-D490-ADBF-9FCE-2857CE784208}"/>
+                <a16:creationId xmlns:a16="http://schemas.microsoft.com/office/drawing/2014/main" id="{87ECD622-2577-1E52-E593-5B841F6738BA}"/>
               </a:ext>
             </a:extLst>
           </p:cNvPr>
@@ -895,7 +897,7 @@
           <p:cNvPr id="6" name="Foliennummernplatzhalter 5">
             <a:extLst>
               <a:ext uri="{FF2B5EF4-FFF2-40B4-BE49-F238E27FC236}">
-                <a16:creationId xmlns:a16="http://schemas.microsoft.com/office/drawing/2014/main" id="{147EABEB-0B5E-9B97-988B-3BFCCEF730AE}"/>
+                <a16:creationId xmlns:a16="http://schemas.microsoft.com/office/drawing/2014/main" id="{C1359DD1-8217-6340-BF8E-233DA944D135}"/>
               </a:ext>
             </a:extLst>
           </p:cNvPr>
@@ -911,7 +913,7 @@
           <a:bodyPr/>
           <a:lstStyle/>
           <a:p>
-            <a:fld id="{F45884CD-9BF8-425B-9EAD-9E0FE3DAEAB7}" type="slidenum">
+            <a:fld id="{FD7A2B11-542E-4CA3-8CAD-ADBF93301D0C}" type="slidenum">
               <a:rPr lang="de-DE" smtClean="0"/>
               <a:t>‹Nr.›</a:t>
             </a:fld>
@@ -922,7 +924,7 @@
     </p:spTree>
     <p:extLst>
       <p:ext uri="{BB962C8B-B14F-4D97-AF65-F5344CB8AC3E}">
-        <p14:creationId xmlns:p14="http://schemas.microsoft.com/office/powerpoint/2010/main" val="84058338"/>
+        <p14:creationId xmlns:p14="http://schemas.microsoft.com/office/powerpoint/2010/main" val="3394778371"/>
       </p:ext>
     </p:extLst>
   </p:cSld>
@@ -954,7 +956,7 @@
           <p:cNvPr id="2" name="Titel 1">
             <a:extLst>
               <a:ext uri="{FF2B5EF4-FFF2-40B4-BE49-F238E27FC236}">
-                <a16:creationId xmlns:a16="http://schemas.microsoft.com/office/drawing/2014/main" id="{BA383E75-CC60-9F3A-F909-C6D043311215}"/>
+                <a16:creationId xmlns:a16="http://schemas.microsoft.com/office/drawing/2014/main" id="{ABDA4AC9-E63C-56F2-D876-74DEBFE22E9D}"/>
               </a:ext>
             </a:extLst>
           </p:cNvPr>
@@ -991,7 +993,7 @@
           <p:cNvPr id="3" name="Textplatzhalter 2">
             <a:extLst>
               <a:ext uri="{FF2B5EF4-FFF2-40B4-BE49-F238E27FC236}">
-                <a16:creationId xmlns:a16="http://schemas.microsoft.com/office/drawing/2014/main" id="{00C38426-646F-CAA3-BDD3-598DD79CCAFC}"/>
+                <a16:creationId xmlns:a16="http://schemas.microsoft.com/office/drawing/2014/main" id="{858FDD71-7A18-4A08-BF66-A57A18828071}"/>
               </a:ext>
             </a:extLst>
           </p:cNvPr>
@@ -1116,7 +1118,7 @@
           <p:cNvPr id="4" name="Datumsplatzhalter 3">
             <a:extLst>
               <a:ext uri="{FF2B5EF4-FFF2-40B4-BE49-F238E27FC236}">
-                <a16:creationId xmlns:a16="http://schemas.microsoft.com/office/drawing/2014/main" id="{388DA232-DAA1-2AB9-F228-8AB62FCA5CB1}"/>
+                <a16:creationId xmlns:a16="http://schemas.microsoft.com/office/drawing/2014/main" id="{F864D8D5-2F68-5533-6D66-95CF2353EF8B}"/>
               </a:ext>
             </a:extLst>
           </p:cNvPr>
@@ -1132,7 +1134,7 @@
           <a:bodyPr/>
           <a:lstStyle/>
           <a:p>
-            <a:fld id="{6D4811C1-AEF3-4DDB-8A6F-AFFB6AB542CA}" type="datetimeFigureOut">
+            <a:fld id="{5A1AF197-8666-45A1-A9DD-65DA68AEA0EB}" type="datetimeFigureOut">
               <a:rPr lang="de-DE" smtClean="0"/>
               <a:t>08.10.2026</a:t>
             </a:fld>
@@ -1145,7 +1147,7 @@
           <p:cNvPr id="5" name="Fußzeilenplatzhalter 4">
             <a:extLst>
               <a:ext uri="{FF2B5EF4-FFF2-40B4-BE49-F238E27FC236}">
-                <a16:creationId xmlns:a16="http://schemas.microsoft.com/office/drawing/2014/main" id="{FADB247F-3911-5463-F5C3-7D7407F183DD}"/>
+                <a16:creationId xmlns:a16="http://schemas.microsoft.com/office/drawing/2014/main" id="{B9B2F4A6-462A-1DB1-630E-1F29B9AA383F}"/>
               </a:ext>
             </a:extLst>
           </p:cNvPr>
@@ -1170,7 +1172,7 @@
           <p:cNvPr id="6" name="Foliennummernplatzhalter 5">
             <a:extLst>
               <a:ext uri="{FF2B5EF4-FFF2-40B4-BE49-F238E27FC236}">
-                <a16:creationId xmlns:a16="http://schemas.microsoft.com/office/drawing/2014/main" id="{FBA740AB-AF97-26E7-CB72-7875E01C0C41}"/>
+                <a16:creationId xmlns:a16="http://schemas.microsoft.com/office/drawing/2014/main" id="{A9A10DA5-F096-DD7C-25B9-177F49297628}"/>
               </a:ext>
             </a:extLst>
           </p:cNvPr>
@@ -1186,7 +1188,7 @@
           <a:bodyPr/>
           <a:lstStyle/>
           <a:p>
-            <a:fld id="{F45884CD-9BF8-425B-9EAD-9E0FE3DAEAB7}" type="slidenum">
+            <a:fld id="{FD7A2B11-542E-4CA3-8CAD-ADBF93301D0C}" type="slidenum">
               <a:rPr lang="de-DE" smtClean="0"/>
               <a:t>‹Nr.›</a:t>
             </a:fld>
@@ -1197,7 +1199,7 @@
     </p:spTree>
     <p:extLst>
       <p:ext uri="{BB962C8B-B14F-4D97-AF65-F5344CB8AC3E}">
-        <p14:creationId xmlns:p14="http://schemas.microsoft.com/office/powerpoint/2010/main" val="1377568954"/>
+        <p14:creationId xmlns:p14="http://schemas.microsoft.com/office/powerpoint/2010/main" val="3996943530"/>
       </p:ext>
     </p:extLst>
   </p:cSld>
@@ -1229,7 +1231,7 @@
           <p:cNvPr id="2" name="Titel 1">
             <a:extLst>
               <a:ext uri="{FF2B5EF4-FFF2-40B4-BE49-F238E27FC236}">
-                <a16:creationId xmlns:a16="http://schemas.microsoft.com/office/drawing/2014/main" id="{41C7CDD6-6F9A-DFC0-CE83-6BDBC9070898}"/>
+                <a16:creationId xmlns:a16="http://schemas.microsoft.com/office/drawing/2014/main" id="{4AF5849A-E7D1-25E1-B2DF-DACE3ECE6940}"/>
               </a:ext>
             </a:extLst>
           </p:cNvPr>
@@ -1257,7 +1259,7 @@
           <p:cNvPr id="3" name="Inhaltsplatzhalter 2">
             <a:extLst>
               <a:ext uri="{FF2B5EF4-FFF2-40B4-BE49-F238E27FC236}">
-                <a16:creationId xmlns:a16="http://schemas.microsoft.com/office/drawing/2014/main" id="{A02381AA-2085-1AF4-DD3F-9B41DFB92306}"/>
+                <a16:creationId xmlns:a16="http://schemas.microsoft.com/office/drawing/2014/main" id="{6DA4F8A0-5E08-1132-0557-604020CFC715}"/>
               </a:ext>
             </a:extLst>
           </p:cNvPr>
@@ -1319,7 +1321,7 @@
           <p:cNvPr id="4" name="Inhaltsplatzhalter 3">
             <a:extLst>
               <a:ext uri="{FF2B5EF4-FFF2-40B4-BE49-F238E27FC236}">
-                <a16:creationId xmlns:a16="http://schemas.microsoft.com/office/drawing/2014/main" id="{8FA06B8E-82D6-7088-4387-8C94E8622D86}"/>
+                <a16:creationId xmlns:a16="http://schemas.microsoft.com/office/drawing/2014/main" id="{6AE4F29D-760F-BC00-E5FC-FD7BB3B668FB}"/>
               </a:ext>
             </a:extLst>
           </p:cNvPr>
@@ -1381,7 +1383,7 @@
           <p:cNvPr id="5" name="Datumsplatzhalter 4">
             <a:extLst>
               <a:ext uri="{FF2B5EF4-FFF2-40B4-BE49-F238E27FC236}">
-                <a16:creationId xmlns:a16="http://schemas.microsoft.com/office/drawing/2014/main" id="{0710599E-A384-9DF6-A811-82914284C735}"/>
+                <a16:creationId xmlns:a16="http://schemas.microsoft.com/office/drawing/2014/main" id="{8F2264E7-C836-71A1-3851-92A6276F5B10}"/>
               </a:ext>
             </a:extLst>
           </p:cNvPr>
@@ -1397,7 +1399,7 @@
           <a:bodyPr/>
           <a:lstStyle/>
           <a:p>
-            <a:fld id="{6D4811C1-AEF3-4DDB-8A6F-AFFB6AB542CA}" type="datetimeFigureOut">
+            <a:fld id="{5A1AF197-8666-45A1-A9DD-65DA68AEA0EB}" type="datetimeFigureOut">
               <a:rPr lang="de-DE" smtClean="0"/>
               <a:t>08.10.2026</a:t>
             </a:fld>
@@ -1410,7 +1412,7 @@
           <p:cNvPr id="6" name="Fußzeilenplatzhalter 5">
             <a:extLst>
               <a:ext uri="{FF2B5EF4-FFF2-40B4-BE49-F238E27FC236}">
-                <a16:creationId xmlns:a16="http://schemas.microsoft.com/office/drawing/2014/main" id="{7624C93F-957A-E900-7604-37F449C7923B}"/>
+                <a16:creationId xmlns:a16="http://schemas.microsoft.com/office/drawing/2014/main" id="{1B9ABD61-A37B-69EA-4DD7-C1249CA31325}"/>
               </a:ext>
             </a:extLst>
           </p:cNvPr>
@@ -1435,7 +1437,7 @@
           <p:cNvPr id="7" name="Foliennummernplatzhalter 6">
             <a:extLst>
               <a:ext uri="{FF2B5EF4-FFF2-40B4-BE49-F238E27FC236}">
-                <a16:creationId xmlns:a16="http://schemas.microsoft.com/office/drawing/2014/main" id="{BDBDEF24-92EA-D1A6-E0FD-62DF3E9FAE1C}"/>
+                <a16:creationId xmlns:a16="http://schemas.microsoft.com/office/drawing/2014/main" id="{8AD97F0F-AFD6-0420-8A75-4EB3C475324E}"/>
               </a:ext>
             </a:extLst>
           </p:cNvPr>
@@ -1451,7 +1453,7 @@
           <a:bodyPr/>
           <a:lstStyle/>
           <a:p>
-            <a:fld id="{F45884CD-9BF8-425B-9EAD-9E0FE3DAEAB7}" type="slidenum">
+            <a:fld id="{FD7A2B11-542E-4CA3-8CAD-ADBF93301D0C}" type="slidenum">
               <a:rPr lang="de-DE" smtClean="0"/>
               <a:t>‹Nr.›</a:t>
             </a:fld>
@@ -1462,7 +1464,7 @@
     </p:spTree>
     <p:extLst>
       <p:ext uri="{BB962C8B-B14F-4D97-AF65-F5344CB8AC3E}">
-        <p14:creationId xmlns:p14="http://schemas.microsoft.com/office/powerpoint/2010/main" val="99208770"/>
+        <p14:creationId xmlns:p14="http://schemas.microsoft.com/office/powerpoint/2010/main" val="3733309982"/>
       </p:ext>
     </p:extLst>
   </p:cSld>
@@ -1494,7 +1496,7 @@
           <p:cNvPr id="2" name="Titel 1">
             <a:extLst>
               <a:ext uri="{FF2B5EF4-FFF2-40B4-BE49-F238E27FC236}">
-                <a16:creationId xmlns:a16="http://schemas.microsoft.com/office/drawing/2014/main" id="{9FA63F1D-1D73-AE31-EA14-A1FD4F779527}"/>
+                <a16:creationId xmlns:a16="http://schemas.microsoft.com/office/drawing/2014/main" id="{DF7FCAD1-A880-F6F0-6428-688651BBE5F3}"/>
               </a:ext>
             </a:extLst>
           </p:cNvPr>
@@ -1527,7 +1529,7 @@
           <p:cNvPr id="3" name="Textplatzhalter 2">
             <a:extLst>
               <a:ext uri="{FF2B5EF4-FFF2-40B4-BE49-F238E27FC236}">
-                <a16:creationId xmlns:a16="http://schemas.microsoft.com/office/drawing/2014/main" id="{5BD7591E-96BF-91DC-578C-1C9D5686E39C}"/>
+                <a16:creationId xmlns:a16="http://schemas.microsoft.com/office/drawing/2014/main" id="{81BF47F1-9E9E-3934-36D0-F2C83BBB1160}"/>
               </a:ext>
             </a:extLst>
           </p:cNvPr>
@@ -1598,7 +1600,7 @@
           <p:cNvPr id="4" name="Inhaltsplatzhalter 3">
             <a:extLst>
               <a:ext uri="{FF2B5EF4-FFF2-40B4-BE49-F238E27FC236}">
-                <a16:creationId xmlns:a16="http://schemas.microsoft.com/office/drawing/2014/main" id="{FAE74539-86FE-5A33-F76C-BDA90BAB16FF}"/>
+                <a16:creationId xmlns:a16="http://schemas.microsoft.com/office/drawing/2014/main" id="{36CDC8D7-BDC2-487D-7DA5-BE538BA407B5}"/>
               </a:ext>
             </a:extLst>
           </p:cNvPr>
@@ -1660,7 +1662,7 @@
           <p:cNvPr id="5" name="Textplatzhalter 4">
             <a:extLst>
               <a:ext uri="{FF2B5EF4-FFF2-40B4-BE49-F238E27FC236}">
-                <a16:creationId xmlns:a16="http://schemas.microsoft.com/office/drawing/2014/main" id="{8104B1F8-EBBB-AB1B-AA9A-59765A2C1650}"/>
+                <a16:creationId xmlns:a16="http://schemas.microsoft.com/office/drawing/2014/main" id="{3B1D7BB4-11CE-C01C-1F2F-6AE1C77698CC}"/>
               </a:ext>
             </a:extLst>
           </p:cNvPr>
@@ -1731,7 +1733,7 @@
           <p:cNvPr id="6" name="Inhaltsplatzhalter 5">
             <a:extLst>
               <a:ext uri="{FF2B5EF4-FFF2-40B4-BE49-F238E27FC236}">
-                <a16:creationId xmlns:a16="http://schemas.microsoft.com/office/drawing/2014/main" id="{28455FA2-FB4B-5504-8A92-CD429A326759}"/>
+                <a16:creationId xmlns:a16="http://schemas.microsoft.com/office/drawing/2014/main" id="{92FBE1FB-5DAF-62D7-FDAC-316D99A220BB}"/>
               </a:ext>
             </a:extLst>
           </p:cNvPr>
@@ -1793,7 +1795,7 @@
           <p:cNvPr id="7" name="Datumsplatzhalter 6">
             <a:extLst>
               <a:ext uri="{FF2B5EF4-FFF2-40B4-BE49-F238E27FC236}">
-                <a16:creationId xmlns:a16="http://schemas.microsoft.com/office/drawing/2014/main" id="{472E7301-7A62-A29A-7565-686160A92F8B}"/>
+                <a16:creationId xmlns:a16="http://schemas.microsoft.com/office/drawing/2014/main" id="{5288D339-5A3F-CC80-289C-9F23D109CB35}"/>
               </a:ext>
             </a:extLst>
           </p:cNvPr>
@@ -1809,7 +1811,7 @@
           <a:bodyPr/>
           <a:lstStyle/>
           <a:p>
-            <a:fld id="{6D4811C1-AEF3-4DDB-8A6F-AFFB6AB542CA}" type="datetimeFigureOut">
+            <a:fld id="{5A1AF197-8666-45A1-A9DD-65DA68AEA0EB}" type="datetimeFigureOut">
               <a:rPr lang="de-DE" smtClean="0"/>
               <a:t>08.10.2026</a:t>
             </a:fld>
@@ -1822,7 +1824,7 @@
           <p:cNvPr id="8" name="Fußzeilenplatzhalter 7">
             <a:extLst>
               <a:ext uri="{FF2B5EF4-FFF2-40B4-BE49-F238E27FC236}">
-                <a16:creationId xmlns:a16="http://schemas.microsoft.com/office/drawing/2014/main" id="{2E81D09C-C8C8-4FAA-459B-A3210CFA31F9}"/>
+                <a16:creationId xmlns:a16="http://schemas.microsoft.com/office/drawing/2014/main" id="{31E237DA-2745-EBCD-C3A2-861475A7D85D}"/>
               </a:ext>
             </a:extLst>
           </p:cNvPr>
@@ -1847,7 +1849,7 @@
           <p:cNvPr id="9" name="Foliennummernplatzhalter 8">
             <a:extLst>
               <a:ext uri="{FF2B5EF4-FFF2-40B4-BE49-F238E27FC236}">
-                <a16:creationId xmlns:a16="http://schemas.microsoft.com/office/drawing/2014/main" id="{48C0FFF8-6E0A-4434-E68D-4F6665D16D8C}"/>
+                <a16:creationId xmlns:a16="http://schemas.microsoft.com/office/drawing/2014/main" id="{7694FA05-D20A-7FB0-A4F2-6EF76ADFAAF1}"/>
               </a:ext>
             </a:extLst>
           </p:cNvPr>
@@ -1863,7 +1865,7 @@
           <a:bodyPr/>
           <a:lstStyle/>
           <a:p>
-            <a:fld id="{F45884CD-9BF8-425B-9EAD-9E0FE3DAEAB7}" type="slidenum">
+            <a:fld id="{FD7A2B11-542E-4CA3-8CAD-ADBF93301D0C}" type="slidenum">
               <a:rPr lang="de-DE" smtClean="0"/>
               <a:t>‹Nr.›</a:t>
             </a:fld>
@@ -1874,7 +1876,7 @@
     </p:spTree>
     <p:extLst>
       <p:ext uri="{BB962C8B-B14F-4D97-AF65-F5344CB8AC3E}">
-        <p14:creationId xmlns:p14="http://schemas.microsoft.com/office/powerpoint/2010/main" val="1521895317"/>
+        <p14:creationId xmlns:p14="http://schemas.microsoft.com/office/powerpoint/2010/main" val="3608037728"/>
       </p:ext>
     </p:extLst>
   </p:cSld>
@@ -1906,7 +1908,7 @@
           <p:cNvPr id="2" name="Titel 1">
             <a:extLst>
               <a:ext uri="{FF2B5EF4-FFF2-40B4-BE49-F238E27FC236}">
-                <a16:creationId xmlns:a16="http://schemas.microsoft.com/office/drawing/2014/main" id="{3936492F-43F3-1D3C-3F7F-444A48B98708}"/>
+                <a16:creationId xmlns:a16="http://schemas.microsoft.com/office/drawing/2014/main" id="{E45E1E03-7F49-7D4A-A8E8-FA673F3EEF06}"/>
               </a:ext>
             </a:extLst>
           </p:cNvPr>
@@ -1934,7 +1936,7 @@
           <p:cNvPr id="3" name="Datumsplatzhalter 2">
             <a:extLst>
               <a:ext uri="{FF2B5EF4-FFF2-40B4-BE49-F238E27FC236}">
-                <a16:creationId xmlns:a16="http://schemas.microsoft.com/office/drawing/2014/main" id="{9C39732E-C13E-00C9-3590-B0202018D434}"/>
+                <a16:creationId xmlns:a16="http://schemas.microsoft.com/office/drawing/2014/main" id="{571A424E-AA81-AEAE-B6C9-73C427F08E40}"/>
               </a:ext>
             </a:extLst>
           </p:cNvPr>
@@ -1950,7 +1952,7 @@
           <a:bodyPr/>
           <a:lstStyle/>
           <a:p>
-            <a:fld id="{6D4811C1-AEF3-4DDB-8A6F-AFFB6AB542CA}" type="datetimeFigureOut">
+            <a:fld id="{5A1AF197-8666-45A1-A9DD-65DA68AEA0EB}" type="datetimeFigureOut">
               <a:rPr lang="de-DE" smtClean="0"/>
               <a:t>08.10.2026</a:t>
             </a:fld>
@@ -1963,7 +1965,7 @@
           <p:cNvPr id="4" name="Fußzeilenplatzhalter 3">
             <a:extLst>
               <a:ext uri="{FF2B5EF4-FFF2-40B4-BE49-F238E27FC236}">
-                <a16:creationId xmlns:a16="http://schemas.microsoft.com/office/drawing/2014/main" id="{FAC534CF-1454-64D4-DFBC-BE0170240E77}"/>
+                <a16:creationId xmlns:a16="http://schemas.microsoft.com/office/drawing/2014/main" id="{F23F30FF-A2F4-9657-DFE4-ADCE0196E561}"/>
               </a:ext>
             </a:extLst>
           </p:cNvPr>
@@ -1988,7 +1990,7 @@
           <p:cNvPr id="5" name="Foliennummernplatzhalter 4">
             <a:extLst>
               <a:ext uri="{FF2B5EF4-FFF2-40B4-BE49-F238E27FC236}">
-                <a16:creationId xmlns:a16="http://schemas.microsoft.com/office/drawing/2014/main" id="{CB21E90E-BF9F-36AA-7EE6-9A300E54BE07}"/>
+                <a16:creationId xmlns:a16="http://schemas.microsoft.com/office/drawing/2014/main" id="{0127FB7C-B101-D599-1C23-B658F1A3A7E4}"/>
               </a:ext>
             </a:extLst>
           </p:cNvPr>
@@ -2004,7 +2006,7 @@
           <a:bodyPr/>
           <a:lstStyle/>
           <a:p>
-            <a:fld id="{F45884CD-9BF8-425B-9EAD-9E0FE3DAEAB7}" type="slidenum">
+            <a:fld id="{FD7A2B11-542E-4CA3-8CAD-ADBF93301D0C}" type="slidenum">
               <a:rPr lang="de-DE" smtClean="0"/>
               <a:t>‹Nr.›</a:t>
             </a:fld>
@@ -2015,7 +2017,7 @@
     </p:spTree>
     <p:extLst>
       <p:ext uri="{BB962C8B-B14F-4D97-AF65-F5344CB8AC3E}">
-        <p14:creationId xmlns:p14="http://schemas.microsoft.com/office/powerpoint/2010/main" val="2240725117"/>
+        <p14:creationId xmlns:p14="http://schemas.microsoft.com/office/powerpoint/2010/main" val="2573641852"/>
       </p:ext>
     </p:extLst>
   </p:cSld>
@@ -2047,7 +2049,7 @@
           <p:cNvPr id="2" name="Datumsplatzhalter 1">
             <a:extLst>
               <a:ext uri="{FF2B5EF4-FFF2-40B4-BE49-F238E27FC236}">
-                <a16:creationId xmlns:a16="http://schemas.microsoft.com/office/drawing/2014/main" id="{AE088A3B-2222-82D8-E0BE-8C6F036ECD86}"/>
+                <a16:creationId xmlns:a16="http://schemas.microsoft.com/office/drawing/2014/main" id="{7282B58B-A0AE-A9DE-0E81-2333FF204C55}"/>
               </a:ext>
             </a:extLst>
           </p:cNvPr>
@@ -2063,7 +2065,7 @@
           <a:bodyPr/>
           <a:lstStyle/>
           <a:p>
-            <a:fld id="{6D4811C1-AEF3-4DDB-8A6F-AFFB6AB542CA}" type="datetimeFigureOut">
+            <a:fld id="{5A1AF197-8666-45A1-A9DD-65DA68AEA0EB}" type="datetimeFigureOut">
               <a:rPr lang="de-DE" smtClean="0"/>
               <a:t>08.10.2026</a:t>
             </a:fld>
@@ -2076,7 +2078,7 @@
           <p:cNvPr id="3" name="Fußzeilenplatzhalter 2">
             <a:extLst>
               <a:ext uri="{FF2B5EF4-FFF2-40B4-BE49-F238E27FC236}">
-                <a16:creationId xmlns:a16="http://schemas.microsoft.com/office/drawing/2014/main" id="{43E98CD1-55C6-6F71-405B-6B67D1E72D23}"/>
+                <a16:creationId xmlns:a16="http://schemas.microsoft.com/office/drawing/2014/main" id="{3CFF02AA-C73E-9097-EFF8-128E14C9300B}"/>
               </a:ext>
             </a:extLst>
           </p:cNvPr>
@@ -2101,7 +2103,7 @@
           <p:cNvPr id="4" name="Foliennummernplatzhalter 3">
             <a:extLst>
               <a:ext uri="{FF2B5EF4-FFF2-40B4-BE49-F238E27FC236}">
-                <a16:creationId xmlns:a16="http://schemas.microsoft.com/office/drawing/2014/main" id="{9D5F17D8-24E2-949F-2515-109B27E96822}"/>
+                <a16:creationId xmlns:a16="http://schemas.microsoft.com/office/drawing/2014/main" id="{3250BD19-16C8-D21E-2374-0B75DB47AAD8}"/>
               </a:ext>
             </a:extLst>
           </p:cNvPr>
@@ -2117,7 +2119,7 @@
           <a:bodyPr/>
           <a:lstStyle/>
           <a:p>
-            <a:fld id="{F45884CD-9BF8-425B-9EAD-9E0FE3DAEAB7}" type="slidenum">
+            <a:fld id="{FD7A2B11-542E-4CA3-8CAD-ADBF93301D0C}" type="slidenum">
               <a:rPr lang="de-DE" smtClean="0"/>
               <a:t>‹Nr.›</a:t>
             </a:fld>
@@ -2128,7 +2130,7 @@
     </p:spTree>
     <p:extLst>
       <p:ext uri="{BB962C8B-B14F-4D97-AF65-F5344CB8AC3E}">
-        <p14:creationId xmlns:p14="http://schemas.microsoft.com/office/powerpoint/2010/main" val="1442249529"/>
+        <p14:creationId xmlns:p14="http://schemas.microsoft.com/office/powerpoint/2010/main" val="2840669831"/>
       </p:ext>
     </p:extLst>
   </p:cSld>
@@ -2160,7 +2162,7 @@
           <p:cNvPr id="2" name="Titel 1">
             <a:extLst>
               <a:ext uri="{FF2B5EF4-FFF2-40B4-BE49-F238E27FC236}">
-                <a16:creationId xmlns:a16="http://schemas.microsoft.com/office/drawing/2014/main" id="{9B7395CE-5484-2302-7DE5-A5D1816F3708}"/>
+                <a16:creationId xmlns:a16="http://schemas.microsoft.com/office/drawing/2014/main" id="{EA490759-DD95-7AD8-D8F4-71529678A784}"/>
               </a:ext>
             </a:extLst>
           </p:cNvPr>
@@ -2197,7 +2199,7 @@
           <p:cNvPr id="3" name="Inhaltsplatzhalter 2">
             <a:extLst>
               <a:ext uri="{FF2B5EF4-FFF2-40B4-BE49-F238E27FC236}">
-                <a16:creationId xmlns:a16="http://schemas.microsoft.com/office/drawing/2014/main" id="{6593991B-8336-F67F-D1AA-BE160919B3E4}"/>
+                <a16:creationId xmlns:a16="http://schemas.microsoft.com/office/drawing/2014/main" id="{A5B00C52-AE47-5A09-A9A4-4439FE1F109E}"/>
               </a:ext>
             </a:extLst>
           </p:cNvPr>
@@ -2287,7 +2289,7 @@
           <p:cNvPr id="4" name="Textplatzhalter 3">
             <a:extLst>
               <a:ext uri="{FF2B5EF4-FFF2-40B4-BE49-F238E27FC236}">
-                <a16:creationId xmlns:a16="http://schemas.microsoft.com/office/drawing/2014/main" id="{F916B70B-EDCE-9B20-A68D-52DFCA638506}"/>
+                <a16:creationId xmlns:a16="http://schemas.microsoft.com/office/drawing/2014/main" id="{B8ADC2AA-2294-B49A-9D4A-0DE780C16DB5}"/>
               </a:ext>
             </a:extLst>
           </p:cNvPr>
@@ -2358,7 +2360,7 @@
           <p:cNvPr id="5" name="Datumsplatzhalter 4">
             <a:extLst>
               <a:ext uri="{FF2B5EF4-FFF2-40B4-BE49-F238E27FC236}">
-                <a16:creationId xmlns:a16="http://schemas.microsoft.com/office/drawing/2014/main" id="{BD44F1DE-1B06-33F1-F282-73FB2E24D9E8}"/>
+                <a16:creationId xmlns:a16="http://schemas.microsoft.com/office/drawing/2014/main" id="{F492C5EB-1021-EACA-EBF7-950CC7D0F7CB}"/>
               </a:ext>
             </a:extLst>
           </p:cNvPr>
@@ -2374,7 +2376,7 @@
           <a:bodyPr/>
           <a:lstStyle/>
           <a:p>
-            <a:fld id="{6D4811C1-AEF3-4DDB-8A6F-AFFB6AB542CA}" type="datetimeFigureOut">
+            <a:fld id="{5A1AF197-8666-45A1-A9DD-65DA68AEA0EB}" type="datetimeFigureOut">
               <a:rPr lang="de-DE" smtClean="0"/>
               <a:t>08.10.2026</a:t>
             </a:fld>
@@ -2387,7 +2389,7 @@
           <p:cNvPr id="6" name="Fußzeilenplatzhalter 5">
             <a:extLst>
               <a:ext uri="{FF2B5EF4-FFF2-40B4-BE49-F238E27FC236}">
-                <a16:creationId xmlns:a16="http://schemas.microsoft.com/office/drawing/2014/main" id="{4DF346E9-29E9-C3F0-9F2A-25FF4A20D11F}"/>
+                <a16:creationId xmlns:a16="http://schemas.microsoft.com/office/drawing/2014/main" id="{2C88EAEA-3AE6-98B5-FA33-8BCFDB17DE97}"/>
               </a:ext>
             </a:extLst>
           </p:cNvPr>
@@ -2412,7 +2414,7 @@
           <p:cNvPr id="7" name="Foliennummernplatzhalter 6">
             <a:extLst>
               <a:ext uri="{FF2B5EF4-FFF2-40B4-BE49-F238E27FC236}">
-                <a16:creationId xmlns:a16="http://schemas.microsoft.com/office/drawing/2014/main" id="{0C843E76-2038-2A0C-7E81-43798B5E3C93}"/>
+                <a16:creationId xmlns:a16="http://schemas.microsoft.com/office/drawing/2014/main" id="{AC08A9FA-3460-A241-89A5-14DEF284408E}"/>
               </a:ext>
             </a:extLst>
           </p:cNvPr>
@@ -2428,7 +2430,7 @@
           <a:bodyPr/>
           <a:lstStyle/>
           <a:p>
-            <a:fld id="{F45884CD-9BF8-425B-9EAD-9E0FE3DAEAB7}" type="slidenum">
+            <a:fld id="{FD7A2B11-542E-4CA3-8CAD-ADBF93301D0C}" type="slidenum">
               <a:rPr lang="de-DE" smtClean="0"/>
               <a:t>‹Nr.›</a:t>
             </a:fld>
@@ -2439,7 +2441,7 @@
     </p:spTree>
     <p:extLst>
       <p:ext uri="{BB962C8B-B14F-4D97-AF65-F5344CB8AC3E}">
-        <p14:creationId xmlns:p14="http://schemas.microsoft.com/office/powerpoint/2010/main" val="2687356039"/>
+        <p14:creationId xmlns:p14="http://schemas.microsoft.com/office/powerpoint/2010/main" val="236535551"/>
       </p:ext>
     </p:extLst>
   </p:cSld>
@@ -2471,7 +2473,7 @@
           <p:cNvPr id="2" name="Titel 1">
             <a:extLst>
               <a:ext uri="{FF2B5EF4-FFF2-40B4-BE49-F238E27FC236}">
-                <a16:creationId xmlns:a16="http://schemas.microsoft.com/office/drawing/2014/main" id="{58465F50-ED0E-3112-8857-0D8273C76DA2}"/>
+                <a16:creationId xmlns:a16="http://schemas.microsoft.com/office/drawing/2014/main" id="{E1ED5D83-5432-08B7-ED72-46E55380525A}"/>
               </a:ext>
             </a:extLst>
           </p:cNvPr>
@@ -2508,7 +2510,7 @@
           <p:cNvPr id="3" name="Bildplatzhalter 2">
             <a:extLst>
               <a:ext uri="{FF2B5EF4-FFF2-40B4-BE49-F238E27FC236}">
-                <a16:creationId xmlns:a16="http://schemas.microsoft.com/office/drawing/2014/main" id="{D8A26185-CBF0-46BF-C1FE-343248AF439C}"/>
+                <a16:creationId xmlns:a16="http://schemas.microsoft.com/office/drawing/2014/main" id="{D7A031F4-40A6-9190-865C-CEBC1A817FA5}"/>
               </a:ext>
             </a:extLst>
           </p:cNvPr>
@@ -2575,7 +2577,7 @@
           <p:cNvPr id="4" name="Textplatzhalter 3">
             <a:extLst>
               <a:ext uri="{FF2B5EF4-FFF2-40B4-BE49-F238E27FC236}">
-                <a16:creationId xmlns:a16="http://schemas.microsoft.com/office/drawing/2014/main" id="{44B84922-CBCD-E9A3-064B-67E1BC6E14F1}"/>
+                <a16:creationId xmlns:a16="http://schemas.microsoft.com/office/drawing/2014/main" id="{23789805-7810-7EEE-59FE-04FA2F21F8B2}"/>
               </a:ext>
             </a:extLst>
           </p:cNvPr>
@@ -2646,7 +2648,7 @@
           <p:cNvPr id="5" name="Datumsplatzhalter 4">
             <a:extLst>
               <a:ext uri="{FF2B5EF4-FFF2-40B4-BE49-F238E27FC236}">
-                <a16:creationId xmlns:a16="http://schemas.microsoft.com/office/drawing/2014/main" id="{D4C71F24-6C5F-07FB-BC63-B6BA751A2CD7}"/>
+                <a16:creationId xmlns:a16="http://schemas.microsoft.com/office/drawing/2014/main" id="{4E3CFBFD-8AE0-22A1-8740-A7D51952D861}"/>
               </a:ext>
             </a:extLst>
           </p:cNvPr>
@@ -2662,7 +2664,7 @@
           <a:bodyPr/>
           <a:lstStyle/>
           <a:p>
-            <a:fld id="{6D4811C1-AEF3-4DDB-8A6F-AFFB6AB542CA}" type="datetimeFigureOut">
+            <a:fld id="{5A1AF197-8666-45A1-A9DD-65DA68AEA0EB}" type="datetimeFigureOut">
               <a:rPr lang="de-DE" smtClean="0"/>
               <a:t>08.10.2026</a:t>
             </a:fld>
@@ -2675,7 +2677,7 @@
           <p:cNvPr id="6" name="Fußzeilenplatzhalter 5">
             <a:extLst>
               <a:ext uri="{FF2B5EF4-FFF2-40B4-BE49-F238E27FC236}">
-                <a16:creationId xmlns:a16="http://schemas.microsoft.com/office/drawing/2014/main" id="{87E80B2D-B55D-113E-9303-638EFD1F21F1}"/>
+                <a16:creationId xmlns:a16="http://schemas.microsoft.com/office/drawing/2014/main" id="{668B69EA-2174-3132-17B1-43E202968E75}"/>
               </a:ext>
             </a:extLst>
           </p:cNvPr>
@@ -2700,7 +2702,7 @@
           <p:cNvPr id="7" name="Foliennummernplatzhalter 6">
             <a:extLst>
               <a:ext uri="{FF2B5EF4-FFF2-40B4-BE49-F238E27FC236}">
-                <a16:creationId xmlns:a16="http://schemas.microsoft.com/office/drawing/2014/main" id="{ECEDD754-42A2-3335-4596-3CAADAE0E189}"/>
+                <a16:creationId xmlns:a16="http://schemas.microsoft.com/office/drawing/2014/main" id="{8CF36AC2-0275-3140-1966-E1B21A7528E0}"/>
               </a:ext>
             </a:extLst>
           </p:cNvPr>
@@ -2716,7 +2718,7 @@
           <a:bodyPr/>
           <a:lstStyle/>
           <a:p>
-            <a:fld id="{F45884CD-9BF8-425B-9EAD-9E0FE3DAEAB7}" type="slidenum">
+            <a:fld id="{FD7A2B11-542E-4CA3-8CAD-ADBF93301D0C}" type="slidenum">
               <a:rPr lang="de-DE" smtClean="0"/>
               <a:t>‹Nr.›</a:t>
             </a:fld>
@@ -2727,7 +2729,7 @@
     </p:spTree>
     <p:extLst>
       <p:ext uri="{BB962C8B-B14F-4D97-AF65-F5344CB8AC3E}">
-        <p14:creationId xmlns:p14="http://schemas.microsoft.com/office/powerpoint/2010/main" val="3950438343"/>
+        <p14:creationId xmlns:p14="http://schemas.microsoft.com/office/powerpoint/2010/main" val="4284705121"/>
       </p:ext>
     </p:extLst>
   </p:cSld>
@@ -2764,7 +2766,7 @@
           <p:cNvPr id="2" name="Titelplatzhalter 1">
             <a:extLst>
               <a:ext uri="{FF2B5EF4-FFF2-40B4-BE49-F238E27FC236}">
-                <a16:creationId xmlns:a16="http://schemas.microsoft.com/office/drawing/2014/main" id="{8020E904-FA50-2C2A-FB3C-64C94D818CB2}"/>
+                <a16:creationId xmlns:a16="http://schemas.microsoft.com/office/drawing/2014/main" id="{2A1B5342-469A-88F5-06D1-2F6BAE196031}"/>
               </a:ext>
             </a:extLst>
           </p:cNvPr>
@@ -2802,7 +2804,7 @@
           <p:cNvPr id="3" name="Textplatzhalter 2">
             <a:extLst>
               <a:ext uri="{FF2B5EF4-FFF2-40B4-BE49-F238E27FC236}">
-                <a16:creationId xmlns:a16="http://schemas.microsoft.com/office/drawing/2014/main" id="{A463D5CC-9926-5934-4D7A-B4CEA8482180}"/>
+                <a16:creationId xmlns:a16="http://schemas.microsoft.com/office/drawing/2014/main" id="{FF82D3DA-0033-4E60-AD70-530A1E840A4A}"/>
               </a:ext>
             </a:extLst>
           </p:cNvPr>
@@ -2869,7 +2871,7 @@
           <p:cNvPr id="4" name="Datumsplatzhalter 3">
             <a:extLst>
               <a:ext uri="{FF2B5EF4-FFF2-40B4-BE49-F238E27FC236}">
-                <a16:creationId xmlns:a16="http://schemas.microsoft.com/office/drawing/2014/main" id="{46848C39-0DBC-526E-7C5D-B9B609322A2E}"/>
+                <a16:creationId xmlns:a16="http://schemas.microsoft.com/office/drawing/2014/main" id="{83311BBC-602C-292F-9D94-A1655F3472B8}"/>
               </a:ext>
             </a:extLst>
           </p:cNvPr>
@@ -2903,7 +2905,7 @@
             </a:lvl1pPr>
           </a:lstStyle>
           <a:p>
-            <a:fld id="{6D4811C1-AEF3-4DDB-8A6F-AFFB6AB542CA}" type="datetimeFigureOut">
+            <a:fld id="{5A1AF197-8666-45A1-A9DD-65DA68AEA0EB}" type="datetimeFigureOut">
               <a:rPr lang="de-DE" smtClean="0"/>
               <a:t>08.10.2026</a:t>
             </a:fld>
@@ -2916,7 +2918,7 @@
           <p:cNvPr id="5" name="Fußzeilenplatzhalter 4">
             <a:extLst>
               <a:ext uri="{FF2B5EF4-FFF2-40B4-BE49-F238E27FC236}">
-                <a16:creationId xmlns:a16="http://schemas.microsoft.com/office/drawing/2014/main" id="{BE26E72E-9BC3-6E7D-5D1A-06BCEB0E7F3F}"/>
+                <a16:creationId xmlns:a16="http://schemas.microsoft.com/office/drawing/2014/main" id="{EEC4B4EA-CE28-553A-B843-ABDAE0269558}"/>
               </a:ext>
             </a:extLst>
           </p:cNvPr>
@@ -2959,7 +2961,7 @@
           <p:cNvPr id="6" name="Foliennummernplatzhalter 5">
             <a:extLst>
               <a:ext uri="{FF2B5EF4-FFF2-40B4-BE49-F238E27FC236}">
-                <a16:creationId xmlns:a16="http://schemas.microsoft.com/office/drawing/2014/main" id="{4AA60E5D-7546-EE1D-A42D-1E431B5FB471}"/>
+                <a16:creationId xmlns:a16="http://schemas.microsoft.com/office/drawing/2014/main" id="{BD0E9F3A-3C43-96F2-4149-F8D7885C390E}"/>
               </a:ext>
             </a:extLst>
           </p:cNvPr>
@@ -2993,7 +2995,7 @@
             </a:lvl1pPr>
           </a:lstStyle>
           <a:p>
-            <a:fld id="{F45884CD-9BF8-425B-9EAD-9E0FE3DAEAB7}" type="slidenum">
+            <a:fld id="{FD7A2B11-542E-4CA3-8CAD-ADBF93301D0C}" type="slidenum">
               <a:rPr lang="de-DE" smtClean="0"/>
               <a:t>‹Nr.›</a:t>
             </a:fld>
@@ -3004,7 +3006,7 @@
     </p:spTree>
     <p:extLst>
       <p:ext uri="{BB962C8B-B14F-4D97-AF65-F5344CB8AC3E}">
-        <p14:creationId xmlns:p14="http://schemas.microsoft.com/office/powerpoint/2010/main" val="4056324035"/>
+        <p14:creationId xmlns:p14="http://schemas.microsoft.com/office/powerpoint/2010/main" val="1261187872"/>
       </p:ext>
     </p:extLst>
   </p:cSld>
@@ -3327,7 +3329,7 @@
           <p:cNvPr id="2" name="Rechteck 1">
             <a:extLst>
               <a:ext uri="{FF2B5EF4-FFF2-40B4-BE49-F238E27FC236}">
-                <a16:creationId xmlns:a16="http://schemas.microsoft.com/office/drawing/2014/main" id="{9AFB2ABC-99D7-D579-325C-09A003F1CC60}"/>
+                <a16:creationId xmlns:a16="http://schemas.microsoft.com/office/drawing/2014/main" id="{9F1DCDF6-ED1D-A1B1-39B9-92A272144DBC}"/>
               </a:ext>
             </a:extLst>
           </p:cNvPr>
@@ -3404,7 +3406,7 @@
           <p:cNvPr id="3" name="Rechteck 2">
             <a:extLst>
               <a:ext uri="{FF2B5EF4-FFF2-40B4-BE49-F238E27FC236}">
-                <a16:creationId xmlns:a16="http://schemas.microsoft.com/office/drawing/2014/main" id="{015D2D40-5DA4-1763-0EF2-1E1D1A0CE33C}"/>
+                <a16:creationId xmlns:a16="http://schemas.microsoft.com/office/drawing/2014/main" id="{43116EA8-4129-2AEC-AA30-0B643F63BED8}"/>
               </a:ext>
             </a:extLst>
           </p:cNvPr>
@@ -3479,7 +3481,7 @@
           <p:cNvPr id="4" name="Rechteck: abgerundete Ecken 3">
             <a:extLst>
               <a:ext uri="{FF2B5EF4-FFF2-40B4-BE49-F238E27FC236}">
-                <a16:creationId xmlns:a16="http://schemas.microsoft.com/office/drawing/2014/main" id="{653B1A2D-0AB8-D1D2-D105-E8C352D833BC}"/>
+                <a16:creationId xmlns:a16="http://schemas.microsoft.com/office/drawing/2014/main" id="{0A159F4C-7D71-3391-FFD2-E1431B85F4FE}"/>
               </a:ext>
             </a:extLst>
           </p:cNvPr>
@@ -3556,7 +3558,7 @@
           <p:cNvPr id="5" name="Rechteck 4">
             <a:extLst>
               <a:ext uri="{FF2B5EF4-FFF2-40B4-BE49-F238E27FC236}">
-                <a16:creationId xmlns:a16="http://schemas.microsoft.com/office/drawing/2014/main" id="{BF744559-8CCE-D865-DF14-A20BA43A3F0C}"/>
+                <a16:creationId xmlns:a16="http://schemas.microsoft.com/office/drawing/2014/main" id="{BE15463F-8592-E90E-5CA4-6274A0BA1081}"/>
               </a:ext>
             </a:extLst>
           </p:cNvPr>
@@ -3633,7 +3635,7 @@
           <p:cNvPr id="6" name="Ellipse 5">
             <a:extLst>
               <a:ext uri="{FF2B5EF4-FFF2-40B4-BE49-F238E27FC236}">
-                <a16:creationId xmlns:a16="http://schemas.microsoft.com/office/drawing/2014/main" id="{479585BD-9D4B-5DB0-B19C-DE538802AC67}"/>
+                <a16:creationId xmlns:a16="http://schemas.microsoft.com/office/drawing/2014/main" id="{0B45B2C6-A961-FB56-0CF0-EA7F07C17D44}"/>
               </a:ext>
             </a:extLst>
           </p:cNvPr>
@@ -3710,7 +3712,7 @@
           <p:cNvPr id="7" name="Rechteck 6">
             <a:extLst>
               <a:ext uri="{FF2B5EF4-FFF2-40B4-BE49-F238E27FC236}">
-                <a16:creationId xmlns:a16="http://schemas.microsoft.com/office/drawing/2014/main" id="{0B6B3F27-8BAD-1E85-1930-A00E9B0DFD18}"/>
+                <a16:creationId xmlns:a16="http://schemas.microsoft.com/office/drawing/2014/main" id="{8BAE3E37-5FA9-369A-8B26-A413B6F3C6BA}"/>
               </a:ext>
             </a:extLst>
           </p:cNvPr>
@@ -3778,7 +3780,7 @@
           <p:cNvPr id="8" name="Ellipse 7">
             <a:extLst>
               <a:ext uri="{FF2B5EF4-FFF2-40B4-BE49-F238E27FC236}">
-                <a16:creationId xmlns:a16="http://schemas.microsoft.com/office/drawing/2014/main" id="{194079A1-7D1E-18E8-2675-DE0A7C64106B}"/>
+                <a16:creationId xmlns:a16="http://schemas.microsoft.com/office/drawing/2014/main" id="{DD480319-B6CD-46AA-5C51-843AF60A1336}"/>
               </a:ext>
             </a:extLst>
           </p:cNvPr>
@@ -3852,7 +3854,7 @@
     </p:spTree>
     <p:extLst>
       <p:ext uri="{BB962C8B-B14F-4D97-AF65-F5344CB8AC3E}">
-        <p14:creationId xmlns:p14="http://schemas.microsoft.com/office/powerpoint/2010/main" val="2080103135"/>
+        <p14:creationId xmlns:p14="http://schemas.microsoft.com/office/powerpoint/2010/main" val="3732569157"/>
       </p:ext>
     </p:extLst>
   </p:cSld>
@@ -3884,7 +3886,7 @@
           <p:cNvPr id="2" name="Rechteck 1">
             <a:extLst>
               <a:ext uri="{FF2B5EF4-FFF2-40B4-BE49-F238E27FC236}">
-                <a16:creationId xmlns:a16="http://schemas.microsoft.com/office/drawing/2014/main" id="{8C42AFB5-8F9B-C906-69BB-2C0ACB11C6C5}"/>
+                <a16:creationId xmlns:a16="http://schemas.microsoft.com/office/drawing/2014/main" id="{EB0CDFF3-9426-601B-6B93-8B20E9316F4C}"/>
               </a:ext>
             </a:extLst>
           </p:cNvPr>
@@ -3962,7 +3964,7 @@
           <p:cNvPr id="3" name="Rechteck: abgerundete Ecken 2">
             <a:extLst>
               <a:ext uri="{FF2B5EF4-FFF2-40B4-BE49-F238E27FC236}">
-                <a16:creationId xmlns:a16="http://schemas.microsoft.com/office/drawing/2014/main" id="{F981924B-C607-12CD-5663-3D2679070DF6}"/>
+                <a16:creationId xmlns:a16="http://schemas.microsoft.com/office/drawing/2014/main" id="{91887F2B-F1A3-0409-742A-AAC507E60903}"/>
               </a:ext>
             </a:extLst>
           </p:cNvPr>
@@ -4040,7 +4042,7 @@
           <p:cNvPr id="4" name="Rechteck 3">
             <a:extLst>
               <a:ext uri="{FF2B5EF4-FFF2-40B4-BE49-F238E27FC236}">
-                <a16:creationId xmlns:a16="http://schemas.microsoft.com/office/drawing/2014/main" id="{3A0C565C-EE08-254A-86D2-02DE6440D982}"/>
+                <a16:creationId xmlns:a16="http://schemas.microsoft.com/office/drawing/2014/main" id="{39D9021C-216B-06E2-F7F8-246E778987FE}"/>
               </a:ext>
             </a:extLst>
           </p:cNvPr>
@@ -4117,7 +4119,7 @@
           <p:cNvPr id="5" name="Rechteck 4">
             <a:extLst>
               <a:ext uri="{FF2B5EF4-FFF2-40B4-BE49-F238E27FC236}">
-                <a16:creationId xmlns:a16="http://schemas.microsoft.com/office/drawing/2014/main" id="{43D76E9D-E947-8D55-3DC1-E829D9AC38D6}"/>
+                <a16:creationId xmlns:a16="http://schemas.microsoft.com/office/drawing/2014/main" id="{619EA6EB-1412-081E-5CA7-33EFDAF275D9}"/>
               </a:ext>
             </a:extLst>
           </p:cNvPr>
@@ -4193,7 +4195,7 @@
           <p:cNvPr id="6" name="Ellipse 5">
             <a:extLst>
               <a:ext uri="{FF2B5EF4-FFF2-40B4-BE49-F238E27FC236}">
-                <a16:creationId xmlns:a16="http://schemas.microsoft.com/office/drawing/2014/main" id="{271DD69E-D4AB-9BF6-2E4D-7925ECA2377A}"/>
+                <a16:creationId xmlns:a16="http://schemas.microsoft.com/office/drawing/2014/main" id="{FDFFA47E-B452-EA0E-5EB0-92DE20429C18}"/>
               </a:ext>
             </a:extLst>
           </p:cNvPr>
@@ -4269,7 +4271,1251 @@
     </p:spTree>
     <p:extLst>
       <p:ext uri="{BB962C8B-B14F-4D97-AF65-F5344CB8AC3E}">
-        <p14:creationId xmlns:p14="http://schemas.microsoft.com/office/powerpoint/2010/main" val="3189950230"/>
+        <p14:creationId xmlns:p14="http://schemas.microsoft.com/office/powerpoint/2010/main" val="1993990675"/>
+      </p:ext>
+    </p:extLst>
+  </p:cSld>
+  <p:clrMapOvr>
+    <a:masterClrMapping/>
+  </p:clrMapOvr>
+</p:sld>
+</file>
+
+<file path=ppt/slides/slide3.xml><?xml version="1.0" encoding="utf-8"?>
+<p:sld xmlns:a="http://schemas.openxmlformats.org/drawingml/2006/main" xmlns:r="http://schemas.openxmlformats.org/officeDocument/2006/relationships" xmlns:p="http://schemas.openxmlformats.org/presentationml/2006/main">
+  <p:cSld>
+    <p:spTree>
+      <p:nvGrpSpPr>
+        <p:cNvPr id="1" name=""/>
+        <p:cNvGrpSpPr/>
+        <p:nvPr/>
+      </p:nvGrpSpPr>
+      <p:grpSpPr>
+        <a:xfrm>
+          <a:off x="0" y="0"/>
+          <a:ext cx="0" cy="0"/>
+          <a:chOff x="0" y="0"/>
+          <a:chExt cx="0" cy="0"/>
+        </a:xfrm>
+      </p:grpSpPr>
+      <p:sp>
+        <p:nvSpPr>
+          <p:cNvPr id="2" name="perspective-0">
+            <a:extLst>
+              <a:ext uri="{FF2B5EF4-FFF2-40B4-BE49-F238E27FC236}">
+                <a16:creationId xmlns:a16="http://schemas.microsoft.com/office/drawing/2014/main" id="{BEF7C74C-C132-B0D8-D66A-D719F3DB739A}"/>
+              </a:ext>
+            </a:extLst>
+          </p:cNvPr>
+          <p:cNvSpPr/>
+          <p:nvPr/>
+        </p:nvSpPr>
+        <p:spPr>
+          <a:xfrm>
+            <a:off x="762000" y="1016000"/>
+            <a:ext cx="1651000" cy="1270000"/>
+          </a:xfrm>
+          <a:prstGeom prst="rect">
+            <a:avLst/>
+          </a:prstGeom>
+          <a:solidFill>
+            <a:srgbClr val="4472C4"/>
+          </a:solidFill>
+          <a:ln w="19050" cap="flat" cmpd="sng" algn="ctr">
+            <a:noFill/>
+            <a:prstDash val="solid"/>
+            <a:miter lim="800000"/>
+          </a:ln>
+          <a:effectLst xmlns:a="http://schemas.openxmlformats.org/drawingml/2006/main">
+            <a:outerShdw dist="0" sx="100000" sy="-50000" algn="b">
+              <a:srgbClr val="000000">
+                <a:alpha val="50000"/>
+              </a:srgbClr>
+            </a:outerShdw>
+          </a:effectLst>
+          <a:extLst>
+            <a:ext uri="{91240B29-F687-4F45-9708-019B960494DF}">
+              <a14:hiddenLine xmlns:a14="http://schemas.microsoft.com/office/drawing/2010/main" w="19050" cap="flat" cmpd="sng" algn="ctr">
+                <a:solidFill>
+                  <a:schemeClr val="accent1">
+                    <a:shade val="15000"/>
+                  </a:schemeClr>
+                </a:solidFill>
+                <a:prstDash val="solid"/>
+                <a:miter lim="800000"/>
+              </a14:hiddenLine>
+            </a:ext>
+          </a:extLst>
+        </p:spPr>
+        <p:style>
+          <a:lnRef idx="2">
+            <a:schemeClr val="accent1">
+              <a:shade val="15000"/>
+            </a:schemeClr>
+          </a:lnRef>
+          <a:fillRef idx="1">
+            <a:schemeClr val="accent1"/>
+          </a:fillRef>
+          <a:effectRef idx="0">
+            <a:schemeClr val="accent1"/>
+          </a:effectRef>
+          <a:fontRef idx="minor">
+            <a:schemeClr val="lt1"/>
+          </a:fontRef>
+        </p:style>
+        <p:txBody>
+          <a:bodyPr rtlCol="0" anchor="ctr"/>
+          <a:lstStyle/>
+          <a:p>
+            <a:pPr algn="ctr"/>
+            <a:endParaRPr lang="de-DE"/>
+          </a:p>
+        </p:txBody>
+      </p:sp>
+      <p:sp>
+        <p:nvSpPr>
+          <p:cNvPr id="3" name="perspective-1">
+            <a:extLst>
+              <a:ext uri="{FF2B5EF4-FFF2-40B4-BE49-F238E27FC236}">
+                <a16:creationId xmlns:a16="http://schemas.microsoft.com/office/drawing/2014/main" id="{BD4FA95A-1329-2224-7377-D8ED6346DB77}"/>
+              </a:ext>
+            </a:extLst>
+          </p:cNvPr>
+          <p:cNvSpPr/>
+          <p:nvPr/>
+        </p:nvSpPr>
+        <p:spPr>
+          <a:xfrm>
+            <a:off x="3683000" y="1016000"/>
+            <a:ext cx="1651000" cy="1270000"/>
+          </a:xfrm>
+          <a:prstGeom prst="rect">
+            <a:avLst/>
+          </a:prstGeom>
+          <a:solidFill>
+            <a:srgbClr val="4472C4"/>
+          </a:solidFill>
+          <a:ln w="19050" cap="flat" cmpd="sng" algn="ctr">
+            <a:noFill/>
+            <a:prstDash val="solid"/>
+            <a:miter lim="800000"/>
+          </a:ln>
+          <a:effectLst xmlns:a="http://schemas.openxmlformats.org/drawingml/2006/main">
+            <a:outerShdw dist="12700" dir="8100000" sy="-23000" kx="800400" algn="br">
+              <a:srgbClr val="000000">
+                <a:alpha val="50000"/>
+              </a:srgbClr>
+            </a:outerShdw>
+          </a:effectLst>
+          <a:extLst>
+            <a:ext uri="{91240B29-F687-4F45-9708-019B960494DF}">
+              <a14:hiddenLine xmlns:a14="http://schemas.microsoft.com/office/drawing/2010/main" w="19050" cap="flat" cmpd="sng" algn="ctr">
+                <a:solidFill>
+                  <a:schemeClr val="accent1">
+                    <a:shade val="15000"/>
+                  </a:schemeClr>
+                </a:solidFill>
+                <a:prstDash val="solid"/>
+                <a:miter lim="800000"/>
+              </a14:hiddenLine>
+            </a:ext>
+          </a:extLst>
+        </p:spPr>
+        <p:style>
+          <a:lnRef idx="2">
+            <a:schemeClr val="accent1">
+              <a:shade val="15000"/>
+            </a:schemeClr>
+          </a:lnRef>
+          <a:fillRef idx="1">
+            <a:schemeClr val="accent1"/>
+          </a:fillRef>
+          <a:effectRef idx="0">
+            <a:schemeClr val="accent1"/>
+          </a:effectRef>
+          <a:fontRef idx="minor">
+            <a:schemeClr val="lt1"/>
+          </a:fontRef>
+        </p:style>
+        <p:txBody>
+          <a:bodyPr rtlCol="0" anchor="ctr"/>
+          <a:lstStyle/>
+          <a:p>
+            <a:pPr algn="ctr"/>
+            <a:endParaRPr lang="de-DE"/>
+          </a:p>
+        </p:txBody>
+      </p:sp>
+      <p:sp>
+        <p:nvSpPr>
+          <p:cNvPr id="4" name="perspective-2">
+            <a:extLst>
+              <a:ext uri="{FF2B5EF4-FFF2-40B4-BE49-F238E27FC236}">
+                <a16:creationId xmlns:a16="http://schemas.microsoft.com/office/drawing/2014/main" id="{374FC81E-8387-5AA8-A2CB-2CE39D69A0E0}"/>
+              </a:ext>
+            </a:extLst>
+          </p:cNvPr>
+          <p:cNvSpPr/>
+          <p:nvPr/>
+        </p:nvSpPr>
+        <p:spPr>
+          <a:xfrm>
+            <a:off x="6604000" y="1016000"/>
+            <a:ext cx="1651000" cy="1270000"/>
+          </a:xfrm>
+          <a:prstGeom prst="rect">
+            <a:avLst/>
+          </a:prstGeom>
+          <a:solidFill>
+            <a:srgbClr val="4472C4"/>
+          </a:solidFill>
+          <a:ln w="19050" cap="flat" cmpd="sng" algn="ctr">
+            <a:noFill/>
+            <a:prstDash val="solid"/>
+            <a:miter lim="800000"/>
+          </a:ln>
+          <a:effectLst xmlns:a="http://schemas.openxmlformats.org/drawingml/2006/main">
+            <a:outerShdw dist="0" sx="50000" sy="50000" algn="tl">
+              <a:srgbClr val="000000">
+                <a:alpha val="50000"/>
+              </a:srgbClr>
+            </a:outerShdw>
+          </a:effectLst>
+          <a:extLst>
+            <a:ext uri="{91240B29-F687-4F45-9708-019B960494DF}">
+              <a14:hiddenLine xmlns:a14="http://schemas.microsoft.com/office/drawing/2010/main" w="19050" cap="flat" cmpd="sng" algn="ctr">
+                <a:solidFill>
+                  <a:schemeClr val="accent1">
+                    <a:shade val="15000"/>
+                  </a:schemeClr>
+                </a:solidFill>
+                <a:prstDash val="solid"/>
+                <a:miter lim="800000"/>
+              </a14:hiddenLine>
+            </a:ext>
+          </a:extLst>
+        </p:spPr>
+        <p:style>
+          <a:lnRef idx="2">
+            <a:schemeClr val="accent1">
+              <a:shade val="15000"/>
+            </a:schemeClr>
+          </a:lnRef>
+          <a:fillRef idx="1">
+            <a:schemeClr val="accent1"/>
+          </a:fillRef>
+          <a:effectRef idx="0">
+            <a:schemeClr val="accent1"/>
+          </a:effectRef>
+          <a:fontRef idx="minor">
+            <a:schemeClr val="lt1"/>
+          </a:fontRef>
+        </p:style>
+        <p:txBody>
+          <a:bodyPr rtlCol="0" anchor="ctr"/>
+          <a:lstStyle/>
+          <a:p>
+            <a:pPr algn="ctr"/>
+            <a:endParaRPr lang="de-DE"/>
+          </a:p>
+        </p:txBody>
+      </p:sp>
+      <p:sp>
+        <p:nvSpPr>
+          <p:cNvPr id="5" name="perspective-3">
+            <a:extLst>
+              <a:ext uri="{FF2B5EF4-FFF2-40B4-BE49-F238E27FC236}">
+                <a16:creationId xmlns:a16="http://schemas.microsoft.com/office/drawing/2014/main" id="{D0BE96B2-8D39-1D23-254E-D9CE4B278BD8}"/>
+              </a:ext>
+            </a:extLst>
+          </p:cNvPr>
+          <p:cNvSpPr/>
+          <p:nvPr/>
+        </p:nvSpPr>
+        <p:spPr>
+          <a:xfrm>
+            <a:off x="9525000" y="1016000"/>
+            <a:ext cx="1651000" cy="1270000"/>
+          </a:xfrm>
+          <a:prstGeom prst="rect">
+            <a:avLst/>
+          </a:prstGeom>
+          <a:solidFill>
+            <a:srgbClr val="4472C4"/>
+          </a:solidFill>
+          <a:ln w="19050" cap="flat" cmpd="sng" algn="ctr">
+            <a:noFill/>
+            <a:prstDash val="solid"/>
+            <a:miter lim="800000"/>
+          </a:ln>
+          <a:effectLst xmlns:a="http://schemas.openxmlformats.org/drawingml/2006/main">
+            <a:outerShdw dist="0" kx="1800000" algn="b">
+              <a:srgbClr val="000000">
+                <a:alpha val="50000"/>
+              </a:srgbClr>
+            </a:outerShdw>
+          </a:effectLst>
+          <a:extLst>
+            <a:ext uri="{91240B29-F687-4F45-9708-019B960494DF}">
+              <a14:hiddenLine xmlns:a14="http://schemas.microsoft.com/office/drawing/2010/main" w="19050" cap="flat" cmpd="sng" algn="ctr">
+                <a:solidFill>
+                  <a:schemeClr val="accent1">
+                    <a:shade val="15000"/>
+                  </a:schemeClr>
+                </a:solidFill>
+                <a:prstDash val="solid"/>
+                <a:miter lim="800000"/>
+              </a14:hiddenLine>
+            </a:ext>
+          </a:extLst>
+        </p:spPr>
+        <p:style>
+          <a:lnRef idx="2">
+            <a:schemeClr val="accent1">
+              <a:shade val="15000"/>
+            </a:schemeClr>
+          </a:lnRef>
+          <a:fillRef idx="1">
+            <a:schemeClr val="accent1"/>
+          </a:fillRef>
+          <a:effectRef idx="0">
+            <a:schemeClr val="accent1"/>
+          </a:effectRef>
+          <a:fontRef idx="minor">
+            <a:schemeClr val="lt1"/>
+          </a:fontRef>
+        </p:style>
+        <p:txBody>
+          <a:bodyPr rtlCol="0" anchor="ctr"/>
+          <a:lstStyle/>
+          <a:p>
+            <a:pPr algn="ctr"/>
+            <a:endParaRPr lang="de-DE"/>
+          </a:p>
+        </p:txBody>
+      </p:sp>
+      <p:sp>
+        <p:nvSpPr>
+          <p:cNvPr id="6" name="perspective-4">
+            <a:extLst>
+              <a:ext uri="{FF2B5EF4-FFF2-40B4-BE49-F238E27FC236}">
+                <a16:creationId xmlns:a16="http://schemas.microsoft.com/office/drawing/2014/main" id="{D180BCE6-6B27-72E1-FD32-E5E1D075A75A}"/>
+              </a:ext>
+            </a:extLst>
+          </p:cNvPr>
+          <p:cNvSpPr/>
+          <p:nvPr/>
+        </p:nvSpPr>
+        <p:spPr>
+          <a:xfrm>
+            <a:off x="762000" y="4318000"/>
+            <a:ext cx="1651000" cy="1270000"/>
+          </a:xfrm>
+          <a:prstGeom prst="rect">
+            <a:avLst/>
+          </a:prstGeom>
+          <a:solidFill>
+            <a:srgbClr val="4472C4"/>
+          </a:solidFill>
+          <a:ln w="19050" cap="flat" cmpd="sng" algn="ctr">
+            <a:noFill/>
+            <a:prstDash val="solid"/>
+            <a:miter lim="800000"/>
+          </a:ln>
+          <a:effectLst xmlns:a="http://schemas.openxmlformats.org/drawingml/2006/main">
+            <a:outerShdw dist="0" ky="1200000" algn="l">
+              <a:srgbClr val="000000">
+                <a:alpha val="50000"/>
+              </a:srgbClr>
+            </a:outerShdw>
+          </a:effectLst>
+          <a:extLst>
+            <a:ext uri="{91240B29-F687-4F45-9708-019B960494DF}">
+              <a14:hiddenLine xmlns:a14="http://schemas.microsoft.com/office/drawing/2010/main" w="19050" cap="flat" cmpd="sng" algn="ctr">
+                <a:solidFill>
+                  <a:schemeClr val="accent1">
+                    <a:shade val="15000"/>
+                  </a:schemeClr>
+                </a:solidFill>
+                <a:prstDash val="solid"/>
+                <a:miter lim="800000"/>
+              </a14:hiddenLine>
+            </a:ext>
+          </a:extLst>
+        </p:spPr>
+        <p:style>
+          <a:lnRef idx="2">
+            <a:schemeClr val="accent1">
+              <a:shade val="15000"/>
+            </a:schemeClr>
+          </a:lnRef>
+          <a:fillRef idx="1">
+            <a:schemeClr val="accent1"/>
+          </a:fillRef>
+          <a:effectRef idx="0">
+            <a:schemeClr val="accent1"/>
+          </a:effectRef>
+          <a:fontRef idx="minor">
+            <a:schemeClr val="lt1"/>
+          </a:fontRef>
+        </p:style>
+        <p:txBody>
+          <a:bodyPr rtlCol="0" anchor="ctr"/>
+          <a:lstStyle/>
+          <a:p>
+            <a:pPr algn="ctr"/>
+            <a:endParaRPr lang="de-DE"/>
+          </a:p>
+        </p:txBody>
+      </p:sp>
+      <p:sp>
+        <p:nvSpPr>
+          <p:cNvPr id="7" name="perspective-5">
+            <a:extLst>
+              <a:ext uri="{FF2B5EF4-FFF2-40B4-BE49-F238E27FC236}">
+                <a16:creationId xmlns:a16="http://schemas.microsoft.com/office/drawing/2014/main" id="{71BFD4D2-C820-3E33-9E0A-0A9E015106C7}"/>
+              </a:ext>
+            </a:extLst>
+          </p:cNvPr>
+          <p:cNvSpPr/>
+          <p:nvPr/>
+        </p:nvSpPr>
+        <p:spPr>
+          <a:xfrm>
+            <a:off x="3683000" y="4318000"/>
+            <a:ext cx="1651000" cy="1270000"/>
+          </a:xfrm>
+          <a:prstGeom prst="rect">
+            <a:avLst/>
+          </a:prstGeom>
+          <a:solidFill>
+            <a:srgbClr val="4472C4"/>
+          </a:solidFill>
+          <a:ln w="19050" cap="flat" cmpd="sng" algn="ctr">
+            <a:noFill/>
+            <a:prstDash val="solid"/>
+            <a:miter lim="800000"/>
+          </a:ln>
+          <a:effectLst xmlns:a="http://schemas.openxmlformats.org/drawingml/2006/main">
+            <a:outerShdw dist="0" sx="150000" sy="150000" algn="ctr">
+              <a:srgbClr val="000000">
+                <a:alpha val="50000"/>
+              </a:srgbClr>
+            </a:outerShdw>
+          </a:effectLst>
+          <a:extLst>
+            <a:ext uri="{91240B29-F687-4F45-9708-019B960494DF}">
+              <a14:hiddenLine xmlns:a14="http://schemas.microsoft.com/office/drawing/2010/main" w="19050" cap="flat" cmpd="sng" algn="ctr">
+                <a:solidFill>
+                  <a:schemeClr val="accent1">
+                    <a:shade val="15000"/>
+                  </a:schemeClr>
+                </a:solidFill>
+                <a:prstDash val="solid"/>
+                <a:miter lim="800000"/>
+              </a14:hiddenLine>
+            </a:ext>
+          </a:extLst>
+        </p:spPr>
+        <p:style>
+          <a:lnRef idx="2">
+            <a:schemeClr val="accent1">
+              <a:shade val="15000"/>
+            </a:schemeClr>
+          </a:lnRef>
+          <a:fillRef idx="1">
+            <a:schemeClr val="accent1"/>
+          </a:fillRef>
+          <a:effectRef idx="0">
+            <a:schemeClr val="accent1"/>
+          </a:effectRef>
+          <a:fontRef idx="minor">
+            <a:schemeClr val="lt1"/>
+          </a:fontRef>
+        </p:style>
+        <p:txBody>
+          <a:bodyPr rtlCol="0" anchor="ctr"/>
+          <a:lstStyle/>
+          <a:p>
+            <a:pPr algn="ctr"/>
+            <a:endParaRPr lang="de-DE"/>
+          </a:p>
+        </p:txBody>
+      </p:sp>
+      <p:sp>
+        <p:nvSpPr>
+          <p:cNvPr id="8" name="perspective-6">
+            <a:extLst>
+              <a:ext uri="{FF2B5EF4-FFF2-40B4-BE49-F238E27FC236}">
+                <a16:creationId xmlns:a16="http://schemas.microsoft.com/office/drawing/2014/main" id="{0B24BDCB-B900-C396-3FEB-79E43AEF9515}"/>
+              </a:ext>
+            </a:extLst>
+          </p:cNvPr>
+          <p:cNvSpPr/>
+          <p:nvPr/>
+        </p:nvSpPr>
+        <p:spPr>
+          <a:xfrm>
+            <a:off x="6604000" y="4318000"/>
+            <a:ext cx="1651000" cy="1270000"/>
+          </a:xfrm>
+          <a:prstGeom prst="rect">
+            <a:avLst/>
+          </a:prstGeom>
+          <a:solidFill>
+            <a:srgbClr val="4472C4"/>
+          </a:solidFill>
+          <a:ln w="19050" cap="flat" cmpd="sng" algn="ctr">
+            <a:noFill/>
+            <a:prstDash val="solid"/>
+            <a:miter lim="800000"/>
+          </a:ln>
+          <a:effectLst xmlns:a="http://schemas.openxmlformats.org/drawingml/2006/main">
+            <a:outerShdw blurRad="76200" dist="12700" dir="8100000" sy="-23000" kx="800400" algn="br">
+              <a:srgbClr val="000000">
+                <a:alpha val="50000"/>
+              </a:srgbClr>
+            </a:outerShdw>
+          </a:effectLst>
+          <a:extLst>
+            <a:ext uri="{91240B29-F687-4F45-9708-019B960494DF}">
+              <a14:hiddenLine xmlns:a14="http://schemas.microsoft.com/office/drawing/2010/main" w="19050" cap="flat" cmpd="sng" algn="ctr">
+                <a:solidFill>
+                  <a:schemeClr val="accent1">
+                    <a:shade val="15000"/>
+                  </a:schemeClr>
+                </a:solidFill>
+                <a:prstDash val="solid"/>
+                <a:miter lim="800000"/>
+              </a14:hiddenLine>
+            </a:ext>
+          </a:extLst>
+        </p:spPr>
+        <p:style>
+          <a:lnRef idx="2">
+            <a:schemeClr val="accent1">
+              <a:shade val="15000"/>
+            </a:schemeClr>
+          </a:lnRef>
+          <a:fillRef idx="1">
+            <a:schemeClr val="accent1"/>
+          </a:fillRef>
+          <a:effectRef idx="0">
+            <a:schemeClr val="accent1"/>
+          </a:effectRef>
+          <a:fontRef idx="minor">
+            <a:schemeClr val="lt1"/>
+          </a:fontRef>
+        </p:style>
+        <p:txBody>
+          <a:bodyPr rtlCol="0" anchor="ctr"/>
+          <a:lstStyle/>
+          <a:p>
+            <a:pPr algn="ctr"/>
+            <a:endParaRPr lang="de-DE"/>
+          </a:p>
+        </p:txBody>
+      </p:sp>
+      <p:sp>
+        <p:nvSpPr>
+          <p:cNvPr id="9" name="perspective-7">
+            <a:extLst>
+              <a:ext uri="{FF2B5EF4-FFF2-40B4-BE49-F238E27FC236}">
+                <a16:creationId xmlns:a16="http://schemas.microsoft.com/office/drawing/2014/main" id="{99EAEC51-9AE6-28DA-C920-01287B4EDB52}"/>
+              </a:ext>
+            </a:extLst>
+          </p:cNvPr>
+          <p:cNvSpPr/>
+          <p:nvPr/>
+        </p:nvSpPr>
+        <p:spPr>
+          <a:xfrm>
+            <a:off x="9525000" y="4318000"/>
+            <a:ext cx="1651000" cy="1270000"/>
+          </a:xfrm>
+          <a:prstGeom prst="rect">
+            <a:avLst/>
+          </a:prstGeom>
+          <a:solidFill>
+            <a:srgbClr val="4472C4"/>
+          </a:solidFill>
+          <a:ln w="19050" cap="flat" cmpd="sng" algn="ctr">
+            <a:noFill/>
+            <a:prstDash val="solid"/>
+            <a:miter lim="800000"/>
+          </a:ln>
+          <a:effectLst xmlns:a="http://schemas.openxmlformats.org/drawingml/2006/main">
+            <a:outerShdw blurRad="76200" dist="317500" dir="5400000" sx="90000" sy="-19000">
+              <a:srgbClr val="000000">
+                <a:alpha val="50000"/>
+              </a:srgbClr>
+            </a:outerShdw>
+          </a:effectLst>
+          <a:extLst>
+            <a:ext uri="{91240B29-F687-4F45-9708-019B960494DF}">
+              <a14:hiddenLine xmlns:a14="http://schemas.microsoft.com/office/drawing/2010/main" w="19050" cap="flat" cmpd="sng" algn="ctr">
+                <a:solidFill>
+                  <a:schemeClr val="accent1">
+                    <a:shade val="15000"/>
+                  </a:schemeClr>
+                </a:solidFill>
+                <a:prstDash val="solid"/>
+                <a:miter lim="800000"/>
+              </a14:hiddenLine>
+            </a:ext>
+          </a:extLst>
+        </p:spPr>
+        <p:style>
+          <a:lnRef idx="2">
+            <a:schemeClr val="accent1">
+              <a:shade val="15000"/>
+            </a:schemeClr>
+          </a:lnRef>
+          <a:fillRef idx="1">
+            <a:schemeClr val="accent1"/>
+          </a:fillRef>
+          <a:effectRef idx="0">
+            <a:schemeClr val="accent1"/>
+          </a:effectRef>
+          <a:fontRef idx="minor">
+            <a:schemeClr val="lt1"/>
+          </a:fontRef>
+        </p:style>
+        <p:txBody>
+          <a:bodyPr rtlCol="0" anchor="ctr"/>
+          <a:lstStyle/>
+          <a:p>
+            <a:pPr algn="ctr"/>
+            <a:endParaRPr lang="de-DE"/>
+          </a:p>
+        </p:txBody>
+      </p:sp>
+    </p:spTree>
+    <p:extLst>
+      <p:ext uri="{BB962C8B-B14F-4D97-AF65-F5344CB8AC3E}">
+        <p14:creationId xmlns:p14="http://schemas.microsoft.com/office/powerpoint/2010/main" val="3146653908"/>
+      </p:ext>
+    </p:extLst>
+  </p:cSld>
+  <p:clrMapOvr>
+    <a:masterClrMapping/>
+  </p:clrMapOvr>
+</p:sld>
+</file>
+
+<file path=ppt/slides/slide4.xml><?xml version="1.0" encoding="utf-8"?>
+<p:sld xmlns:a="http://schemas.openxmlformats.org/drawingml/2006/main" xmlns:r="http://schemas.openxmlformats.org/officeDocument/2006/relationships" xmlns:p="http://schemas.openxmlformats.org/presentationml/2006/main">
+  <p:cSld>
+    <p:spTree>
+      <p:nvGrpSpPr>
+        <p:cNvPr id="1" name=""/>
+        <p:cNvGrpSpPr/>
+        <p:nvPr/>
+      </p:nvGrpSpPr>
+      <p:grpSpPr>
+        <a:xfrm>
+          <a:off x="0" y="0"/>
+          <a:ext cx="0" cy="0"/>
+          <a:chOff x="0" y="0"/>
+          <a:chExt cx="0" cy="0"/>
+        </a:xfrm>
+      </p:grpSpPr>
+      <p:sp>
+        <p:nvSpPr>
+          <p:cNvPr id="2" name="turned-0">
+            <a:extLst>
+              <a:ext uri="{FF2B5EF4-FFF2-40B4-BE49-F238E27FC236}">
+                <a16:creationId xmlns:a16="http://schemas.microsoft.com/office/drawing/2014/main" id="{0EA5DEC4-0EED-8E42-A95D-1DF0FA17945E}"/>
+              </a:ext>
+            </a:extLst>
+          </p:cNvPr>
+          <p:cNvSpPr/>
+          <p:nvPr/>
+        </p:nvSpPr>
+        <p:spPr>
+          <a:xfrm rot="1800000">
+            <a:off x="762000" y="1016000"/>
+            <a:ext cx="1651000" cy="1270000"/>
+          </a:xfrm>
+          <a:prstGeom prst="rect">
+            <a:avLst/>
+          </a:prstGeom>
+          <a:solidFill>
+            <a:srgbClr val="4472C4"/>
+          </a:solidFill>
+          <a:ln w="19050" cap="flat" cmpd="sng" algn="ctr">
+            <a:noFill/>
+            <a:prstDash val="solid"/>
+            <a:miter lim="800000"/>
+          </a:ln>
+          <a:effectLst xmlns:a="http://schemas.openxmlformats.org/drawingml/2006/main">
+            <a:outerShdw dist="190500" dir="2700000" rotWithShape="0">
+              <a:srgbClr val="000000">
+                <a:alpha val="50000"/>
+              </a:srgbClr>
+            </a:outerShdw>
+          </a:effectLst>
+          <a:extLst>
+            <a:ext uri="{91240B29-F687-4F45-9708-019B960494DF}">
+              <a14:hiddenLine xmlns:a14="http://schemas.microsoft.com/office/drawing/2010/main" w="19050" cap="flat" cmpd="sng" algn="ctr">
+                <a:solidFill>
+                  <a:schemeClr val="accent1">
+                    <a:shade val="15000"/>
+                  </a:schemeClr>
+                </a:solidFill>
+                <a:prstDash val="solid"/>
+                <a:miter lim="800000"/>
+              </a14:hiddenLine>
+            </a:ext>
+          </a:extLst>
+        </p:spPr>
+        <p:style>
+          <a:lnRef idx="2">
+            <a:schemeClr val="accent1">
+              <a:shade val="15000"/>
+            </a:schemeClr>
+          </a:lnRef>
+          <a:fillRef idx="1">
+            <a:schemeClr val="accent1"/>
+          </a:fillRef>
+          <a:effectRef idx="0">
+            <a:schemeClr val="accent1"/>
+          </a:effectRef>
+          <a:fontRef idx="minor">
+            <a:schemeClr val="lt1"/>
+          </a:fontRef>
+        </p:style>
+        <p:txBody>
+          <a:bodyPr rtlCol="0" anchor="ctr"/>
+          <a:lstStyle/>
+          <a:p>
+            <a:pPr algn="ctr"/>
+            <a:endParaRPr lang="de-DE"/>
+          </a:p>
+        </p:txBody>
+      </p:sp>
+      <p:sp>
+        <p:nvSpPr>
+          <p:cNvPr id="3" name="turned-1">
+            <a:extLst>
+              <a:ext uri="{FF2B5EF4-FFF2-40B4-BE49-F238E27FC236}">
+                <a16:creationId xmlns:a16="http://schemas.microsoft.com/office/drawing/2014/main" id="{439F2E9E-D1C8-601D-5B61-4A2BA56D7431}"/>
+              </a:ext>
+            </a:extLst>
+          </p:cNvPr>
+          <p:cNvSpPr/>
+          <p:nvPr/>
+        </p:nvSpPr>
+        <p:spPr>
+          <a:xfrm rot="5400000">
+            <a:off x="3683000" y="1016000"/>
+            <a:ext cx="1651000" cy="1270000"/>
+          </a:xfrm>
+          <a:prstGeom prst="rect">
+            <a:avLst/>
+          </a:prstGeom>
+          <a:solidFill>
+            <a:srgbClr val="4472C4"/>
+          </a:solidFill>
+          <a:ln w="19050" cap="flat" cmpd="sng" algn="ctr">
+            <a:noFill/>
+            <a:prstDash val="solid"/>
+            <a:miter lim="800000"/>
+          </a:ln>
+          <a:effectLst xmlns:a="http://schemas.openxmlformats.org/drawingml/2006/main">
+            <a:outerShdw dist="190500" dir="2700000" rotWithShape="0">
+              <a:srgbClr val="000000">
+                <a:alpha val="50000"/>
+              </a:srgbClr>
+            </a:outerShdw>
+          </a:effectLst>
+          <a:extLst>
+            <a:ext uri="{91240B29-F687-4F45-9708-019B960494DF}">
+              <a14:hiddenLine xmlns:a14="http://schemas.microsoft.com/office/drawing/2010/main" w="19050" cap="flat" cmpd="sng" algn="ctr">
+                <a:solidFill>
+                  <a:schemeClr val="accent1">
+                    <a:shade val="15000"/>
+                  </a:schemeClr>
+                </a:solidFill>
+                <a:prstDash val="solid"/>
+                <a:miter lim="800000"/>
+              </a14:hiddenLine>
+            </a:ext>
+          </a:extLst>
+        </p:spPr>
+        <p:style>
+          <a:lnRef idx="2">
+            <a:schemeClr val="accent1">
+              <a:shade val="15000"/>
+            </a:schemeClr>
+          </a:lnRef>
+          <a:fillRef idx="1">
+            <a:schemeClr val="accent1"/>
+          </a:fillRef>
+          <a:effectRef idx="0">
+            <a:schemeClr val="accent1"/>
+          </a:effectRef>
+          <a:fontRef idx="minor">
+            <a:schemeClr val="lt1"/>
+          </a:fontRef>
+        </p:style>
+        <p:txBody>
+          <a:bodyPr rtlCol="0" anchor="ctr"/>
+          <a:lstStyle/>
+          <a:p>
+            <a:pPr algn="ctr"/>
+            <a:endParaRPr lang="de-DE"/>
+          </a:p>
+        </p:txBody>
+      </p:sp>
+      <p:sp>
+        <p:nvSpPr>
+          <p:cNvPr id="4" name="turned-2">
+            <a:extLst>
+              <a:ext uri="{FF2B5EF4-FFF2-40B4-BE49-F238E27FC236}">
+                <a16:creationId xmlns:a16="http://schemas.microsoft.com/office/drawing/2014/main" id="{45095E88-1B56-148C-906B-59760DCA2136}"/>
+              </a:ext>
+            </a:extLst>
+          </p:cNvPr>
+          <p:cNvSpPr/>
+          <p:nvPr/>
+        </p:nvSpPr>
+        <p:spPr>
+          <a:xfrm rot="1800000">
+            <a:off x="6604000" y="1016000"/>
+            <a:ext cx="1651000" cy="1270000"/>
+          </a:xfrm>
+          <a:prstGeom prst="rect">
+            <a:avLst/>
+          </a:prstGeom>
+          <a:solidFill>
+            <a:srgbClr val="4472C4"/>
+          </a:solidFill>
+          <a:ln w="19050" cap="flat" cmpd="sng" algn="ctr">
+            <a:noFill/>
+            <a:prstDash val="solid"/>
+            <a:miter lim="800000"/>
+          </a:ln>
+          <a:effectLst xmlns:a="http://schemas.openxmlformats.org/drawingml/2006/main">
+            <a:outerShdw dist="190500" dir="2700000" rotWithShape="1">
+              <a:srgbClr val="000000">
+                <a:alpha val="50000"/>
+              </a:srgbClr>
+            </a:outerShdw>
+          </a:effectLst>
+          <a:extLst>
+            <a:ext uri="{91240B29-F687-4F45-9708-019B960494DF}">
+              <a14:hiddenLine xmlns:a14="http://schemas.microsoft.com/office/drawing/2010/main" w="19050" cap="flat" cmpd="sng" algn="ctr">
+                <a:solidFill>
+                  <a:schemeClr val="accent1">
+                    <a:shade val="15000"/>
+                  </a:schemeClr>
+                </a:solidFill>
+                <a:prstDash val="solid"/>
+                <a:miter lim="800000"/>
+              </a14:hiddenLine>
+            </a:ext>
+          </a:extLst>
+        </p:spPr>
+        <p:style>
+          <a:lnRef idx="2">
+            <a:schemeClr val="accent1">
+              <a:shade val="15000"/>
+            </a:schemeClr>
+          </a:lnRef>
+          <a:fillRef idx="1">
+            <a:schemeClr val="accent1"/>
+          </a:fillRef>
+          <a:effectRef idx="0">
+            <a:schemeClr val="accent1"/>
+          </a:effectRef>
+          <a:fontRef idx="minor">
+            <a:schemeClr val="lt1"/>
+          </a:fontRef>
+        </p:style>
+        <p:txBody>
+          <a:bodyPr rtlCol="0" anchor="ctr"/>
+          <a:lstStyle/>
+          <a:p>
+            <a:pPr algn="ctr"/>
+            <a:endParaRPr lang="de-DE"/>
+          </a:p>
+        </p:txBody>
+      </p:sp>
+      <p:sp>
+        <p:nvSpPr>
+          <p:cNvPr id="5" name="turned-3">
+            <a:extLst>
+              <a:ext uri="{FF2B5EF4-FFF2-40B4-BE49-F238E27FC236}">
+                <a16:creationId xmlns:a16="http://schemas.microsoft.com/office/drawing/2014/main" id="{DA543B73-9AB1-11D1-0328-22FF4EF3D093}"/>
+              </a:ext>
+            </a:extLst>
+          </p:cNvPr>
+          <p:cNvSpPr/>
+          <p:nvPr/>
+        </p:nvSpPr>
+        <p:spPr>
+          <a:xfrm rot="5400000">
+            <a:off x="9525000" y="1016000"/>
+            <a:ext cx="1651000" cy="1270000"/>
+          </a:xfrm>
+          <a:prstGeom prst="rect">
+            <a:avLst/>
+          </a:prstGeom>
+          <a:solidFill>
+            <a:srgbClr val="4472C4"/>
+          </a:solidFill>
+          <a:ln w="19050" cap="flat" cmpd="sng" algn="ctr">
+            <a:noFill/>
+            <a:prstDash val="solid"/>
+            <a:miter lim="800000"/>
+          </a:ln>
+          <a:effectLst xmlns:a="http://schemas.openxmlformats.org/drawingml/2006/main">
+            <a:outerShdw dist="190500" dir="2700000" rotWithShape="1">
+              <a:srgbClr val="000000">
+                <a:alpha val="50000"/>
+              </a:srgbClr>
+            </a:outerShdw>
+          </a:effectLst>
+          <a:extLst>
+            <a:ext uri="{91240B29-F687-4F45-9708-019B960494DF}">
+              <a14:hiddenLine xmlns:a14="http://schemas.microsoft.com/office/drawing/2010/main" w="19050" cap="flat" cmpd="sng" algn="ctr">
+                <a:solidFill>
+                  <a:schemeClr val="accent1">
+                    <a:shade val="15000"/>
+                  </a:schemeClr>
+                </a:solidFill>
+                <a:prstDash val="solid"/>
+                <a:miter lim="800000"/>
+              </a14:hiddenLine>
+            </a:ext>
+          </a:extLst>
+        </p:spPr>
+        <p:style>
+          <a:lnRef idx="2">
+            <a:schemeClr val="accent1">
+              <a:shade val="15000"/>
+            </a:schemeClr>
+          </a:lnRef>
+          <a:fillRef idx="1">
+            <a:schemeClr val="accent1"/>
+          </a:fillRef>
+          <a:effectRef idx="0">
+            <a:schemeClr val="accent1"/>
+          </a:effectRef>
+          <a:fontRef idx="minor">
+            <a:schemeClr val="lt1"/>
+          </a:fontRef>
+        </p:style>
+        <p:txBody>
+          <a:bodyPr rtlCol="0" anchor="ctr"/>
+          <a:lstStyle/>
+          <a:p>
+            <a:pPr algn="ctr"/>
+            <a:endParaRPr lang="de-DE"/>
+          </a:p>
+        </p:txBody>
+      </p:sp>
+      <p:sp>
+        <p:nvSpPr>
+          <p:cNvPr id="6" name="turned-4">
+            <a:extLst>
+              <a:ext uri="{FF2B5EF4-FFF2-40B4-BE49-F238E27FC236}">
+                <a16:creationId xmlns:a16="http://schemas.microsoft.com/office/drawing/2014/main" id="{F6B42B56-767F-0E62-237B-BDA94D4A6389}"/>
+              </a:ext>
+            </a:extLst>
+          </p:cNvPr>
+          <p:cNvSpPr/>
+          <p:nvPr/>
+        </p:nvSpPr>
+        <p:spPr>
+          <a:xfrm rot="1800000">
+            <a:off x="762000" y="4318000"/>
+            <a:ext cx="1651000" cy="1270000"/>
+          </a:xfrm>
+          <a:prstGeom prst="rect">
+            <a:avLst/>
+          </a:prstGeom>
+          <a:solidFill>
+            <a:srgbClr val="4472C4"/>
+          </a:solidFill>
+          <a:ln w="19050" cap="flat" cmpd="sng" algn="ctr">
+            <a:noFill/>
+            <a:prstDash val="solid"/>
+            <a:miter lim="800000"/>
+          </a:ln>
+          <a:effectLst xmlns:a="http://schemas.openxmlformats.org/drawingml/2006/main">
+            <a:outerShdw dist="12700" dir="8100000" sy="-23000" kx="800400" algn="br" rotWithShape="0">
+              <a:srgbClr val="000000">
+                <a:alpha val="50000"/>
+              </a:srgbClr>
+            </a:outerShdw>
+          </a:effectLst>
+          <a:extLst>
+            <a:ext uri="{91240B29-F687-4F45-9708-019B960494DF}">
+              <a14:hiddenLine xmlns:a14="http://schemas.microsoft.com/office/drawing/2010/main" w="19050" cap="flat" cmpd="sng" algn="ctr">
+                <a:solidFill>
+                  <a:schemeClr val="accent1">
+                    <a:shade val="15000"/>
+                  </a:schemeClr>
+                </a:solidFill>
+                <a:prstDash val="solid"/>
+                <a:miter lim="800000"/>
+              </a14:hiddenLine>
+            </a:ext>
+          </a:extLst>
+        </p:spPr>
+        <p:style>
+          <a:lnRef idx="2">
+            <a:schemeClr val="accent1">
+              <a:shade val="15000"/>
+            </a:schemeClr>
+          </a:lnRef>
+          <a:fillRef idx="1">
+            <a:schemeClr val="accent1"/>
+          </a:fillRef>
+          <a:effectRef idx="0">
+            <a:schemeClr val="accent1"/>
+          </a:effectRef>
+          <a:fontRef idx="minor">
+            <a:schemeClr val="lt1"/>
+          </a:fontRef>
+        </p:style>
+        <p:txBody>
+          <a:bodyPr rtlCol="0" anchor="ctr"/>
+          <a:lstStyle/>
+          <a:p>
+            <a:pPr algn="ctr"/>
+            <a:endParaRPr lang="de-DE"/>
+          </a:p>
+        </p:txBody>
+      </p:sp>
+      <p:sp>
+        <p:nvSpPr>
+          <p:cNvPr id="7" name="turned-5">
+            <a:extLst>
+              <a:ext uri="{FF2B5EF4-FFF2-40B4-BE49-F238E27FC236}">
+                <a16:creationId xmlns:a16="http://schemas.microsoft.com/office/drawing/2014/main" id="{4D693258-FAA2-46AF-2689-61A1D3919947}"/>
+              </a:ext>
+            </a:extLst>
+          </p:cNvPr>
+          <p:cNvSpPr/>
+          <p:nvPr/>
+        </p:nvSpPr>
+        <p:spPr>
+          <a:xfrm flipH="1">
+            <a:off x="3683000" y="4318000"/>
+            <a:ext cx="1651000" cy="1270000"/>
+          </a:xfrm>
+          <a:prstGeom prst="rect">
+            <a:avLst/>
+          </a:prstGeom>
+          <a:solidFill>
+            <a:srgbClr val="4472C4"/>
+          </a:solidFill>
+          <a:ln w="19050" cap="flat" cmpd="sng" algn="ctr">
+            <a:noFill/>
+            <a:prstDash val="solid"/>
+            <a:miter lim="800000"/>
+          </a:ln>
+          <a:effectLst xmlns:a="http://schemas.openxmlformats.org/drawingml/2006/main">
+            <a:outerShdw dist="190500" dir="2700000" rotWithShape="0">
+              <a:srgbClr val="000000">
+                <a:alpha val="50000"/>
+              </a:srgbClr>
+            </a:outerShdw>
+          </a:effectLst>
+          <a:extLst>
+            <a:ext uri="{91240B29-F687-4F45-9708-019B960494DF}">
+              <a14:hiddenLine xmlns:a14="http://schemas.microsoft.com/office/drawing/2010/main" w="19050" cap="flat" cmpd="sng" algn="ctr">
+                <a:solidFill>
+                  <a:schemeClr val="accent1">
+                    <a:shade val="15000"/>
+                  </a:schemeClr>
+                </a:solidFill>
+                <a:prstDash val="solid"/>
+                <a:miter lim="800000"/>
+              </a14:hiddenLine>
+            </a:ext>
+          </a:extLst>
+        </p:spPr>
+        <p:style>
+          <a:lnRef idx="2">
+            <a:schemeClr val="accent1">
+              <a:shade val="15000"/>
+            </a:schemeClr>
+          </a:lnRef>
+          <a:fillRef idx="1">
+            <a:schemeClr val="accent1"/>
+          </a:fillRef>
+          <a:effectRef idx="0">
+            <a:schemeClr val="accent1"/>
+          </a:effectRef>
+          <a:fontRef idx="minor">
+            <a:schemeClr val="lt1"/>
+          </a:fontRef>
+        </p:style>
+        <p:txBody>
+          <a:bodyPr rtlCol="0" anchor="ctr"/>
+          <a:lstStyle/>
+          <a:p>
+            <a:pPr algn="ctr"/>
+            <a:endParaRPr lang="de-DE"/>
+          </a:p>
+        </p:txBody>
+      </p:sp>
+      <p:sp>
+        <p:nvSpPr>
+          <p:cNvPr id="8" name="turned-6">
+            <a:extLst>
+              <a:ext uri="{FF2B5EF4-FFF2-40B4-BE49-F238E27FC236}">
+                <a16:creationId xmlns:a16="http://schemas.microsoft.com/office/drawing/2014/main" id="{1CDB972F-65D1-C236-A394-20F361D3E2F8}"/>
+              </a:ext>
+            </a:extLst>
+          </p:cNvPr>
+          <p:cNvSpPr/>
+          <p:nvPr/>
+        </p:nvSpPr>
+        <p:spPr>
+          <a:xfrm rot="12000000">
+            <a:off x="6604000" y="4318000"/>
+            <a:ext cx="1651000" cy="1270000"/>
+          </a:xfrm>
+          <a:prstGeom prst="rect">
+            <a:avLst/>
+          </a:prstGeom>
+          <a:solidFill>
+            <a:srgbClr val="4472C4"/>
+          </a:solidFill>
+          <a:ln w="19050" cap="flat" cmpd="sng" algn="ctr">
+            <a:noFill/>
+            <a:prstDash val="solid"/>
+            <a:miter lim="800000"/>
+          </a:ln>
+          <a:effectLst xmlns:a="http://schemas.openxmlformats.org/drawingml/2006/main">
+            <a:outerShdw dist="190500" dir="2700000" rotWithShape="0">
+              <a:srgbClr val="000000">
+                <a:alpha val="50000"/>
+              </a:srgbClr>
+            </a:outerShdw>
+          </a:effectLst>
+          <a:extLst>
+            <a:ext uri="{91240B29-F687-4F45-9708-019B960494DF}">
+              <a14:hiddenLine xmlns:a14="http://schemas.microsoft.com/office/drawing/2010/main" w="19050" cap="flat" cmpd="sng" algn="ctr">
+                <a:solidFill>
+                  <a:schemeClr val="accent1">
+                    <a:shade val="15000"/>
+                  </a:schemeClr>
+                </a:solidFill>
+                <a:prstDash val="solid"/>
+                <a:miter lim="800000"/>
+              </a14:hiddenLine>
+            </a:ext>
+          </a:extLst>
+        </p:spPr>
+        <p:style>
+          <a:lnRef idx="2">
+            <a:schemeClr val="accent1">
+              <a:shade val="15000"/>
+            </a:schemeClr>
+          </a:lnRef>
+          <a:fillRef idx="1">
+            <a:schemeClr val="accent1"/>
+          </a:fillRef>
+          <a:effectRef idx="0">
+            <a:schemeClr val="accent1"/>
+          </a:effectRef>
+          <a:fontRef idx="minor">
+            <a:schemeClr val="lt1"/>
+          </a:fontRef>
+        </p:style>
+        <p:txBody>
+          <a:bodyPr rtlCol="0" anchor="ctr"/>
+          <a:lstStyle/>
+          <a:p>
+            <a:pPr algn="ctr"/>
+            <a:endParaRPr lang="de-DE"/>
+          </a:p>
+        </p:txBody>
+      </p:sp>
+      <p:sp>
+        <p:nvSpPr>
+          <p:cNvPr id="9" name="turned-7">
+            <a:extLst>
+              <a:ext uri="{FF2B5EF4-FFF2-40B4-BE49-F238E27FC236}">
+                <a16:creationId xmlns:a16="http://schemas.microsoft.com/office/drawing/2014/main" id="{C523081F-AC63-7F65-F484-9D842B79568C}"/>
+              </a:ext>
+            </a:extLst>
+          </p:cNvPr>
+          <p:cNvSpPr/>
+          <p:nvPr/>
+        </p:nvSpPr>
+        <p:spPr>
+          <a:xfrm rot="1800000">
+            <a:off x="9525000" y="4318000"/>
+            <a:ext cx="1651000" cy="1270000"/>
+          </a:xfrm>
+          <a:prstGeom prst="rect">
+            <a:avLst/>
+          </a:prstGeom>
+          <a:solidFill>
+            <a:srgbClr val="4472C4"/>
+          </a:solidFill>
+          <a:ln w="19050" cap="flat" cmpd="sng" algn="ctr">
+            <a:noFill/>
+            <a:prstDash val="solid"/>
+            <a:miter lim="800000"/>
+          </a:ln>
+          <a:effectLst xmlns:a="http://schemas.openxmlformats.org/drawingml/2006/main">
+            <a:outerShdw dist="12700" dir="8100000" sy="-23000" kx="800400" algn="br" rotWithShape="1">
+              <a:srgbClr val="000000">
+                <a:alpha val="50000"/>
+              </a:srgbClr>
+            </a:outerShdw>
+          </a:effectLst>
+          <a:extLst>
+            <a:ext uri="{91240B29-F687-4F45-9708-019B960494DF}">
+              <a14:hiddenLine xmlns:a14="http://schemas.microsoft.com/office/drawing/2010/main" w="19050" cap="flat" cmpd="sng" algn="ctr">
+                <a:solidFill>
+                  <a:schemeClr val="accent1">
+                    <a:shade val="15000"/>
+                  </a:schemeClr>
+                </a:solidFill>
+                <a:prstDash val="solid"/>
+                <a:miter lim="800000"/>
+              </a14:hiddenLine>
+            </a:ext>
+          </a:extLst>
+        </p:spPr>
+        <p:style>
+          <a:lnRef idx="2">
+            <a:schemeClr val="accent1">
+              <a:shade val="15000"/>
+            </a:schemeClr>
+          </a:lnRef>
+          <a:fillRef idx="1">
+            <a:schemeClr val="accent1"/>
+          </a:fillRef>
+          <a:effectRef idx="0">
+            <a:schemeClr val="accent1"/>
+          </a:effectRef>
+          <a:fontRef idx="minor">
+            <a:schemeClr val="lt1"/>
+          </a:fontRef>
+        </p:style>
+        <p:txBody>
+          <a:bodyPr rtlCol="0" anchor="ctr"/>
+          <a:lstStyle/>
+          <a:p>
+            <a:pPr algn="ctr"/>
+            <a:endParaRPr lang="de-DE"/>
+          </a:p>
+        </p:txBody>
+      </p:sp>
+    </p:spTree>
+    <p:extLst>
+      <p:ext uri="{BB962C8B-B14F-4D97-AF65-F5344CB8AC3E}">
+        <p14:creationId xmlns:p14="http://schemas.microsoft.com/office/powerpoint/2010/main" val="2821036149"/>
       </p:ext>
     </p:extLst>
   </p:cSld>

</xml_diff>

<commit_message>
Reflections: skew, fade direction, still reflections of turned shapes; picture details
Shadows and reflections scale and skew with independent skew terms (measured with
flipped copies). Reflections fade along fadeDir in the copy's frame and keep still
on the slide with rotWithShape 0. clrChange honors useA; PowerPoint ignores
blipFill dpi for tiles (measured).

Co-Authored-By: Claude Opus 5.5 <noreply@anthropic.com>
</commit_message>
<xml_diff>
--- a/tests/corpus/pptx/generated/effects.pptx
+++ b/tests/corpus/pptx/generated/effects.pptx
@@ -9,6 +9,7 @@
     <p:sldId id="257" r:id="rId3"/>
     <p:sldId id="258" r:id="rId4"/>
     <p:sldId id="259" r:id="rId5"/>
+    <p:sldId id="260" r:id="rId6"/>
   </p:sldIdLst>
   <p:sldSz cx="12192000" cy="6858000"/>
   <p:notesSz cx="6858000" cy="9144000"/>
@@ -132,7 +133,7 @@
           <p:cNvPr id="2" name="Titel 1">
             <a:extLst>
               <a:ext uri="{FF2B5EF4-FFF2-40B4-BE49-F238E27FC236}">
-                <a16:creationId xmlns:a16="http://schemas.microsoft.com/office/drawing/2014/main" id="{0A7199FF-1A45-EB29-A0BC-0EA369265080}"/>
+                <a16:creationId xmlns:a16="http://schemas.microsoft.com/office/drawing/2014/main" id="{8BEB1A70-84E6-6026-2A15-5BBB2240BB7A}"/>
               </a:ext>
             </a:extLst>
           </p:cNvPr>
@@ -169,7 +170,7 @@
           <p:cNvPr id="3" name="Untertitel 2">
             <a:extLst>
               <a:ext uri="{FF2B5EF4-FFF2-40B4-BE49-F238E27FC236}">
-                <a16:creationId xmlns:a16="http://schemas.microsoft.com/office/drawing/2014/main" id="{635552F4-D857-C88F-B9B6-839C18DAECCC}"/>
+                <a16:creationId xmlns:a16="http://schemas.microsoft.com/office/drawing/2014/main" id="{E9A8AC4B-4EDE-8E9A-49F4-25AFCB6F0480}"/>
               </a:ext>
             </a:extLst>
           </p:cNvPr>
@@ -239,7 +240,7 @@
           <p:cNvPr id="4" name="Datumsplatzhalter 3">
             <a:extLst>
               <a:ext uri="{FF2B5EF4-FFF2-40B4-BE49-F238E27FC236}">
-                <a16:creationId xmlns:a16="http://schemas.microsoft.com/office/drawing/2014/main" id="{95999C38-F840-427D-78D0-4D9FA453A46E}"/>
+                <a16:creationId xmlns:a16="http://schemas.microsoft.com/office/drawing/2014/main" id="{BC5AA442-8D19-4B5D-D498-2F00885A9997}"/>
               </a:ext>
             </a:extLst>
           </p:cNvPr>
@@ -255,7 +256,7 @@
           <a:bodyPr/>
           <a:lstStyle/>
           <a:p>
-            <a:fld id="{5A1AF197-8666-45A1-A9DD-65DA68AEA0EB}" type="datetimeFigureOut">
+            <a:fld id="{B2B075A0-D846-4290-88CC-C140D1C58584}" type="datetimeFigureOut">
               <a:rPr lang="de-DE" smtClean="0"/>
               <a:t>08.10.2026</a:t>
             </a:fld>
@@ -268,7 +269,7 @@
           <p:cNvPr id="5" name="Fußzeilenplatzhalter 4">
             <a:extLst>
               <a:ext uri="{FF2B5EF4-FFF2-40B4-BE49-F238E27FC236}">
-                <a16:creationId xmlns:a16="http://schemas.microsoft.com/office/drawing/2014/main" id="{09DA14AC-79FD-C1B9-6E65-4EF3646A7740}"/>
+                <a16:creationId xmlns:a16="http://schemas.microsoft.com/office/drawing/2014/main" id="{50674454-EC0C-68DC-E077-151B50527042}"/>
               </a:ext>
             </a:extLst>
           </p:cNvPr>
@@ -293,7 +294,7 @@
           <p:cNvPr id="6" name="Foliennummernplatzhalter 5">
             <a:extLst>
               <a:ext uri="{FF2B5EF4-FFF2-40B4-BE49-F238E27FC236}">
-                <a16:creationId xmlns:a16="http://schemas.microsoft.com/office/drawing/2014/main" id="{4D73CA68-EBAD-AC26-0814-CC06634918CC}"/>
+                <a16:creationId xmlns:a16="http://schemas.microsoft.com/office/drawing/2014/main" id="{D35CE148-0999-1885-164E-084F26064FB6}"/>
               </a:ext>
             </a:extLst>
           </p:cNvPr>
@@ -309,7 +310,7 @@
           <a:bodyPr/>
           <a:lstStyle/>
           <a:p>
-            <a:fld id="{FD7A2B11-542E-4CA3-8CAD-ADBF93301D0C}" type="slidenum">
+            <a:fld id="{56A1CD77-F38E-452D-AE70-F639BBE63637}" type="slidenum">
               <a:rPr lang="de-DE" smtClean="0"/>
               <a:t>‹Nr.›</a:t>
             </a:fld>
@@ -320,7 +321,7 @@
     </p:spTree>
     <p:extLst>
       <p:ext uri="{BB962C8B-B14F-4D97-AF65-F5344CB8AC3E}">
-        <p14:creationId xmlns:p14="http://schemas.microsoft.com/office/powerpoint/2010/main" val="1518090723"/>
+        <p14:creationId xmlns:p14="http://schemas.microsoft.com/office/powerpoint/2010/main" val="278253278"/>
       </p:ext>
     </p:extLst>
   </p:cSld>
@@ -352,7 +353,7 @@
           <p:cNvPr id="2" name="Titel 1">
             <a:extLst>
               <a:ext uri="{FF2B5EF4-FFF2-40B4-BE49-F238E27FC236}">
-                <a16:creationId xmlns:a16="http://schemas.microsoft.com/office/drawing/2014/main" id="{C2D471B9-DACF-73F3-4910-A236AC245575}"/>
+                <a16:creationId xmlns:a16="http://schemas.microsoft.com/office/drawing/2014/main" id="{E4C3E5E1-A00B-5E36-D19E-FF4719EE7754}"/>
               </a:ext>
             </a:extLst>
           </p:cNvPr>
@@ -380,7 +381,7 @@
           <p:cNvPr id="3" name="Vertikaler Textplatzhalter 2">
             <a:extLst>
               <a:ext uri="{FF2B5EF4-FFF2-40B4-BE49-F238E27FC236}">
-                <a16:creationId xmlns:a16="http://schemas.microsoft.com/office/drawing/2014/main" id="{951D566B-99B9-9C48-292E-2E1A7FD6694F}"/>
+                <a16:creationId xmlns:a16="http://schemas.microsoft.com/office/drawing/2014/main" id="{CC5BB5E4-7845-F138-9CC2-427D433E2935}"/>
               </a:ext>
             </a:extLst>
           </p:cNvPr>
@@ -437,7 +438,7 @@
           <p:cNvPr id="4" name="Datumsplatzhalter 3">
             <a:extLst>
               <a:ext uri="{FF2B5EF4-FFF2-40B4-BE49-F238E27FC236}">
-                <a16:creationId xmlns:a16="http://schemas.microsoft.com/office/drawing/2014/main" id="{5E2A96C1-E8E7-57C9-9F4B-7B979C3FFDD4}"/>
+                <a16:creationId xmlns:a16="http://schemas.microsoft.com/office/drawing/2014/main" id="{E07879E2-F826-7EBE-579B-0186D7BB00B1}"/>
               </a:ext>
             </a:extLst>
           </p:cNvPr>
@@ -453,7 +454,7 @@
           <a:bodyPr/>
           <a:lstStyle/>
           <a:p>
-            <a:fld id="{5A1AF197-8666-45A1-A9DD-65DA68AEA0EB}" type="datetimeFigureOut">
+            <a:fld id="{B2B075A0-D846-4290-88CC-C140D1C58584}" type="datetimeFigureOut">
               <a:rPr lang="de-DE" smtClean="0"/>
               <a:t>08.10.2026</a:t>
             </a:fld>
@@ -466,7 +467,7 @@
           <p:cNvPr id="5" name="Fußzeilenplatzhalter 4">
             <a:extLst>
               <a:ext uri="{FF2B5EF4-FFF2-40B4-BE49-F238E27FC236}">
-                <a16:creationId xmlns:a16="http://schemas.microsoft.com/office/drawing/2014/main" id="{26E1B800-A5C4-1EF5-CF70-A1C1DF6ADAFD}"/>
+                <a16:creationId xmlns:a16="http://schemas.microsoft.com/office/drawing/2014/main" id="{B5E0305B-D00A-A422-81C3-4318549D7737}"/>
               </a:ext>
             </a:extLst>
           </p:cNvPr>
@@ -491,7 +492,7 @@
           <p:cNvPr id="6" name="Foliennummernplatzhalter 5">
             <a:extLst>
               <a:ext uri="{FF2B5EF4-FFF2-40B4-BE49-F238E27FC236}">
-                <a16:creationId xmlns:a16="http://schemas.microsoft.com/office/drawing/2014/main" id="{4C33FB90-B6C9-FCFE-BB89-6D2C34CCCC09}"/>
+                <a16:creationId xmlns:a16="http://schemas.microsoft.com/office/drawing/2014/main" id="{435C540F-9CBA-2FA1-722F-81334D497F07}"/>
               </a:ext>
             </a:extLst>
           </p:cNvPr>
@@ -507,7 +508,7 @@
           <a:bodyPr/>
           <a:lstStyle/>
           <a:p>
-            <a:fld id="{FD7A2B11-542E-4CA3-8CAD-ADBF93301D0C}" type="slidenum">
+            <a:fld id="{56A1CD77-F38E-452D-AE70-F639BBE63637}" type="slidenum">
               <a:rPr lang="de-DE" smtClean="0"/>
               <a:t>‹Nr.›</a:t>
             </a:fld>
@@ -518,7 +519,7 @@
     </p:spTree>
     <p:extLst>
       <p:ext uri="{BB962C8B-B14F-4D97-AF65-F5344CB8AC3E}">
-        <p14:creationId xmlns:p14="http://schemas.microsoft.com/office/powerpoint/2010/main" val="3911492640"/>
+        <p14:creationId xmlns:p14="http://schemas.microsoft.com/office/powerpoint/2010/main" val="2557100837"/>
       </p:ext>
     </p:extLst>
   </p:cSld>
@@ -550,7 +551,7 @@
           <p:cNvPr id="2" name="Vertikaler Titel 1">
             <a:extLst>
               <a:ext uri="{FF2B5EF4-FFF2-40B4-BE49-F238E27FC236}">
-                <a16:creationId xmlns:a16="http://schemas.microsoft.com/office/drawing/2014/main" id="{FA0F1A3C-1479-6884-1416-B0A0961B3680}"/>
+                <a16:creationId xmlns:a16="http://schemas.microsoft.com/office/drawing/2014/main" id="{26A55FD1-F958-65C4-BF8E-DCC26EC2FF04}"/>
               </a:ext>
             </a:extLst>
           </p:cNvPr>
@@ -583,7 +584,7 @@
           <p:cNvPr id="3" name="Vertikaler Textplatzhalter 2">
             <a:extLst>
               <a:ext uri="{FF2B5EF4-FFF2-40B4-BE49-F238E27FC236}">
-                <a16:creationId xmlns:a16="http://schemas.microsoft.com/office/drawing/2014/main" id="{B77E2EDB-B08E-4A97-ABCA-81778AB8F83B}"/>
+                <a16:creationId xmlns:a16="http://schemas.microsoft.com/office/drawing/2014/main" id="{E6FB4F81-9B13-0373-7C3B-5B3641B204FD}"/>
               </a:ext>
             </a:extLst>
           </p:cNvPr>
@@ -645,7 +646,7 @@
           <p:cNvPr id="4" name="Datumsplatzhalter 3">
             <a:extLst>
               <a:ext uri="{FF2B5EF4-FFF2-40B4-BE49-F238E27FC236}">
-                <a16:creationId xmlns:a16="http://schemas.microsoft.com/office/drawing/2014/main" id="{F7278748-A8E4-B974-554A-4B8390B89CD0}"/>
+                <a16:creationId xmlns:a16="http://schemas.microsoft.com/office/drawing/2014/main" id="{CE65AB08-1927-FA3A-275D-7532CC89E5B1}"/>
               </a:ext>
             </a:extLst>
           </p:cNvPr>
@@ -661,7 +662,7 @@
           <a:bodyPr/>
           <a:lstStyle/>
           <a:p>
-            <a:fld id="{5A1AF197-8666-45A1-A9DD-65DA68AEA0EB}" type="datetimeFigureOut">
+            <a:fld id="{B2B075A0-D846-4290-88CC-C140D1C58584}" type="datetimeFigureOut">
               <a:rPr lang="de-DE" smtClean="0"/>
               <a:t>08.10.2026</a:t>
             </a:fld>
@@ -674,7 +675,7 @@
           <p:cNvPr id="5" name="Fußzeilenplatzhalter 4">
             <a:extLst>
               <a:ext uri="{FF2B5EF4-FFF2-40B4-BE49-F238E27FC236}">
-                <a16:creationId xmlns:a16="http://schemas.microsoft.com/office/drawing/2014/main" id="{C496F664-2D0B-E9FF-0148-7EB4FFCD3E23}"/>
+                <a16:creationId xmlns:a16="http://schemas.microsoft.com/office/drawing/2014/main" id="{96D90D63-E3A2-D2FB-4D38-329A410290B8}"/>
               </a:ext>
             </a:extLst>
           </p:cNvPr>
@@ -699,7 +700,7 @@
           <p:cNvPr id="6" name="Foliennummernplatzhalter 5">
             <a:extLst>
               <a:ext uri="{FF2B5EF4-FFF2-40B4-BE49-F238E27FC236}">
-                <a16:creationId xmlns:a16="http://schemas.microsoft.com/office/drawing/2014/main" id="{7B71E32C-4056-C975-9368-BD507506F8B9}"/>
+                <a16:creationId xmlns:a16="http://schemas.microsoft.com/office/drawing/2014/main" id="{154CDC3F-4262-41BF-2D6F-375C6B361498}"/>
               </a:ext>
             </a:extLst>
           </p:cNvPr>
@@ -715,7 +716,7 @@
           <a:bodyPr/>
           <a:lstStyle/>
           <a:p>
-            <a:fld id="{FD7A2B11-542E-4CA3-8CAD-ADBF93301D0C}" type="slidenum">
+            <a:fld id="{56A1CD77-F38E-452D-AE70-F639BBE63637}" type="slidenum">
               <a:rPr lang="de-DE" smtClean="0"/>
               <a:t>‹Nr.›</a:t>
             </a:fld>
@@ -726,7 +727,7 @@
     </p:spTree>
     <p:extLst>
       <p:ext uri="{BB962C8B-B14F-4D97-AF65-F5344CB8AC3E}">
-        <p14:creationId xmlns:p14="http://schemas.microsoft.com/office/powerpoint/2010/main" val="1763581593"/>
+        <p14:creationId xmlns:p14="http://schemas.microsoft.com/office/powerpoint/2010/main" val="1859356957"/>
       </p:ext>
     </p:extLst>
   </p:cSld>
@@ -758,7 +759,7 @@
           <p:cNvPr id="2" name="Titel 1">
             <a:extLst>
               <a:ext uri="{FF2B5EF4-FFF2-40B4-BE49-F238E27FC236}">
-                <a16:creationId xmlns:a16="http://schemas.microsoft.com/office/drawing/2014/main" id="{06755BAF-71E2-3262-D3F5-0467D0BE2F7A}"/>
+                <a16:creationId xmlns:a16="http://schemas.microsoft.com/office/drawing/2014/main" id="{6227ED53-CE58-9DA2-8318-6625664D0170}"/>
               </a:ext>
             </a:extLst>
           </p:cNvPr>
@@ -786,7 +787,7 @@
           <p:cNvPr id="3" name="Inhaltsplatzhalter 2">
             <a:extLst>
               <a:ext uri="{FF2B5EF4-FFF2-40B4-BE49-F238E27FC236}">
-                <a16:creationId xmlns:a16="http://schemas.microsoft.com/office/drawing/2014/main" id="{81E498FD-4E31-362D-976A-A05120E89C00}"/>
+                <a16:creationId xmlns:a16="http://schemas.microsoft.com/office/drawing/2014/main" id="{F17FD985-BE06-C63D-81BE-363E98471C25}"/>
               </a:ext>
             </a:extLst>
           </p:cNvPr>
@@ -843,7 +844,7 @@
           <p:cNvPr id="4" name="Datumsplatzhalter 3">
             <a:extLst>
               <a:ext uri="{FF2B5EF4-FFF2-40B4-BE49-F238E27FC236}">
-                <a16:creationId xmlns:a16="http://schemas.microsoft.com/office/drawing/2014/main" id="{540030CB-C414-0BE1-AB5E-6CD1644FB07C}"/>
+                <a16:creationId xmlns:a16="http://schemas.microsoft.com/office/drawing/2014/main" id="{44F644B3-4B20-4972-B2FC-5725C037E727}"/>
               </a:ext>
             </a:extLst>
           </p:cNvPr>
@@ -859,7 +860,7 @@
           <a:bodyPr/>
           <a:lstStyle/>
           <a:p>
-            <a:fld id="{5A1AF197-8666-45A1-A9DD-65DA68AEA0EB}" type="datetimeFigureOut">
+            <a:fld id="{B2B075A0-D846-4290-88CC-C140D1C58584}" type="datetimeFigureOut">
               <a:rPr lang="de-DE" smtClean="0"/>
               <a:t>08.10.2026</a:t>
             </a:fld>
@@ -872,7 +873,7 @@
           <p:cNvPr id="5" name="Fußzeilenplatzhalter 4">
             <a:extLst>
               <a:ext uri="{FF2B5EF4-FFF2-40B4-BE49-F238E27FC236}">
-                <a16:creationId xmlns:a16="http://schemas.microsoft.com/office/drawing/2014/main" id="{87ECD622-2577-1E52-E593-5B841F6738BA}"/>
+                <a16:creationId xmlns:a16="http://schemas.microsoft.com/office/drawing/2014/main" id="{57034BFE-1986-3389-74D0-C7BE33A383D9}"/>
               </a:ext>
             </a:extLst>
           </p:cNvPr>
@@ -897,7 +898,7 @@
           <p:cNvPr id="6" name="Foliennummernplatzhalter 5">
             <a:extLst>
               <a:ext uri="{FF2B5EF4-FFF2-40B4-BE49-F238E27FC236}">
-                <a16:creationId xmlns:a16="http://schemas.microsoft.com/office/drawing/2014/main" id="{C1359DD1-8217-6340-BF8E-233DA944D135}"/>
+                <a16:creationId xmlns:a16="http://schemas.microsoft.com/office/drawing/2014/main" id="{F50D6AD8-165A-3412-EEAB-B866DA57C87E}"/>
               </a:ext>
             </a:extLst>
           </p:cNvPr>
@@ -913,7 +914,7 @@
           <a:bodyPr/>
           <a:lstStyle/>
           <a:p>
-            <a:fld id="{FD7A2B11-542E-4CA3-8CAD-ADBF93301D0C}" type="slidenum">
+            <a:fld id="{56A1CD77-F38E-452D-AE70-F639BBE63637}" type="slidenum">
               <a:rPr lang="de-DE" smtClean="0"/>
               <a:t>‹Nr.›</a:t>
             </a:fld>
@@ -924,7 +925,7 @@
     </p:spTree>
     <p:extLst>
       <p:ext uri="{BB962C8B-B14F-4D97-AF65-F5344CB8AC3E}">
-        <p14:creationId xmlns:p14="http://schemas.microsoft.com/office/powerpoint/2010/main" val="3394778371"/>
+        <p14:creationId xmlns:p14="http://schemas.microsoft.com/office/powerpoint/2010/main" val="1222884156"/>
       </p:ext>
     </p:extLst>
   </p:cSld>
@@ -956,7 +957,7 @@
           <p:cNvPr id="2" name="Titel 1">
             <a:extLst>
               <a:ext uri="{FF2B5EF4-FFF2-40B4-BE49-F238E27FC236}">
-                <a16:creationId xmlns:a16="http://schemas.microsoft.com/office/drawing/2014/main" id="{ABDA4AC9-E63C-56F2-D876-74DEBFE22E9D}"/>
+                <a16:creationId xmlns:a16="http://schemas.microsoft.com/office/drawing/2014/main" id="{E21BF7F7-F7E8-80A3-16CC-D47D0EB1A1DA}"/>
               </a:ext>
             </a:extLst>
           </p:cNvPr>
@@ -993,7 +994,7 @@
           <p:cNvPr id="3" name="Textplatzhalter 2">
             <a:extLst>
               <a:ext uri="{FF2B5EF4-FFF2-40B4-BE49-F238E27FC236}">
-                <a16:creationId xmlns:a16="http://schemas.microsoft.com/office/drawing/2014/main" id="{858FDD71-7A18-4A08-BF66-A57A18828071}"/>
+                <a16:creationId xmlns:a16="http://schemas.microsoft.com/office/drawing/2014/main" id="{93739F2F-63FC-79CD-BB13-7454D84D8F9A}"/>
               </a:ext>
             </a:extLst>
           </p:cNvPr>
@@ -1118,7 +1119,7 @@
           <p:cNvPr id="4" name="Datumsplatzhalter 3">
             <a:extLst>
               <a:ext uri="{FF2B5EF4-FFF2-40B4-BE49-F238E27FC236}">
-                <a16:creationId xmlns:a16="http://schemas.microsoft.com/office/drawing/2014/main" id="{F864D8D5-2F68-5533-6D66-95CF2353EF8B}"/>
+                <a16:creationId xmlns:a16="http://schemas.microsoft.com/office/drawing/2014/main" id="{3E1ED8A6-4C6E-95DC-D9CB-A0582A9277C8}"/>
               </a:ext>
             </a:extLst>
           </p:cNvPr>
@@ -1134,7 +1135,7 @@
           <a:bodyPr/>
           <a:lstStyle/>
           <a:p>
-            <a:fld id="{5A1AF197-8666-45A1-A9DD-65DA68AEA0EB}" type="datetimeFigureOut">
+            <a:fld id="{B2B075A0-D846-4290-88CC-C140D1C58584}" type="datetimeFigureOut">
               <a:rPr lang="de-DE" smtClean="0"/>
               <a:t>08.10.2026</a:t>
             </a:fld>
@@ -1147,7 +1148,7 @@
           <p:cNvPr id="5" name="Fußzeilenplatzhalter 4">
             <a:extLst>
               <a:ext uri="{FF2B5EF4-FFF2-40B4-BE49-F238E27FC236}">
-                <a16:creationId xmlns:a16="http://schemas.microsoft.com/office/drawing/2014/main" id="{B9B2F4A6-462A-1DB1-630E-1F29B9AA383F}"/>
+                <a16:creationId xmlns:a16="http://schemas.microsoft.com/office/drawing/2014/main" id="{A93184EC-A68E-7ABC-CFDD-120CABCD5903}"/>
               </a:ext>
             </a:extLst>
           </p:cNvPr>
@@ -1172,7 +1173,7 @@
           <p:cNvPr id="6" name="Foliennummernplatzhalter 5">
             <a:extLst>
               <a:ext uri="{FF2B5EF4-FFF2-40B4-BE49-F238E27FC236}">
-                <a16:creationId xmlns:a16="http://schemas.microsoft.com/office/drawing/2014/main" id="{A9A10DA5-F096-DD7C-25B9-177F49297628}"/>
+                <a16:creationId xmlns:a16="http://schemas.microsoft.com/office/drawing/2014/main" id="{1EEFA52E-6DB3-BAAF-C58B-C6EF75F49AA8}"/>
               </a:ext>
             </a:extLst>
           </p:cNvPr>
@@ -1188,7 +1189,7 @@
           <a:bodyPr/>
           <a:lstStyle/>
           <a:p>
-            <a:fld id="{FD7A2B11-542E-4CA3-8CAD-ADBF93301D0C}" type="slidenum">
+            <a:fld id="{56A1CD77-F38E-452D-AE70-F639BBE63637}" type="slidenum">
               <a:rPr lang="de-DE" smtClean="0"/>
               <a:t>‹Nr.›</a:t>
             </a:fld>
@@ -1199,7 +1200,7 @@
     </p:spTree>
     <p:extLst>
       <p:ext uri="{BB962C8B-B14F-4D97-AF65-F5344CB8AC3E}">
-        <p14:creationId xmlns:p14="http://schemas.microsoft.com/office/powerpoint/2010/main" val="3996943530"/>
+        <p14:creationId xmlns:p14="http://schemas.microsoft.com/office/powerpoint/2010/main" val="2874697670"/>
       </p:ext>
     </p:extLst>
   </p:cSld>
@@ -1231,7 +1232,7 @@
           <p:cNvPr id="2" name="Titel 1">
             <a:extLst>
               <a:ext uri="{FF2B5EF4-FFF2-40B4-BE49-F238E27FC236}">
-                <a16:creationId xmlns:a16="http://schemas.microsoft.com/office/drawing/2014/main" id="{4AF5849A-E7D1-25E1-B2DF-DACE3ECE6940}"/>
+                <a16:creationId xmlns:a16="http://schemas.microsoft.com/office/drawing/2014/main" id="{F8E782E3-7FDF-21E5-4ED6-D57A3413F53E}"/>
               </a:ext>
             </a:extLst>
           </p:cNvPr>
@@ -1259,7 +1260,7 @@
           <p:cNvPr id="3" name="Inhaltsplatzhalter 2">
             <a:extLst>
               <a:ext uri="{FF2B5EF4-FFF2-40B4-BE49-F238E27FC236}">
-                <a16:creationId xmlns:a16="http://schemas.microsoft.com/office/drawing/2014/main" id="{6DA4F8A0-5E08-1132-0557-604020CFC715}"/>
+                <a16:creationId xmlns:a16="http://schemas.microsoft.com/office/drawing/2014/main" id="{27D6975F-585E-B7A7-9753-71F01250D49D}"/>
               </a:ext>
             </a:extLst>
           </p:cNvPr>
@@ -1321,7 +1322,7 @@
           <p:cNvPr id="4" name="Inhaltsplatzhalter 3">
             <a:extLst>
               <a:ext uri="{FF2B5EF4-FFF2-40B4-BE49-F238E27FC236}">
-                <a16:creationId xmlns:a16="http://schemas.microsoft.com/office/drawing/2014/main" id="{6AE4F29D-760F-BC00-E5FC-FD7BB3B668FB}"/>
+                <a16:creationId xmlns:a16="http://schemas.microsoft.com/office/drawing/2014/main" id="{EA1B1BEB-D498-A875-1F04-F511228DB4C7}"/>
               </a:ext>
             </a:extLst>
           </p:cNvPr>
@@ -1383,7 +1384,7 @@
           <p:cNvPr id="5" name="Datumsplatzhalter 4">
             <a:extLst>
               <a:ext uri="{FF2B5EF4-FFF2-40B4-BE49-F238E27FC236}">
-                <a16:creationId xmlns:a16="http://schemas.microsoft.com/office/drawing/2014/main" id="{8F2264E7-C836-71A1-3851-92A6276F5B10}"/>
+                <a16:creationId xmlns:a16="http://schemas.microsoft.com/office/drawing/2014/main" id="{2FB3E54F-1571-C17D-E868-650941F13E2A}"/>
               </a:ext>
             </a:extLst>
           </p:cNvPr>
@@ -1399,7 +1400,7 @@
           <a:bodyPr/>
           <a:lstStyle/>
           <a:p>
-            <a:fld id="{5A1AF197-8666-45A1-A9DD-65DA68AEA0EB}" type="datetimeFigureOut">
+            <a:fld id="{B2B075A0-D846-4290-88CC-C140D1C58584}" type="datetimeFigureOut">
               <a:rPr lang="de-DE" smtClean="0"/>
               <a:t>08.10.2026</a:t>
             </a:fld>
@@ -1412,7 +1413,7 @@
           <p:cNvPr id="6" name="Fußzeilenplatzhalter 5">
             <a:extLst>
               <a:ext uri="{FF2B5EF4-FFF2-40B4-BE49-F238E27FC236}">
-                <a16:creationId xmlns:a16="http://schemas.microsoft.com/office/drawing/2014/main" id="{1B9ABD61-A37B-69EA-4DD7-C1249CA31325}"/>
+                <a16:creationId xmlns:a16="http://schemas.microsoft.com/office/drawing/2014/main" id="{85456782-9E56-8BF1-99C2-1840D854AA45}"/>
               </a:ext>
             </a:extLst>
           </p:cNvPr>
@@ -1437,7 +1438,7 @@
           <p:cNvPr id="7" name="Foliennummernplatzhalter 6">
             <a:extLst>
               <a:ext uri="{FF2B5EF4-FFF2-40B4-BE49-F238E27FC236}">
-                <a16:creationId xmlns:a16="http://schemas.microsoft.com/office/drawing/2014/main" id="{8AD97F0F-AFD6-0420-8A75-4EB3C475324E}"/>
+                <a16:creationId xmlns:a16="http://schemas.microsoft.com/office/drawing/2014/main" id="{D13FCEFE-58BD-6537-9F57-9D89BCF0BEC2}"/>
               </a:ext>
             </a:extLst>
           </p:cNvPr>
@@ -1453,7 +1454,7 @@
           <a:bodyPr/>
           <a:lstStyle/>
           <a:p>
-            <a:fld id="{FD7A2B11-542E-4CA3-8CAD-ADBF93301D0C}" type="slidenum">
+            <a:fld id="{56A1CD77-F38E-452D-AE70-F639BBE63637}" type="slidenum">
               <a:rPr lang="de-DE" smtClean="0"/>
               <a:t>‹Nr.›</a:t>
             </a:fld>
@@ -1464,7 +1465,7 @@
     </p:spTree>
     <p:extLst>
       <p:ext uri="{BB962C8B-B14F-4D97-AF65-F5344CB8AC3E}">
-        <p14:creationId xmlns:p14="http://schemas.microsoft.com/office/powerpoint/2010/main" val="3733309982"/>
+        <p14:creationId xmlns:p14="http://schemas.microsoft.com/office/powerpoint/2010/main" val="4019589627"/>
       </p:ext>
     </p:extLst>
   </p:cSld>
@@ -1496,7 +1497,7 @@
           <p:cNvPr id="2" name="Titel 1">
             <a:extLst>
               <a:ext uri="{FF2B5EF4-FFF2-40B4-BE49-F238E27FC236}">
-                <a16:creationId xmlns:a16="http://schemas.microsoft.com/office/drawing/2014/main" id="{DF7FCAD1-A880-F6F0-6428-688651BBE5F3}"/>
+                <a16:creationId xmlns:a16="http://schemas.microsoft.com/office/drawing/2014/main" id="{C243BEAD-7000-1EA3-E69E-F7AE1331853A}"/>
               </a:ext>
             </a:extLst>
           </p:cNvPr>
@@ -1529,7 +1530,7 @@
           <p:cNvPr id="3" name="Textplatzhalter 2">
             <a:extLst>
               <a:ext uri="{FF2B5EF4-FFF2-40B4-BE49-F238E27FC236}">
-                <a16:creationId xmlns:a16="http://schemas.microsoft.com/office/drawing/2014/main" id="{81BF47F1-9E9E-3934-36D0-F2C83BBB1160}"/>
+                <a16:creationId xmlns:a16="http://schemas.microsoft.com/office/drawing/2014/main" id="{0E917852-B675-A77D-D588-C5A461180BCF}"/>
               </a:ext>
             </a:extLst>
           </p:cNvPr>
@@ -1600,7 +1601,7 @@
           <p:cNvPr id="4" name="Inhaltsplatzhalter 3">
             <a:extLst>
               <a:ext uri="{FF2B5EF4-FFF2-40B4-BE49-F238E27FC236}">
-                <a16:creationId xmlns:a16="http://schemas.microsoft.com/office/drawing/2014/main" id="{36CDC8D7-BDC2-487D-7DA5-BE538BA407B5}"/>
+                <a16:creationId xmlns:a16="http://schemas.microsoft.com/office/drawing/2014/main" id="{5E693C4C-C048-FDF2-80F2-FAE814F6C53B}"/>
               </a:ext>
             </a:extLst>
           </p:cNvPr>
@@ -1662,7 +1663,7 @@
           <p:cNvPr id="5" name="Textplatzhalter 4">
             <a:extLst>
               <a:ext uri="{FF2B5EF4-FFF2-40B4-BE49-F238E27FC236}">
-                <a16:creationId xmlns:a16="http://schemas.microsoft.com/office/drawing/2014/main" id="{3B1D7BB4-11CE-C01C-1F2F-6AE1C77698CC}"/>
+                <a16:creationId xmlns:a16="http://schemas.microsoft.com/office/drawing/2014/main" id="{3D874796-3060-6B89-44F2-35D7CAFFBE6C}"/>
               </a:ext>
             </a:extLst>
           </p:cNvPr>
@@ -1733,7 +1734,7 @@
           <p:cNvPr id="6" name="Inhaltsplatzhalter 5">
             <a:extLst>
               <a:ext uri="{FF2B5EF4-FFF2-40B4-BE49-F238E27FC236}">
-                <a16:creationId xmlns:a16="http://schemas.microsoft.com/office/drawing/2014/main" id="{92FBE1FB-5DAF-62D7-FDAC-316D99A220BB}"/>
+                <a16:creationId xmlns:a16="http://schemas.microsoft.com/office/drawing/2014/main" id="{7973CD52-99C5-D93D-9508-6ECA6D3FEA28}"/>
               </a:ext>
             </a:extLst>
           </p:cNvPr>
@@ -1795,7 +1796,7 @@
           <p:cNvPr id="7" name="Datumsplatzhalter 6">
             <a:extLst>
               <a:ext uri="{FF2B5EF4-FFF2-40B4-BE49-F238E27FC236}">
-                <a16:creationId xmlns:a16="http://schemas.microsoft.com/office/drawing/2014/main" id="{5288D339-5A3F-CC80-289C-9F23D109CB35}"/>
+                <a16:creationId xmlns:a16="http://schemas.microsoft.com/office/drawing/2014/main" id="{24C206D3-598E-83AF-B475-33C56BF75862}"/>
               </a:ext>
             </a:extLst>
           </p:cNvPr>
@@ -1811,7 +1812,7 @@
           <a:bodyPr/>
           <a:lstStyle/>
           <a:p>
-            <a:fld id="{5A1AF197-8666-45A1-A9DD-65DA68AEA0EB}" type="datetimeFigureOut">
+            <a:fld id="{B2B075A0-D846-4290-88CC-C140D1C58584}" type="datetimeFigureOut">
               <a:rPr lang="de-DE" smtClean="0"/>
               <a:t>08.10.2026</a:t>
             </a:fld>
@@ -1824,7 +1825,7 @@
           <p:cNvPr id="8" name="Fußzeilenplatzhalter 7">
             <a:extLst>
               <a:ext uri="{FF2B5EF4-FFF2-40B4-BE49-F238E27FC236}">
-                <a16:creationId xmlns:a16="http://schemas.microsoft.com/office/drawing/2014/main" id="{31E237DA-2745-EBCD-C3A2-861475A7D85D}"/>
+                <a16:creationId xmlns:a16="http://schemas.microsoft.com/office/drawing/2014/main" id="{15BA3B99-8E32-5A2F-7ED2-D7C8016B40BE}"/>
               </a:ext>
             </a:extLst>
           </p:cNvPr>
@@ -1849,7 +1850,7 @@
           <p:cNvPr id="9" name="Foliennummernplatzhalter 8">
             <a:extLst>
               <a:ext uri="{FF2B5EF4-FFF2-40B4-BE49-F238E27FC236}">
-                <a16:creationId xmlns:a16="http://schemas.microsoft.com/office/drawing/2014/main" id="{7694FA05-D20A-7FB0-A4F2-6EF76ADFAAF1}"/>
+                <a16:creationId xmlns:a16="http://schemas.microsoft.com/office/drawing/2014/main" id="{9F1DE143-8C4C-F84F-1CC2-272C9A290AAB}"/>
               </a:ext>
             </a:extLst>
           </p:cNvPr>
@@ -1865,7 +1866,7 @@
           <a:bodyPr/>
           <a:lstStyle/>
           <a:p>
-            <a:fld id="{FD7A2B11-542E-4CA3-8CAD-ADBF93301D0C}" type="slidenum">
+            <a:fld id="{56A1CD77-F38E-452D-AE70-F639BBE63637}" type="slidenum">
               <a:rPr lang="de-DE" smtClean="0"/>
               <a:t>‹Nr.›</a:t>
             </a:fld>
@@ -1876,7 +1877,7 @@
     </p:spTree>
     <p:extLst>
       <p:ext uri="{BB962C8B-B14F-4D97-AF65-F5344CB8AC3E}">
-        <p14:creationId xmlns:p14="http://schemas.microsoft.com/office/powerpoint/2010/main" val="3608037728"/>
+        <p14:creationId xmlns:p14="http://schemas.microsoft.com/office/powerpoint/2010/main" val="1754774303"/>
       </p:ext>
     </p:extLst>
   </p:cSld>
@@ -1908,7 +1909,7 @@
           <p:cNvPr id="2" name="Titel 1">
             <a:extLst>
               <a:ext uri="{FF2B5EF4-FFF2-40B4-BE49-F238E27FC236}">
-                <a16:creationId xmlns:a16="http://schemas.microsoft.com/office/drawing/2014/main" id="{E45E1E03-7F49-7D4A-A8E8-FA673F3EEF06}"/>
+                <a16:creationId xmlns:a16="http://schemas.microsoft.com/office/drawing/2014/main" id="{B7FC9B37-0E03-44CB-304E-C756725FAA1F}"/>
               </a:ext>
             </a:extLst>
           </p:cNvPr>
@@ -1936,7 +1937,7 @@
           <p:cNvPr id="3" name="Datumsplatzhalter 2">
             <a:extLst>
               <a:ext uri="{FF2B5EF4-FFF2-40B4-BE49-F238E27FC236}">
-                <a16:creationId xmlns:a16="http://schemas.microsoft.com/office/drawing/2014/main" id="{571A424E-AA81-AEAE-B6C9-73C427F08E40}"/>
+                <a16:creationId xmlns:a16="http://schemas.microsoft.com/office/drawing/2014/main" id="{4DA16509-2077-8999-2517-41B21EF3048A}"/>
               </a:ext>
             </a:extLst>
           </p:cNvPr>
@@ -1952,7 +1953,7 @@
           <a:bodyPr/>
           <a:lstStyle/>
           <a:p>
-            <a:fld id="{5A1AF197-8666-45A1-A9DD-65DA68AEA0EB}" type="datetimeFigureOut">
+            <a:fld id="{B2B075A0-D846-4290-88CC-C140D1C58584}" type="datetimeFigureOut">
               <a:rPr lang="de-DE" smtClean="0"/>
               <a:t>08.10.2026</a:t>
             </a:fld>
@@ -1965,7 +1966,7 @@
           <p:cNvPr id="4" name="Fußzeilenplatzhalter 3">
             <a:extLst>
               <a:ext uri="{FF2B5EF4-FFF2-40B4-BE49-F238E27FC236}">
-                <a16:creationId xmlns:a16="http://schemas.microsoft.com/office/drawing/2014/main" id="{F23F30FF-A2F4-9657-DFE4-ADCE0196E561}"/>
+                <a16:creationId xmlns:a16="http://schemas.microsoft.com/office/drawing/2014/main" id="{384A81F3-D7D6-3491-4918-F8F10F42EC0E}"/>
               </a:ext>
             </a:extLst>
           </p:cNvPr>
@@ -1990,7 +1991,7 @@
           <p:cNvPr id="5" name="Foliennummernplatzhalter 4">
             <a:extLst>
               <a:ext uri="{FF2B5EF4-FFF2-40B4-BE49-F238E27FC236}">
-                <a16:creationId xmlns:a16="http://schemas.microsoft.com/office/drawing/2014/main" id="{0127FB7C-B101-D599-1C23-B658F1A3A7E4}"/>
+                <a16:creationId xmlns:a16="http://schemas.microsoft.com/office/drawing/2014/main" id="{3742CAFA-886B-45BA-3A2C-9C62AFBF5E88}"/>
               </a:ext>
             </a:extLst>
           </p:cNvPr>
@@ -2006,7 +2007,7 @@
           <a:bodyPr/>
           <a:lstStyle/>
           <a:p>
-            <a:fld id="{FD7A2B11-542E-4CA3-8CAD-ADBF93301D0C}" type="slidenum">
+            <a:fld id="{56A1CD77-F38E-452D-AE70-F639BBE63637}" type="slidenum">
               <a:rPr lang="de-DE" smtClean="0"/>
               <a:t>‹Nr.›</a:t>
             </a:fld>
@@ -2017,7 +2018,7 @@
     </p:spTree>
     <p:extLst>
       <p:ext uri="{BB962C8B-B14F-4D97-AF65-F5344CB8AC3E}">
-        <p14:creationId xmlns:p14="http://schemas.microsoft.com/office/powerpoint/2010/main" val="2573641852"/>
+        <p14:creationId xmlns:p14="http://schemas.microsoft.com/office/powerpoint/2010/main" val="2441466213"/>
       </p:ext>
     </p:extLst>
   </p:cSld>
@@ -2049,7 +2050,7 @@
           <p:cNvPr id="2" name="Datumsplatzhalter 1">
             <a:extLst>
               <a:ext uri="{FF2B5EF4-FFF2-40B4-BE49-F238E27FC236}">
-                <a16:creationId xmlns:a16="http://schemas.microsoft.com/office/drawing/2014/main" id="{7282B58B-A0AE-A9DE-0E81-2333FF204C55}"/>
+                <a16:creationId xmlns:a16="http://schemas.microsoft.com/office/drawing/2014/main" id="{CE7DB488-3325-4822-363F-D4538FD5F08D}"/>
               </a:ext>
             </a:extLst>
           </p:cNvPr>
@@ -2065,7 +2066,7 @@
           <a:bodyPr/>
           <a:lstStyle/>
           <a:p>
-            <a:fld id="{5A1AF197-8666-45A1-A9DD-65DA68AEA0EB}" type="datetimeFigureOut">
+            <a:fld id="{B2B075A0-D846-4290-88CC-C140D1C58584}" type="datetimeFigureOut">
               <a:rPr lang="de-DE" smtClean="0"/>
               <a:t>08.10.2026</a:t>
             </a:fld>
@@ -2078,7 +2079,7 @@
           <p:cNvPr id="3" name="Fußzeilenplatzhalter 2">
             <a:extLst>
               <a:ext uri="{FF2B5EF4-FFF2-40B4-BE49-F238E27FC236}">
-                <a16:creationId xmlns:a16="http://schemas.microsoft.com/office/drawing/2014/main" id="{3CFF02AA-C73E-9097-EFF8-128E14C9300B}"/>
+                <a16:creationId xmlns:a16="http://schemas.microsoft.com/office/drawing/2014/main" id="{CEE04DB9-6E65-6ED2-75F3-8C401D52A2FE}"/>
               </a:ext>
             </a:extLst>
           </p:cNvPr>
@@ -2103,7 +2104,7 @@
           <p:cNvPr id="4" name="Foliennummernplatzhalter 3">
             <a:extLst>
               <a:ext uri="{FF2B5EF4-FFF2-40B4-BE49-F238E27FC236}">
-                <a16:creationId xmlns:a16="http://schemas.microsoft.com/office/drawing/2014/main" id="{3250BD19-16C8-D21E-2374-0B75DB47AAD8}"/>
+                <a16:creationId xmlns:a16="http://schemas.microsoft.com/office/drawing/2014/main" id="{B4B8C999-0EC5-EA37-2EBB-5915BFA4F759}"/>
               </a:ext>
             </a:extLst>
           </p:cNvPr>
@@ -2119,7 +2120,7 @@
           <a:bodyPr/>
           <a:lstStyle/>
           <a:p>
-            <a:fld id="{FD7A2B11-542E-4CA3-8CAD-ADBF93301D0C}" type="slidenum">
+            <a:fld id="{56A1CD77-F38E-452D-AE70-F639BBE63637}" type="slidenum">
               <a:rPr lang="de-DE" smtClean="0"/>
               <a:t>‹Nr.›</a:t>
             </a:fld>
@@ -2130,7 +2131,7 @@
     </p:spTree>
     <p:extLst>
       <p:ext uri="{BB962C8B-B14F-4D97-AF65-F5344CB8AC3E}">
-        <p14:creationId xmlns:p14="http://schemas.microsoft.com/office/powerpoint/2010/main" val="2840669831"/>
+        <p14:creationId xmlns:p14="http://schemas.microsoft.com/office/powerpoint/2010/main" val="3400210695"/>
       </p:ext>
     </p:extLst>
   </p:cSld>
@@ -2162,7 +2163,7 @@
           <p:cNvPr id="2" name="Titel 1">
             <a:extLst>
               <a:ext uri="{FF2B5EF4-FFF2-40B4-BE49-F238E27FC236}">
-                <a16:creationId xmlns:a16="http://schemas.microsoft.com/office/drawing/2014/main" id="{EA490759-DD95-7AD8-D8F4-71529678A784}"/>
+                <a16:creationId xmlns:a16="http://schemas.microsoft.com/office/drawing/2014/main" id="{DAFCF47D-50A6-EB69-4AEE-4AB1BBBBA972}"/>
               </a:ext>
             </a:extLst>
           </p:cNvPr>
@@ -2199,7 +2200,7 @@
           <p:cNvPr id="3" name="Inhaltsplatzhalter 2">
             <a:extLst>
               <a:ext uri="{FF2B5EF4-FFF2-40B4-BE49-F238E27FC236}">
-                <a16:creationId xmlns:a16="http://schemas.microsoft.com/office/drawing/2014/main" id="{A5B00C52-AE47-5A09-A9A4-4439FE1F109E}"/>
+                <a16:creationId xmlns:a16="http://schemas.microsoft.com/office/drawing/2014/main" id="{81215F9F-921F-7B2C-417E-02D8D2D4D89E}"/>
               </a:ext>
             </a:extLst>
           </p:cNvPr>
@@ -2289,7 +2290,7 @@
           <p:cNvPr id="4" name="Textplatzhalter 3">
             <a:extLst>
               <a:ext uri="{FF2B5EF4-FFF2-40B4-BE49-F238E27FC236}">
-                <a16:creationId xmlns:a16="http://schemas.microsoft.com/office/drawing/2014/main" id="{B8ADC2AA-2294-B49A-9D4A-0DE780C16DB5}"/>
+                <a16:creationId xmlns:a16="http://schemas.microsoft.com/office/drawing/2014/main" id="{E10343AD-C715-EAB8-838B-323B96132F23}"/>
               </a:ext>
             </a:extLst>
           </p:cNvPr>
@@ -2360,7 +2361,7 @@
           <p:cNvPr id="5" name="Datumsplatzhalter 4">
             <a:extLst>
               <a:ext uri="{FF2B5EF4-FFF2-40B4-BE49-F238E27FC236}">
-                <a16:creationId xmlns:a16="http://schemas.microsoft.com/office/drawing/2014/main" id="{F492C5EB-1021-EACA-EBF7-950CC7D0F7CB}"/>
+                <a16:creationId xmlns:a16="http://schemas.microsoft.com/office/drawing/2014/main" id="{DF22A225-F982-58A7-98E5-774201C34FE3}"/>
               </a:ext>
             </a:extLst>
           </p:cNvPr>
@@ -2376,7 +2377,7 @@
           <a:bodyPr/>
           <a:lstStyle/>
           <a:p>
-            <a:fld id="{5A1AF197-8666-45A1-A9DD-65DA68AEA0EB}" type="datetimeFigureOut">
+            <a:fld id="{B2B075A0-D846-4290-88CC-C140D1C58584}" type="datetimeFigureOut">
               <a:rPr lang="de-DE" smtClean="0"/>
               <a:t>08.10.2026</a:t>
             </a:fld>
@@ -2389,7 +2390,7 @@
           <p:cNvPr id="6" name="Fußzeilenplatzhalter 5">
             <a:extLst>
               <a:ext uri="{FF2B5EF4-FFF2-40B4-BE49-F238E27FC236}">
-                <a16:creationId xmlns:a16="http://schemas.microsoft.com/office/drawing/2014/main" id="{2C88EAEA-3AE6-98B5-FA33-8BCFDB17DE97}"/>
+                <a16:creationId xmlns:a16="http://schemas.microsoft.com/office/drawing/2014/main" id="{E4E0816D-C16A-E890-5E69-56D39C9200D2}"/>
               </a:ext>
             </a:extLst>
           </p:cNvPr>
@@ -2414,7 +2415,7 @@
           <p:cNvPr id="7" name="Foliennummernplatzhalter 6">
             <a:extLst>
               <a:ext uri="{FF2B5EF4-FFF2-40B4-BE49-F238E27FC236}">
-                <a16:creationId xmlns:a16="http://schemas.microsoft.com/office/drawing/2014/main" id="{AC08A9FA-3460-A241-89A5-14DEF284408E}"/>
+                <a16:creationId xmlns:a16="http://schemas.microsoft.com/office/drawing/2014/main" id="{64B71750-5E83-B3FA-1EFA-70909565DE56}"/>
               </a:ext>
             </a:extLst>
           </p:cNvPr>
@@ -2430,7 +2431,7 @@
           <a:bodyPr/>
           <a:lstStyle/>
           <a:p>
-            <a:fld id="{FD7A2B11-542E-4CA3-8CAD-ADBF93301D0C}" type="slidenum">
+            <a:fld id="{56A1CD77-F38E-452D-AE70-F639BBE63637}" type="slidenum">
               <a:rPr lang="de-DE" smtClean="0"/>
               <a:t>‹Nr.›</a:t>
             </a:fld>
@@ -2441,7 +2442,7 @@
     </p:spTree>
     <p:extLst>
       <p:ext uri="{BB962C8B-B14F-4D97-AF65-F5344CB8AC3E}">
-        <p14:creationId xmlns:p14="http://schemas.microsoft.com/office/powerpoint/2010/main" val="236535551"/>
+        <p14:creationId xmlns:p14="http://schemas.microsoft.com/office/powerpoint/2010/main" val="4268019021"/>
       </p:ext>
     </p:extLst>
   </p:cSld>
@@ -2473,7 +2474,7 @@
           <p:cNvPr id="2" name="Titel 1">
             <a:extLst>
               <a:ext uri="{FF2B5EF4-FFF2-40B4-BE49-F238E27FC236}">
-                <a16:creationId xmlns:a16="http://schemas.microsoft.com/office/drawing/2014/main" id="{E1ED5D83-5432-08B7-ED72-46E55380525A}"/>
+                <a16:creationId xmlns:a16="http://schemas.microsoft.com/office/drawing/2014/main" id="{A8008E7E-36D0-CF13-8F67-172B7A8E1A1D}"/>
               </a:ext>
             </a:extLst>
           </p:cNvPr>
@@ -2510,7 +2511,7 @@
           <p:cNvPr id="3" name="Bildplatzhalter 2">
             <a:extLst>
               <a:ext uri="{FF2B5EF4-FFF2-40B4-BE49-F238E27FC236}">
-                <a16:creationId xmlns:a16="http://schemas.microsoft.com/office/drawing/2014/main" id="{D7A031F4-40A6-9190-865C-CEBC1A817FA5}"/>
+                <a16:creationId xmlns:a16="http://schemas.microsoft.com/office/drawing/2014/main" id="{051B0832-B363-8D7A-EE35-7225CF02ECA2}"/>
               </a:ext>
             </a:extLst>
           </p:cNvPr>
@@ -2577,7 +2578,7 @@
           <p:cNvPr id="4" name="Textplatzhalter 3">
             <a:extLst>
               <a:ext uri="{FF2B5EF4-FFF2-40B4-BE49-F238E27FC236}">
-                <a16:creationId xmlns:a16="http://schemas.microsoft.com/office/drawing/2014/main" id="{23789805-7810-7EEE-59FE-04FA2F21F8B2}"/>
+                <a16:creationId xmlns:a16="http://schemas.microsoft.com/office/drawing/2014/main" id="{65F1191D-E0EB-A29D-79E7-0358DBFC0D2D}"/>
               </a:ext>
             </a:extLst>
           </p:cNvPr>
@@ -2648,7 +2649,7 @@
           <p:cNvPr id="5" name="Datumsplatzhalter 4">
             <a:extLst>
               <a:ext uri="{FF2B5EF4-FFF2-40B4-BE49-F238E27FC236}">
-                <a16:creationId xmlns:a16="http://schemas.microsoft.com/office/drawing/2014/main" id="{4E3CFBFD-8AE0-22A1-8740-A7D51952D861}"/>
+                <a16:creationId xmlns:a16="http://schemas.microsoft.com/office/drawing/2014/main" id="{ED084057-1DBF-2CE9-2466-C023D4F851C3}"/>
               </a:ext>
             </a:extLst>
           </p:cNvPr>
@@ -2664,7 +2665,7 @@
           <a:bodyPr/>
           <a:lstStyle/>
           <a:p>
-            <a:fld id="{5A1AF197-8666-45A1-A9DD-65DA68AEA0EB}" type="datetimeFigureOut">
+            <a:fld id="{B2B075A0-D846-4290-88CC-C140D1C58584}" type="datetimeFigureOut">
               <a:rPr lang="de-DE" smtClean="0"/>
               <a:t>08.10.2026</a:t>
             </a:fld>
@@ -2677,7 +2678,7 @@
           <p:cNvPr id="6" name="Fußzeilenplatzhalter 5">
             <a:extLst>
               <a:ext uri="{FF2B5EF4-FFF2-40B4-BE49-F238E27FC236}">
-                <a16:creationId xmlns:a16="http://schemas.microsoft.com/office/drawing/2014/main" id="{668B69EA-2174-3132-17B1-43E202968E75}"/>
+                <a16:creationId xmlns:a16="http://schemas.microsoft.com/office/drawing/2014/main" id="{96FF7421-A9A9-F80B-C26E-624FAA63C1A0}"/>
               </a:ext>
             </a:extLst>
           </p:cNvPr>
@@ -2702,7 +2703,7 @@
           <p:cNvPr id="7" name="Foliennummernplatzhalter 6">
             <a:extLst>
               <a:ext uri="{FF2B5EF4-FFF2-40B4-BE49-F238E27FC236}">
-                <a16:creationId xmlns:a16="http://schemas.microsoft.com/office/drawing/2014/main" id="{8CF36AC2-0275-3140-1966-E1B21A7528E0}"/>
+                <a16:creationId xmlns:a16="http://schemas.microsoft.com/office/drawing/2014/main" id="{9983975A-89C4-C3FD-3DF7-52EA039EA713}"/>
               </a:ext>
             </a:extLst>
           </p:cNvPr>
@@ -2718,7 +2719,7 @@
           <a:bodyPr/>
           <a:lstStyle/>
           <a:p>
-            <a:fld id="{FD7A2B11-542E-4CA3-8CAD-ADBF93301D0C}" type="slidenum">
+            <a:fld id="{56A1CD77-F38E-452D-AE70-F639BBE63637}" type="slidenum">
               <a:rPr lang="de-DE" smtClean="0"/>
               <a:t>‹Nr.›</a:t>
             </a:fld>
@@ -2729,7 +2730,7 @@
     </p:spTree>
     <p:extLst>
       <p:ext uri="{BB962C8B-B14F-4D97-AF65-F5344CB8AC3E}">
-        <p14:creationId xmlns:p14="http://schemas.microsoft.com/office/powerpoint/2010/main" val="4284705121"/>
+        <p14:creationId xmlns:p14="http://schemas.microsoft.com/office/powerpoint/2010/main" val="836559656"/>
       </p:ext>
     </p:extLst>
   </p:cSld>
@@ -2766,7 +2767,7 @@
           <p:cNvPr id="2" name="Titelplatzhalter 1">
             <a:extLst>
               <a:ext uri="{FF2B5EF4-FFF2-40B4-BE49-F238E27FC236}">
-                <a16:creationId xmlns:a16="http://schemas.microsoft.com/office/drawing/2014/main" id="{2A1B5342-469A-88F5-06D1-2F6BAE196031}"/>
+                <a16:creationId xmlns:a16="http://schemas.microsoft.com/office/drawing/2014/main" id="{AD2478CD-14C1-DFC3-6D48-751EE1C3EA2F}"/>
               </a:ext>
             </a:extLst>
           </p:cNvPr>
@@ -2804,7 +2805,7 @@
           <p:cNvPr id="3" name="Textplatzhalter 2">
             <a:extLst>
               <a:ext uri="{FF2B5EF4-FFF2-40B4-BE49-F238E27FC236}">
-                <a16:creationId xmlns:a16="http://schemas.microsoft.com/office/drawing/2014/main" id="{FF82D3DA-0033-4E60-AD70-530A1E840A4A}"/>
+                <a16:creationId xmlns:a16="http://schemas.microsoft.com/office/drawing/2014/main" id="{9703E0EF-D82C-8665-17EC-A290B478A18B}"/>
               </a:ext>
             </a:extLst>
           </p:cNvPr>
@@ -2871,7 +2872,7 @@
           <p:cNvPr id="4" name="Datumsplatzhalter 3">
             <a:extLst>
               <a:ext uri="{FF2B5EF4-FFF2-40B4-BE49-F238E27FC236}">
-                <a16:creationId xmlns:a16="http://schemas.microsoft.com/office/drawing/2014/main" id="{83311BBC-602C-292F-9D94-A1655F3472B8}"/>
+                <a16:creationId xmlns:a16="http://schemas.microsoft.com/office/drawing/2014/main" id="{CB90F1C1-F179-B169-125E-90FEB903EBFB}"/>
               </a:ext>
             </a:extLst>
           </p:cNvPr>
@@ -2905,7 +2906,7 @@
             </a:lvl1pPr>
           </a:lstStyle>
           <a:p>
-            <a:fld id="{5A1AF197-8666-45A1-A9DD-65DA68AEA0EB}" type="datetimeFigureOut">
+            <a:fld id="{B2B075A0-D846-4290-88CC-C140D1C58584}" type="datetimeFigureOut">
               <a:rPr lang="de-DE" smtClean="0"/>
               <a:t>08.10.2026</a:t>
             </a:fld>
@@ -2918,7 +2919,7 @@
           <p:cNvPr id="5" name="Fußzeilenplatzhalter 4">
             <a:extLst>
               <a:ext uri="{FF2B5EF4-FFF2-40B4-BE49-F238E27FC236}">
-                <a16:creationId xmlns:a16="http://schemas.microsoft.com/office/drawing/2014/main" id="{EEC4B4EA-CE28-553A-B843-ABDAE0269558}"/>
+                <a16:creationId xmlns:a16="http://schemas.microsoft.com/office/drawing/2014/main" id="{F2BE319A-E69E-16EA-E5AF-346B1BBA8450}"/>
               </a:ext>
             </a:extLst>
           </p:cNvPr>
@@ -2961,7 +2962,7 @@
           <p:cNvPr id="6" name="Foliennummernplatzhalter 5">
             <a:extLst>
               <a:ext uri="{FF2B5EF4-FFF2-40B4-BE49-F238E27FC236}">
-                <a16:creationId xmlns:a16="http://schemas.microsoft.com/office/drawing/2014/main" id="{BD0E9F3A-3C43-96F2-4149-F8D7885C390E}"/>
+                <a16:creationId xmlns:a16="http://schemas.microsoft.com/office/drawing/2014/main" id="{58B20F33-DD29-D207-524A-91E6C9180446}"/>
               </a:ext>
             </a:extLst>
           </p:cNvPr>
@@ -2995,7 +2996,7 @@
             </a:lvl1pPr>
           </a:lstStyle>
           <a:p>
-            <a:fld id="{FD7A2B11-542E-4CA3-8CAD-ADBF93301D0C}" type="slidenum">
+            <a:fld id="{56A1CD77-F38E-452D-AE70-F639BBE63637}" type="slidenum">
               <a:rPr lang="de-DE" smtClean="0"/>
               <a:t>‹Nr.›</a:t>
             </a:fld>
@@ -3006,7 +3007,7 @@
     </p:spTree>
     <p:extLst>
       <p:ext uri="{BB962C8B-B14F-4D97-AF65-F5344CB8AC3E}">
-        <p14:creationId xmlns:p14="http://schemas.microsoft.com/office/powerpoint/2010/main" val="1261187872"/>
+        <p14:creationId xmlns:p14="http://schemas.microsoft.com/office/powerpoint/2010/main" val="387281136"/>
       </p:ext>
     </p:extLst>
   </p:cSld>
@@ -3329,7 +3330,7 @@
           <p:cNvPr id="2" name="Rechteck 1">
             <a:extLst>
               <a:ext uri="{FF2B5EF4-FFF2-40B4-BE49-F238E27FC236}">
-                <a16:creationId xmlns:a16="http://schemas.microsoft.com/office/drawing/2014/main" id="{9F1DCDF6-ED1D-A1B1-39B9-92A272144DBC}"/>
+                <a16:creationId xmlns:a16="http://schemas.microsoft.com/office/drawing/2014/main" id="{59BB3FF2-24B4-DC0D-69AA-3D8A9FA87158}"/>
               </a:ext>
             </a:extLst>
           </p:cNvPr>
@@ -3406,7 +3407,7 @@
           <p:cNvPr id="3" name="Rechteck 2">
             <a:extLst>
               <a:ext uri="{FF2B5EF4-FFF2-40B4-BE49-F238E27FC236}">
-                <a16:creationId xmlns:a16="http://schemas.microsoft.com/office/drawing/2014/main" id="{43116EA8-4129-2AEC-AA30-0B643F63BED8}"/>
+                <a16:creationId xmlns:a16="http://schemas.microsoft.com/office/drawing/2014/main" id="{3D3F2A02-F436-182B-C609-DE0F98DBBE3D}"/>
               </a:ext>
             </a:extLst>
           </p:cNvPr>
@@ -3481,7 +3482,7 @@
           <p:cNvPr id="4" name="Rechteck: abgerundete Ecken 3">
             <a:extLst>
               <a:ext uri="{FF2B5EF4-FFF2-40B4-BE49-F238E27FC236}">
-                <a16:creationId xmlns:a16="http://schemas.microsoft.com/office/drawing/2014/main" id="{0A159F4C-7D71-3391-FFD2-E1431B85F4FE}"/>
+                <a16:creationId xmlns:a16="http://schemas.microsoft.com/office/drawing/2014/main" id="{BD62DA65-F28D-3EA9-DF2E-B9CDB9F40C3C}"/>
               </a:ext>
             </a:extLst>
           </p:cNvPr>
@@ -3558,7 +3559,7 @@
           <p:cNvPr id="5" name="Rechteck 4">
             <a:extLst>
               <a:ext uri="{FF2B5EF4-FFF2-40B4-BE49-F238E27FC236}">
-                <a16:creationId xmlns:a16="http://schemas.microsoft.com/office/drawing/2014/main" id="{BE15463F-8592-E90E-5CA4-6274A0BA1081}"/>
+                <a16:creationId xmlns:a16="http://schemas.microsoft.com/office/drawing/2014/main" id="{953E8D4C-5D55-F2E3-5AE6-D8F7E8BC644B}"/>
               </a:ext>
             </a:extLst>
           </p:cNvPr>
@@ -3635,7 +3636,7 @@
           <p:cNvPr id="6" name="Ellipse 5">
             <a:extLst>
               <a:ext uri="{FF2B5EF4-FFF2-40B4-BE49-F238E27FC236}">
-                <a16:creationId xmlns:a16="http://schemas.microsoft.com/office/drawing/2014/main" id="{0B45B2C6-A961-FB56-0CF0-EA7F07C17D44}"/>
+                <a16:creationId xmlns:a16="http://schemas.microsoft.com/office/drawing/2014/main" id="{046477FC-BBB1-67B8-CF96-3EF8F81D944B}"/>
               </a:ext>
             </a:extLst>
           </p:cNvPr>
@@ -3712,7 +3713,7 @@
           <p:cNvPr id="7" name="Rechteck 6">
             <a:extLst>
               <a:ext uri="{FF2B5EF4-FFF2-40B4-BE49-F238E27FC236}">
-                <a16:creationId xmlns:a16="http://schemas.microsoft.com/office/drawing/2014/main" id="{8BAE3E37-5FA9-369A-8B26-A413B6F3C6BA}"/>
+                <a16:creationId xmlns:a16="http://schemas.microsoft.com/office/drawing/2014/main" id="{D5265BC0-ADC1-F81B-A354-978DCA8FF4D8}"/>
               </a:ext>
             </a:extLst>
           </p:cNvPr>
@@ -3780,7 +3781,7 @@
           <p:cNvPr id="8" name="Ellipse 7">
             <a:extLst>
               <a:ext uri="{FF2B5EF4-FFF2-40B4-BE49-F238E27FC236}">
-                <a16:creationId xmlns:a16="http://schemas.microsoft.com/office/drawing/2014/main" id="{DD480319-B6CD-46AA-5C51-843AF60A1336}"/>
+                <a16:creationId xmlns:a16="http://schemas.microsoft.com/office/drawing/2014/main" id="{E0899BCB-9A63-FB11-08E0-9E47B175B8C1}"/>
               </a:ext>
             </a:extLst>
           </p:cNvPr>
@@ -3854,7 +3855,7 @@
     </p:spTree>
     <p:extLst>
       <p:ext uri="{BB962C8B-B14F-4D97-AF65-F5344CB8AC3E}">
-        <p14:creationId xmlns:p14="http://schemas.microsoft.com/office/powerpoint/2010/main" val="3732569157"/>
+        <p14:creationId xmlns:p14="http://schemas.microsoft.com/office/powerpoint/2010/main" val="3469920732"/>
       </p:ext>
     </p:extLst>
   </p:cSld>
@@ -3886,7 +3887,7 @@
           <p:cNvPr id="2" name="Rechteck 1">
             <a:extLst>
               <a:ext uri="{FF2B5EF4-FFF2-40B4-BE49-F238E27FC236}">
-                <a16:creationId xmlns:a16="http://schemas.microsoft.com/office/drawing/2014/main" id="{EB0CDFF3-9426-601B-6B93-8B20E9316F4C}"/>
+                <a16:creationId xmlns:a16="http://schemas.microsoft.com/office/drawing/2014/main" id="{06908775-989C-BC23-9E5A-70DE3B542B61}"/>
               </a:ext>
             </a:extLst>
           </p:cNvPr>
@@ -3964,7 +3965,7 @@
           <p:cNvPr id="3" name="Rechteck: abgerundete Ecken 2">
             <a:extLst>
               <a:ext uri="{FF2B5EF4-FFF2-40B4-BE49-F238E27FC236}">
-                <a16:creationId xmlns:a16="http://schemas.microsoft.com/office/drawing/2014/main" id="{91887F2B-F1A3-0409-742A-AAC507E60903}"/>
+                <a16:creationId xmlns:a16="http://schemas.microsoft.com/office/drawing/2014/main" id="{44CD0E3A-F119-8EFD-F1A1-6FA0CF088DE7}"/>
               </a:ext>
             </a:extLst>
           </p:cNvPr>
@@ -4042,7 +4043,7 @@
           <p:cNvPr id="4" name="Rechteck 3">
             <a:extLst>
               <a:ext uri="{FF2B5EF4-FFF2-40B4-BE49-F238E27FC236}">
-                <a16:creationId xmlns:a16="http://schemas.microsoft.com/office/drawing/2014/main" id="{39D9021C-216B-06E2-F7F8-246E778987FE}"/>
+                <a16:creationId xmlns:a16="http://schemas.microsoft.com/office/drawing/2014/main" id="{9D71A4B1-67BC-926C-9F72-00E14F0EA552}"/>
               </a:ext>
             </a:extLst>
           </p:cNvPr>
@@ -4119,7 +4120,7 @@
           <p:cNvPr id="5" name="Rechteck 4">
             <a:extLst>
               <a:ext uri="{FF2B5EF4-FFF2-40B4-BE49-F238E27FC236}">
-                <a16:creationId xmlns:a16="http://schemas.microsoft.com/office/drawing/2014/main" id="{619EA6EB-1412-081E-5CA7-33EFDAF275D9}"/>
+                <a16:creationId xmlns:a16="http://schemas.microsoft.com/office/drawing/2014/main" id="{598D8348-EAD4-BFD7-82F0-500D353DB910}"/>
               </a:ext>
             </a:extLst>
           </p:cNvPr>
@@ -4195,7 +4196,7 @@
           <p:cNvPr id="6" name="Ellipse 5">
             <a:extLst>
               <a:ext uri="{FF2B5EF4-FFF2-40B4-BE49-F238E27FC236}">
-                <a16:creationId xmlns:a16="http://schemas.microsoft.com/office/drawing/2014/main" id="{FDFFA47E-B452-EA0E-5EB0-92DE20429C18}"/>
+                <a16:creationId xmlns:a16="http://schemas.microsoft.com/office/drawing/2014/main" id="{D0E6CFCD-E0B3-7139-249D-6057782E190A}"/>
               </a:ext>
             </a:extLst>
           </p:cNvPr>
@@ -4271,7 +4272,7 @@
     </p:spTree>
     <p:extLst>
       <p:ext uri="{BB962C8B-B14F-4D97-AF65-F5344CB8AC3E}">
-        <p14:creationId xmlns:p14="http://schemas.microsoft.com/office/powerpoint/2010/main" val="1993990675"/>
+        <p14:creationId xmlns:p14="http://schemas.microsoft.com/office/powerpoint/2010/main" val="1766651423"/>
       </p:ext>
     </p:extLst>
   </p:cSld>
@@ -4303,7 +4304,7 @@
           <p:cNvPr id="2" name="perspective-0">
             <a:extLst>
               <a:ext uri="{FF2B5EF4-FFF2-40B4-BE49-F238E27FC236}">
-                <a16:creationId xmlns:a16="http://schemas.microsoft.com/office/drawing/2014/main" id="{BEF7C74C-C132-B0D8-D66A-D719F3DB739A}"/>
+                <a16:creationId xmlns:a16="http://schemas.microsoft.com/office/drawing/2014/main" id="{2ACF6BAE-20F8-C86D-15A0-0F848246059C}"/>
               </a:ext>
             </a:extLst>
           </p:cNvPr>
@@ -4377,7 +4378,7 @@
           <p:cNvPr id="3" name="perspective-1">
             <a:extLst>
               <a:ext uri="{FF2B5EF4-FFF2-40B4-BE49-F238E27FC236}">
-                <a16:creationId xmlns:a16="http://schemas.microsoft.com/office/drawing/2014/main" id="{BD4FA95A-1329-2224-7377-D8ED6346DB77}"/>
+                <a16:creationId xmlns:a16="http://schemas.microsoft.com/office/drawing/2014/main" id="{F790BD56-6C9B-1B9E-4637-5F4E94E73E48}"/>
               </a:ext>
             </a:extLst>
           </p:cNvPr>
@@ -4451,7 +4452,7 @@
           <p:cNvPr id="4" name="perspective-2">
             <a:extLst>
               <a:ext uri="{FF2B5EF4-FFF2-40B4-BE49-F238E27FC236}">
-                <a16:creationId xmlns:a16="http://schemas.microsoft.com/office/drawing/2014/main" id="{374FC81E-8387-5AA8-A2CB-2CE39D69A0E0}"/>
+                <a16:creationId xmlns:a16="http://schemas.microsoft.com/office/drawing/2014/main" id="{71698A75-BEEA-D088-630A-4ED5D12C63BA}"/>
               </a:ext>
             </a:extLst>
           </p:cNvPr>
@@ -4525,7 +4526,7 @@
           <p:cNvPr id="5" name="perspective-3">
             <a:extLst>
               <a:ext uri="{FF2B5EF4-FFF2-40B4-BE49-F238E27FC236}">
-                <a16:creationId xmlns:a16="http://schemas.microsoft.com/office/drawing/2014/main" id="{D0BE96B2-8D39-1D23-254E-D9CE4B278BD8}"/>
+                <a16:creationId xmlns:a16="http://schemas.microsoft.com/office/drawing/2014/main" id="{25FBA2D3-31BD-6145-5DD6-3CA7451883D6}"/>
               </a:ext>
             </a:extLst>
           </p:cNvPr>
@@ -4599,7 +4600,7 @@
           <p:cNvPr id="6" name="perspective-4">
             <a:extLst>
               <a:ext uri="{FF2B5EF4-FFF2-40B4-BE49-F238E27FC236}">
-                <a16:creationId xmlns:a16="http://schemas.microsoft.com/office/drawing/2014/main" id="{D180BCE6-6B27-72E1-FD32-E5E1D075A75A}"/>
+                <a16:creationId xmlns:a16="http://schemas.microsoft.com/office/drawing/2014/main" id="{34C2B1D3-2BA9-9DB3-EA9A-8FBB2F4C4BE6}"/>
               </a:ext>
             </a:extLst>
           </p:cNvPr>
@@ -4673,7 +4674,7 @@
           <p:cNvPr id="7" name="perspective-5">
             <a:extLst>
               <a:ext uri="{FF2B5EF4-FFF2-40B4-BE49-F238E27FC236}">
-                <a16:creationId xmlns:a16="http://schemas.microsoft.com/office/drawing/2014/main" id="{71BFD4D2-C820-3E33-9E0A-0A9E015106C7}"/>
+                <a16:creationId xmlns:a16="http://schemas.microsoft.com/office/drawing/2014/main" id="{6B02CB5C-A870-840D-A89B-999BCD3497BE}"/>
               </a:ext>
             </a:extLst>
           </p:cNvPr>
@@ -4747,7 +4748,7 @@
           <p:cNvPr id="8" name="perspective-6">
             <a:extLst>
               <a:ext uri="{FF2B5EF4-FFF2-40B4-BE49-F238E27FC236}">
-                <a16:creationId xmlns:a16="http://schemas.microsoft.com/office/drawing/2014/main" id="{0B24BDCB-B900-C396-3FEB-79E43AEF9515}"/>
+                <a16:creationId xmlns:a16="http://schemas.microsoft.com/office/drawing/2014/main" id="{014C0043-05D6-2571-7F26-5EA27EA84581}"/>
               </a:ext>
             </a:extLst>
           </p:cNvPr>
@@ -4821,7 +4822,7 @@
           <p:cNvPr id="9" name="perspective-7">
             <a:extLst>
               <a:ext uri="{FF2B5EF4-FFF2-40B4-BE49-F238E27FC236}">
-                <a16:creationId xmlns:a16="http://schemas.microsoft.com/office/drawing/2014/main" id="{99EAEC51-9AE6-28DA-C920-01287B4EDB52}"/>
+                <a16:creationId xmlns:a16="http://schemas.microsoft.com/office/drawing/2014/main" id="{BBA0A933-BB10-6749-3567-31B77B58BDE8}"/>
               </a:ext>
             </a:extLst>
           </p:cNvPr>
@@ -4893,7 +4894,7 @@
     </p:spTree>
     <p:extLst>
       <p:ext uri="{BB962C8B-B14F-4D97-AF65-F5344CB8AC3E}">
-        <p14:creationId xmlns:p14="http://schemas.microsoft.com/office/powerpoint/2010/main" val="3146653908"/>
+        <p14:creationId xmlns:p14="http://schemas.microsoft.com/office/powerpoint/2010/main" val="983393089"/>
       </p:ext>
     </p:extLst>
   </p:cSld>
@@ -4925,7 +4926,7 @@
           <p:cNvPr id="2" name="turned-0">
             <a:extLst>
               <a:ext uri="{FF2B5EF4-FFF2-40B4-BE49-F238E27FC236}">
-                <a16:creationId xmlns:a16="http://schemas.microsoft.com/office/drawing/2014/main" id="{0EA5DEC4-0EED-8E42-A95D-1DF0FA17945E}"/>
+                <a16:creationId xmlns:a16="http://schemas.microsoft.com/office/drawing/2014/main" id="{3872C9EC-AF04-830F-E4CB-8C51ACD005F0}"/>
               </a:ext>
             </a:extLst>
           </p:cNvPr>
@@ -4999,7 +5000,7 @@
           <p:cNvPr id="3" name="turned-1">
             <a:extLst>
               <a:ext uri="{FF2B5EF4-FFF2-40B4-BE49-F238E27FC236}">
-                <a16:creationId xmlns:a16="http://schemas.microsoft.com/office/drawing/2014/main" id="{439F2E9E-D1C8-601D-5B61-4A2BA56D7431}"/>
+                <a16:creationId xmlns:a16="http://schemas.microsoft.com/office/drawing/2014/main" id="{BA8DB7FE-02F0-AA21-2A16-514C63576B0A}"/>
               </a:ext>
             </a:extLst>
           </p:cNvPr>
@@ -5073,7 +5074,7 @@
           <p:cNvPr id="4" name="turned-2">
             <a:extLst>
               <a:ext uri="{FF2B5EF4-FFF2-40B4-BE49-F238E27FC236}">
-                <a16:creationId xmlns:a16="http://schemas.microsoft.com/office/drawing/2014/main" id="{45095E88-1B56-148C-906B-59760DCA2136}"/>
+                <a16:creationId xmlns:a16="http://schemas.microsoft.com/office/drawing/2014/main" id="{8AF329BD-B8CA-8C8F-FEAA-49BBEA76E9F9}"/>
               </a:ext>
             </a:extLst>
           </p:cNvPr>
@@ -5147,7 +5148,7 @@
           <p:cNvPr id="5" name="turned-3">
             <a:extLst>
               <a:ext uri="{FF2B5EF4-FFF2-40B4-BE49-F238E27FC236}">
-                <a16:creationId xmlns:a16="http://schemas.microsoft.com/office/drawing/2014/main" id="{DA543B73-9AB1-11D1-0328-22FF4EF3D093}"/>
+                <a16:creationId xmlns:a16="http://schemas.microsoft.com/office/drawing/2014/main" id="{5BCC7A14-885E-CC9E-4606-4669D7EFF766}"/>
               </a:ext>
             </a:extLst>
           </p:cNvPr>
@@ -5221,7 +5222,7 @@
           <p:cNvPr id="6" name="turned-4">
             <a:extLst>
               <a:ext uri="{FF2B5EF4-FFF2-40B4-BE49-F238E27FC236}">
-                <a16:creationId xmlns:a16="http://schemas.microsoft.com/office/drawing/2014/main" id="{F6B42B56-767F-0E62-237B-BDA94D4A6389}"/>
+                <a16:creationId xmlns:a16="http://schemas.microsoft.com/office/drawing/2014/main" id="{11D43F43-2E2A-7FEE-5E8E-B522EB18F273}"/>
               </a:ext>
             </a:extLst>
           </p:cNvPr>
@@ -5295,7 +5296,7 @@
           <p:cNvPr id="7" name="turned-5">
             <a:extLst>
               <a:ext uri="{FF2B5EF4-FFF2-40B4-BE49-F238E27FC236}">
-                <a16:creationId xmlns:a16="http://schemas.microsoft.com/office/drawing/2014/main" id="{4D693258-FAA2-46AF-2689-61A1D3919947}"/>
+                <a16:creationId xmlns:a16="http://schemas.microsoft.com/office/drawing/2014/main" id="{67DC131B-D845-7EF1-DA46-21391C05CB95}"/>
               </a:ext>
             </a:extLst>
           </p:cNvPr>
@@ -5369,7 +5370,7 @@
           <p:cNvPr id="8" name="turned-6">
             <a:extLst>
               <a:ext uri="{FF2B5EF4-FFF2-40B4-BE49-F238E27FC236}">
-                <a16:creationId xmlns:a16="http://schemas.microsoft.com/office/drawing/2014/main" id="{1CDB972F-65D1-C236-A394-20F361D3E2F8}"/>
+                <a16:creationId xmlns:a16="http://schemas.microsoft.com/office/drawing/2014/main" id="{C06826AF-E8F7-C8F9-13B3-F2FDD49AA638}"/>
               </a:ext>
             </a:extLst>
           </p:cNvPr>
@@ -5443,7 +5444,7 @@
           <p:cNvPr id="9" name="turned-7">
             <a:extLst>
               <a:ext uri="{FF2B5EF4-FFF2-40B4-BE49-F238E27FC236}">
-                <a16:creationId xmlns:a16="http://schemas.microsoft.com/office/drawing/2014/main" id="{C523081F-AC63-7F65-F484-9D842B79568C}"/>
+                <a16:creationId xmlns:a16="http://schemas.microsoft.com/office/drawing/2014/main" id="{DC53F8C4-8BEE-820A-698D-EC578EA27027}"/>
               </a:ext>
             </a:extLst>
           </p:cNvPr>
@@ -5515,7 +5516,597 @@
     </p:spTree>
     <p:extLst>
       <p:ext uri="{BB962C8B-B14F-4D97-AF65-F5344CB8AC3E}">
-        <p14:creationId xmlns:p14="http://schemas.microsoft.com/office/powerpoint/2010/main" val="2821036149"/>
+        <p14:creationId xmlns:p14="http://schemas.microsoft.com/office/powerpoint/2010/main" val="2823851770"/>
+      </p:ext>
+    </p:extLst>
+  </p:cSld>
+  <p:clrMapOvr>
+    <a:masterClrMapping/>
+  </p:clrMapOvr>
+</p:sld>
+</file>
+
+<file path=ppt/slides/slide5.xml><?xml version="1.0" encoding="utf-8"?>
+<p:sld xmlns:a="http://schemas.openxmlformats.org/drawingml/2006/main" xmlns:r="http://schemas.openxmlformats.org/officeDocument/2006/relationships" xmlns:p="http://schemas.openxmlformats.org/presentationml/2006/main">
+  <p:cSld>
+    <p:spTree>
+      <p:nvGrpSpPr>
+        <p:cNvPr id="1" name=""/>
+        <p:cNvGrpSpPr/>
+        <p:nvPr/>
+      </p:nvGrpSpPr>
+      <p:grpSpPr>
+        <a:xfrm>
+          <a:off x="0" y="0"/>
+          <a:ext cx="0" cy="0"/>
+          <a:chOff x="0" y="0"/>
+          <a:chExt cx="0" cy="0"/>
+        </a:xfrm>
+      </p:grpSpPr>
+      <p:sp>
+        <p:nvSpPr>
+          <p:cNvPr id="2" name="reflection-0">
+            <a:extLst>
+              <a:ext uri="{FF2B5EF4-FFF2-40B4-BE49-F238E27FC236}">
+                <a16:creationId xmlns:a16="http://schemas.microsoft.com/office/drawing/2014/main" id="{763521E6-DCFE-EF79-C5BC-762BDA588C77}"/>
+              </a:ext>
+            </a:extLst>
+          </p:cNvPr>
+          <p:cNvSpPr/>
+          <p:nvPr/>
+        </p:nvSpPr>
+        <p:spPr>
+          <a:xfrm>
+            <a:off x="762000" y="508000"/>
+            <a:ext cx="1651000" cy="1270000"/>
+          </a:xfrm>
+          <a:prstGeom prst="rect">
+            <a:avLst/>
+          </a:prstGeom>
+          <a:solidFill>
+            <a:srgbClr val="4472C4"/>
+          </a:solidFill>
+          <a:ln w="19050" cap="flat" cmpd="sng" algn="ctr">
+            <a:noFill/>
+            <a:prstDash val="solid"/>
+            <a:miter lim="800000"/>
+          </a:ln>
+          <a:effectLst>
+            <a:reflection xmlns:a="http://schemas.openxmlformats.org/drawingml/2006/main" stA="50000" endA="300" endPos="90000" dir="5400000" sy="-100000" algn="bl" rotWithShape="0"/>
+          </a:effectLst>
+          <a:extLst>
+            <a:ext uri="{91240B29-F687-4F45-9708-019B960494DF}">
+              <a14:hiddenLine xmlns:a14="http://schemas.microsoft.com/office/drawing/2010/main" w="19050" cap="flat" cmpd="sng" algn="ctr">
+                <a:solidFill>
+                  <a:schemeClr val="accent1">
+                    <a:shade val="15000"/>
+                  </a:schemeClr>
+                </a:solidFill>
+                <a:prstDash val="solid"/>
+                <a:miter lim="800000"/>
+              </a14:hiddenLine>
+            </a:ext>
+          </a:extLst>
+        </p:spPr>
+        <p:style>
+          <a:lnRef idx="2">
+            <a:schemeClr val="accent1">
+              <a:shade val="15000"/>
+            </a:schemeClr>
+          </a:lnRef>
+          <a:fillRef idx="1">
+            <a:schemeClr val="accent1"/>
+          </a:fillRef>
+          <a:effectRef idx="0">
+            <a:schemeClr val="accent1"/>
+          </a:effectRef>
+          <a:fontRef idx="minor">
+            <a:schemeClr val="lt1"/>
+          </a:fontRef>
+        </p:style>
+        <p:txBody>
+          <a:bodyPr rtlCol="0" anchor="ctr"/>
+          <a:lstStyle/>
+          <a:p>
+            <a:pPr algn="ctr"/>
+            <a:endParaRPr lang="de-DE"/>
+          </a:p>
+        </p:txBody>
+      </p:sp>
+      <p:sp>
+        <p:nvSpPr>
+          <p:cNvPr id="3" name="reflection-1">
+            <a:extLst>
+              <a:ext uri="{FF2B5EF4-FFF2-40B4-BE49-F238E27FC236}">
+                <a16:creationId xmlns:a16="http://schemas.microsoft.com/office/drawing/2014/main" id="{02CF4227-1006-560E-FD65-2490AC4269F5}"/>
+              </a:ext>
+            </a:extLst>
+          </p:cNvPr>
+          <p:cNvSpPr/>
+          <p:nvPr/>
+        </p:nvSpPr>
+        <p:spPr>
+          <a:xfrm>
+            <a:off x="3683000" y="508000"/>
+            <a:ext cx="1651000" cy="1270000"/>
+          </a:xfrm>
+          <a:prstGeom prst="rect">
+            <a:avLst/>
+          </a:prstGeom>
+          <a:solidFill>
+            <a:srgbClr val="4472C4"/>
+          </a:solidFill>
+          <a:ln w="19050" cap="flat" cmpd="sng" algn="ctr">
+            <a:noFill/>
+            <a:prstDash val="solid"/>
+            <a:miter lim="800000"/>
+          </a:ln>
+          <a:effectLst>
+            <a:reflection xmlns:a="http://schemas.openxmlformats.org/drawingml/2006/main" stA="50000" endA="300" endPos="90000" dir="5400000" sy="-100000" kx="1200000" algn="bl" rotWithShape="0"/>
+          </a:effectLst>
+          <a:extLst>
+            <a:ext uri="{91240B29-F687-4F45-9708-019B960494DF}">
+              <a14:hiddenLine xmlns:a14="http://schemas.microsoft.com/office/drawing/2010/main" w="19050" cap="flat" cmpd="sng" algn="ctr">
+                <a:solidFill>
+                  <a:schemeClr val="accent1">
+                    <a:shade val="15000"/>
+                  </a:schemeClr>
+                </a:solidFill>
+                <a:prstDash val="solid"/>
+                <a:miter lim="800000"/>
+              </a14:hiddenLine>
+            </a:ext>
+          </a:extLst>
+        </p:spPr>
+        <p:style>
+          <a:lnRef idx="2">
+            <a:schemeClr val="accent1">
+              <a:shade val="15000"/>
+            </a:schemeClr>
+          </a:lnRef>
+          <a:fillRef idx="1">
+            <a:schemeClr val="accent1"/>
+          </a:fillRef>
+          <a:effectRef idx="0">
+            <a:schemeClr val="accent1"/>
+          </a:effectRef>
+          <a:fontRef idx="minor">
+            <a:schemeClr val="lt1"/>
+          </a:fontRef>
+        </p:style>
+        <p:txBody>
+          <a:bodyPr rtlCol="0" anchor="ctr"/>
+          <a:lstStyle/>
+          <a:p>
+            <a:pPr algn="ctr"/>
+            <a:endParaRPr lang="de-DE"/>
+          </a:p>
+        </p:txBody>
+      </p:sp>
+      <p:sp>
+        <p:nvSpPr>
+          <p:cNvPr id="4" name="reflection-2">
+            <a:extLst>
+              <a:ext uri="{FF2B5EF4-FFF2-40B4-BE49-F238E27FC236}">
+                <a16:creationId xmlns:a16="http://schemas.microsoft.com/office/drawing/2014/main" id="{8940EBD1-2DB1-3188-E52C-AC1D32298A11}"/>
+              </a:ext>
+            </a:extLst>
+          </p:cNvPr>
+          <p:cNvSpPr/>
+          <p:nvPr/>
+        </p:nvSpPr>
+        <p:spPr>
+          <a:xfrm>
+            <a:off x="6604000" y="508000"/>
+            <a:ext cx="1651000" cy="1270000"/>
+          </a:xfrm>
+          <a:prstGeom prst="rect">
+            <a:avLst/>
+          </a:prstGeom>
+          <a:solidFill>
+            <a:srgbClr val="4472C4"/>
+          </a:solidFill>
+          <a:ln w="19050" cap="flat" cmpd="sng" algn="ctr">
+            <a:noFill/>
+            <a:prstDash val="solid"/>
+            <a:miter lim="800000"/>
+          </a:ln>
+          <a:effectLst>
+            <a:reflection xmlns:a="http://schemas.openxmlformats.org/drawingml/2006/main" stA="50000" endA="300" endPos="90000" fadeDir="0" dir="5400000" sy="-100000" algn="bl" rotWithShape="0"/>
+          </a:effectLst>
+          <a:extLst>
+            <a:ext uri="{91240B29-F687-4F45-9708-019B960494DF}">
+              <a14:hiddenLine xmlns:a14="http://schemas.microsoft.com/office/drawing/2010/main" w="19050" cap="flat" cmpd="sng" algn="ctr">
+                <a:solidFill>
+                  <a:schemeClr val="accent1">
+                    <a:shade val="15000"/>
+                  </a:schemeClr>
+                </a:solidFill>
+                <a:prstDash val="solid"/>
+                <a:miter lim="800000"/>
+              </a14:hiddenLine>
+            </a:ext>
+          </a:extLst>
+        </p:spPr>
+        <p:style>
+          <a:lnRef idx="2">
+            <a:schemeClr val="accent1">
+              <a:shade val="15000"/>
+            </a:schemeClr>
+          </a:lnRef>
+          <a:fillRef idx="1">
+            <a:schemeClr val="accent1"/>
+          </a:fillRef>
+          <a:effectRef idx="0">
+            <a:schemeClr val="accent1"/>
+          </a:effectRef>
+          <a:fontRef idx="minor">
+            <a:schemeClr val="lt1"/>
+          </a:fontRef>
+        </p:style>
+        <p:txBody>
+          <a:bodyPr rtlCol="0" anchor="ctr"/>
+          <a:lstStyle/>
+          <a:p>
+            <a:pPr algn="ctr"/>
+            <a:endParaRPr lang="de-DE"/>
+          </a:p>
+        </p:txBody>
+      </p:sp>
+      <p:sp>
+        <p:nvSpPr>
+          <p:cNvPr id="5" name="reflection-3">
+            <a:extLst>
+              <a:ext uri="{FF2B5EF4-FFF2-40B4-BE49-F238E27FC236}">
+                <a16:creationId xmlns:a16="http://schemas.microsoft.com/office/drawing/2014/main" id="{D7579C0F-C0B5-CA48-A5F6-E24A971CD957}"/>
+              </a:ext>
+            </a:extLst>
+          </p:cNvPr>
+          <p:cNvSpPr/>
+          <p:nvPr/>
+        </p:nvSpPr>
+        <p:spPr>
+          <a:xfrm>
+            <a:off x="9525000" y="508000"/>
+            <a:ext cx="1651000" cy="1270000"/>
+          </a:xfrm>
+          <a:prstGeom prst="rect">
+            <a:avLst/>
+          </a:prstGeom>
+          <a:solidFill>
+            <a:srgbClr val="4472C4"/>
+          </a:solidFill>
+          <a:ln w="19050" cap="flat" cmpd="sng" algn="ctr">
+            <a:noFill/>
+            <a:prstDash val="solid"/>
+            <a:miter lim="800000"/>
+          </a:ln>
+          <a:effectLst>
+            <a:reflection xmlns:a="http://schemas.openxmlformats.org/drawingml/2006/main" stA="50000" endA="300" endPos="90000" dist="76200" dir="5400000" sy="-60000" ky="600000" algn="bl" rotWithShape="0"/>
+          </a:effectLst>
+          <a:extLst>
+            <a:ext uri="{91240B29-F687-4F45-9708-019B960494DF}">
+              <a14:hiddenLine xmlns:a14="http://schemas.microsoft.com/office/drawing/2010/main" w="19050" cap="flat" cmpd="sng" algn="ctr">
+                <a:solidFill>
+                  <a:schemeClr val="accent1">
+                    <a:shade val="15000"/>
+                  </a:schemeClr>
+                </a:solidFill>
+                <a:prstDash val="solid"/>
+                <a:miter lim="800000"/>
+              </a14:hiddenLine>
+            </a:ext>
+          </a:extLst>
+        </p:spPr>
+        <p:style>
+          <a:lnRef idx="2">
+            <a:schemeClr val="accent1">
+              <a:shade val="15000"/>
+            </a:schemeClr>
+          </a:lnRef>
+          <a:fillRef idx="1">
+            <a:schemeClr val="accent1"/>
+          </a:fillRef>
+          <a:effectRef idx="0">
+            <a:schemeClr val="accent1"/>
+          </a:effectRef>
+          <a:fontRef idx="minor">
+            <a:schemeClr val="lt1"/>
+          </a:fontRef>
+        </p:style>
+        <p:txBody>
+          <a:bodyPr rtlCol="0" anchor="ctr"/>
+          <a:lstStyle/>
+          <a:p>
+            <a:pPr algn="ctr"/>
+            <a:endParaRPr lang="de-DE"/>
+          </a:p>
+        </p:txBody>
+      </p:sp>
+      <p:sp>
+        <p:nvSpPr>
+          <p:cNvPr id="6" name="reflection-4">
+            <a:extLst>
+              <a:ext uri="{FF2B5EF4-FFF2-40B4-BE49-F238E27FC236}">
+                <a16:creationId xmlns:a16="http://schemas.microsoft.com/office/drawing/2014/main" id="{C9670B48-0621-2E9A-5705-92F25272692F}"/>
+              </a:ext>
+            </a:extLst>
+          </p:cNvPr>
+          <p:cNvSpPr/>
+          <p:nvPr/>
+        </p:nvSpPr>
+        <p:spPr>
+          <a:xfrm rot="1800000">
+            <a:off x="762000" y="3810000"/>
+            <a:ext cx="1651000" cy="1270000"/>
+          </a:xfrm>
+          <a:prstGeom prst="rect">
+            <a:avLst/>
+          </a:prstGeom>
+          <a:solidFill>
+            <a:srgbClr val="4472C4"/>
+          </a:solidFill>
+          <a:ln w="19050" cap="flat" cmpd="sng" algn="ctr">
+            <a:noFill/>
+            <a:prstDash val="solid"/>
+            <a:miter lim="800000"/>
+          </a:ln>
+          <a:effectLst>
+            <a:reflection xmlns:a="http://schemas.openxmlformats.org/drawingml/2006/main" stA="50000" endA="300" endPos="90000" dir="5400000" sy="-100000" algn="bl" rotWithShape="0"/>
+          </a:effectLst>
+          <a:extLst>
+            <a:ext uri="{91240B29-F687-4F45-9708-019B960494DF}">
+              <a14:hiddenLine xmlns:a14="http://schemas.microsoft.com/office/drawing/2010/main" w="19050" cap="flat" cmpd="sng" algn="ctr">
+                <a:solidFill>
+                  <a:schemeClr val="accent1">
+                    <a:shade val="15000"/>
+                  </a:schemeClr>
+                </a:solidFill>
+                <a:prstDash val="solid"/>
+                <a:miter lim="800000"/>
+              </a14:hiddenLine>
+            </a:ext>
+          </a:extLst>
+        </p:spPr>
+        <p:style>
+          <a:lnRef idx="2">
+            <a:schemeClr val="accent1">
+              <a:shade val="15000"/>
+            </a:schemeClr>
+          </a:lnRef>
+          <a:fillRef idx="1">
+            <a:schemeClr val="accent1"/>
+          </a:fillRef>
+          <a:effectRef idx="0">
+            <a:schemeClr val="accent1"/>
+          </a:effectRef>
+          <a:fontRef idx="minor">
+            <a:schemeClr val="lt1"/>
+          </a:fontRef>
+        </p:style>
+        <p:txBody>
+          <a:bodyPr rtlCol="0" anchor="ctr"/>
+          <a:lstStyle/>
+          <a:p>
+            <a:pPr algn="ctr"/>
+            <a:endParaRPr lang="de-DE"/>
+          </a:p>
+        </p:txBody>
+      </p:sp>
+      <p:sp>
+        <p:nvSpPr>
+          <p:cNvPr id="7" name="reflection-5">
+            <a:extLst>
+              <a:ext uri="{FF2B5EF4-FFF2-40B4-BE49-F238E27FC236}">
+                <a16:creationId xmlns:a16="http://schemas.microsoft.com/office/drawing/2014/main" id="{23C1C228-FB5E-337C-A0DD-90812D1D7CC1}"/>
+              </a:ext>
+            </a:extLst>
+          </p:cNvPr>
+          <p:cNvSpPr/>
+          <p:nvPr/>
+        </p:nvSpPr>
+        <p:spPr>
+          <a:xfrm rot="1800000">
+            <a:off x="3683000" y="3810000"/>
+            <a:ext cx="1651000" cy="1270000"/>
+          </a:xfrm>
+          <a:prstGeom prst="rect">
+            <a:avLst/>
+          </a:prstGeom>
+          <a:solidFill>
+            <a:srgbClr val="4472C4"/>
+          </a:solidFill>
+          <a:ln w="19050" cap="flat" cmpd="sng" algn="ctr">
+            <a:noFill/>
+            <a:prstDash val="solid"/>
+            <a:miter lim="800000"/>
+          </a:ln>
+          <a:effectLst>
+            <a:reflection xmlns:a="http://schemas.openxmlformats.org/drawingml/2006/main" stA="50000" endA="300" endPos="90000" dir="5400000" sy="-100000" algn="bl" rotWithShape="1"/>
+          </a:effectLst>
+          <a:extLst>
+            <a:ext uri="{91240B29-F687-4F45-9708-019B960494DF}">
+              <a14:hiddenLine xmlns:a14="http://schemas.microsoft.com/office/drawing/2010/main" w="19050" cap="flat" cmpd="sng" algn="ctr">
+                <a:solidFill>
+                  <a:schemeClr val="accent1">
+                    <a:shade val="15000"/>
+                  </a:schemeClr>
+                </a:solidFill>
+                <a:prstDash val="solid"/>
+                <a:miter lim="800000"/>
+              </a14:hiddenLine>
+            </a:ext>
+          </a:extLst>
+        </p:spPr>
+        <p:style>
+          <a:lnRef idx="2">
+            <a:schemeClr val="accent1">
+              <a:shade val="15000"/>
+            </a:schemeClr>
+          </a:lnRef>
+          <a:fillRef idx="1">
+            <a:schemeClr val="accent1"/>
+          </a:fillRef>
+          <a:effectRef idx="0">
+            <a:schemeClr val="accent1"/>
+          </a:effectRef>
+          <a:fontRef idx="minor">
+            <a:schemeClr val="lt1"/>
+          </a:fontRef>
+        </p:style>
+        <p:txBody>
+          <a:bodyPr rtlCol="0" anchor="ctr"/>
+          <a:lstStyle/>
+          <a:p>
+            <a:pPr algn="ctr"/>
+            <a:endParaRPr lang="de-DE"/>
+          </a:p>
+        </p:txBody>
+      </p:sp>
+      <p:sp>
+        <p:nvSpPr>
+          <p:cNvPr id="8" name="reflection-6">
+            <a:extLst>
+              <a:ext uri="{FF2B5EF4-FFF2-40B4-BE49-F238E27FC236}">
+                <a16:creationId xmlns:a16="http://schemas.microsoft.com/office/drawing/2014/main" id="{F03DA3E9-19EA-7407-28F1-FB22DB6AC076}"/>
+              </a:ext>
+            </a:extLst>
+          </p:cNvPr>
+          <p:cNvSpPr/>
+          <p:nvPr/>
+        </p:nvSpPr>
+        <p:spPr>
+          <a:xfrm>
+            <a:off x="6604000" y="3810000"/>
+            <a:ext cx="1651000" cy="1270000"/>
+          </a:xfrm>
+          <a:prstGeom prst="rect">
+            <a:avLst/>
+          </a:prstGeom>
+          <a:solidFill>
+            <a:srgbClr val="4472C4"/>
+          </a:solidFill>
+          <a:ln w="19050" cap="flat" cmpd="sng" algn="ctr">
+            <a:noFill/>
+            <a:prstDash val="solid"/>
+            <a:miter lim="800000"/>
+          </a:ln>
+          <a:effectLst>
+            <a:reflection xmlns:a="http://schemas.openxmlformats.org/drawingml/2006/main" stA="50000" endA="300" endPos="90000" fadeDir="2700000" dir="5400000" sy="-100000" algn="bl" rotWithShape="0"/>
+          </a:effectLst>
+          <a:extLst>
+            <a:ext uri="{91240B29-F687-4F45-9708-019B960494DF}">
+              <a14:hiddenLine xmlns:a14="http://schemas.microsoft.com/office/drawing/2010/main" w="19050" cap="flat" cmpd="sng" algn="ctr">
+                <a:solidFill>
+                  <a:schemeClr val="accent1">
+                    <a:shade val="15000"/>
+                  </a:schemeClr>
+                </a:solidFill>
+                <a:prstDash val="solid"/>
+                <a:miter lim="800000"/>
+              </a14:hiddenLine>
+            </a:ext>
+          </a:extLst>
+        </p:spPr>
+        <p:style>
+          <a:lnRef idx="2">
+            <a:schemeClr val="accent1">
+              <a:shade val="15000"/>
+            </a:schemeClr>
+          </a:lnRef>
+          <a:fillRef idx="1">
+            <a:schemeClr val="accent1"/>
+          </a:fillRef>
+          <a:effectRef idx="0">
+            <a:schemeClr val="accent1"/>
+          </a:effectRef>
+          <a:fontRef idx="minor">
+            <a:schemeClr val="lt1"/>
+          </a:fontRef>
+        </p:style>
+        <p:txBody>
+          <a:bodyPr rtlCol="0" anchor="ctr"/>
+          <a:lstStyle/>
+          <a:p>
+            <a:pPr algn="ctr"/>
+            <a:endParaRPr lang="de-DE"/>
+          </a:p>
+        </p:txBody>
+      </p:sp>
+      <p:sp>
+        <p:nvSpPr>
+          <p:cNvPr id="9" name="reflection-7">
+            <a:extLst>
+              <a:ext uri="{FF2B5EF4-FFF2-40B4-BE49-F238E27FC236}">
+                <a16:creationId xmlns:a16="http://schemas.microsoft.com/office/drawing/2014/main" id="{118CB979-2747-7EE3-3DF0-C48DA21C9C93}"/>
+              </a:ext>
+            </a:extLst>
+          </p:cNvPr>
+          <p:cNvSpPr/>
+          <p:nvPr/>
+        </p:nvSpPr>
+        <p:spPr>
+          <a:xfrm>
+            <a:off x="9525000" y="3810000"/>
+            <a:ext cx="1651000" cy="1270000"/>
+          </a:xfrm>
+          <a:prstGeom prst="rect">
+            <a:avLst/>
+          </a:prstGeom>
+          <a:solidFill>
+            <a:srgbClr val="4472C4"/>
+          </a:solidFill>
+          <a:ln w="19050" cap="flat" cmpd="sng" algn="ctr">
+            <a:noFill/>
+            <a:prstDash val="solid"/>
+            <a:miter lim="800000"/>
+          </a:ln>
+          <a:effectLst>
+            <a:reflection xmlns:a="http://schemas.openxmlformats.org/drawingml/2006/main" stA="80000" endA="0" stPos="20000" endPos="60000" dir="0" sx="-100000" algn="r" rotWithShape="0"/>
+          </a:effectLst>
+          <a:extLst>
+            <a:ext uri="{91240B29-F687-4F45-9708-019B960494DF}">
+              <a14:hiddenLine xmlns:a14="http://schemas.microsoft.com/office/drawing/2010/main" w="19050" cap="flat" cmpd="sng" algn="ctr">
+                <a:solidFill>
+                  <a:schemeClr val="accent1">
+                    <a:shade val="15000"/>
+                  </a:schemeClr>
+                </a:solidFill>
+                <a:prstDash val="solid"/>
+                <a:miter lim="800000"/>
+              </a14:hiddenLine>
+            </a:ext>
+          </a:extLst>
+        </p:spPr>
+        <p:style>
+          <a:lnRef idx="2">
+            <a:schemeClr val="accent1">
+              <a:shade val="15000"/>
+            </a:schemeClr>
+          </a:lnRef>
+          <a:fillRef idx="1">
+            <a:schemeClr val="accent1"/>
+          </a:fillRef>
+          <a:effectRef idx="0">
+            <a:schemeClr val="accent1"/>
+          </a:effectRef>
+          <a:fontRef idx="minor">
+            <a:schemeClr val="lt1"/>
+          </a:fontRef>
+        </p:style>
+        <p:txBody>
+          <a:bodyPr rtlCol="0" anchor="ctr"/>
+          <a:lstStyle/>
+          <a:p>
+            <a:pPr algn="ctr"/>
+            <a:endParaRPr lang="de-DE"/>
+          </a:p>
+        </p:txBody>
+      </p:sp>
+    </p:spTree>
+    <p:extLst>
+      <p:ext uri="{BB962C8B-B14F-4D97-AF65-F5344CB8AC3E}">
+        <p14:creationId xmlns:p14="http://schemas.microsoft.com/office/powerpoint/2010/main" val="2217486653"/>
       </p:ext>
     </p:extLst>
   </p:cSld>

</xml_diff>